<commit_message>
docs (#26): Add personas slide and platform admin
</commit_message>
<xml_diff>
--- a/Docs/Presentation/Farol_First_Presentation.pptx
+++ b/Docs/Presentation/Farol_First_Presentation.pptx
@@ -6,6 +6,7 @@
   </p:sldMasterIdLst>
   <p:sldIdLst>
     <p:sldId id="256" r:id="rId2"/>
+    <p:sldId id="259" r:id="rId10"/>
     <p:sldId id="257" r:id="rId3"/>
     <p:sldId id="258" r:id="rId4"/>
   </p:sldIdLst>
@@ -109,9 +110,18 @@
   <p:extLst>
     <p:ext uri="{521415D9-36F7-43E2-AB2F-B90AF26B5E84}">
       <p14:sectionLst xmlns:p14="http://schemas.microsoft.com/office/powerpoint/2010/main">
+        <p14:section name="Cover (Bruno Lopes)" id="{3c1f5a2e-6d4b-4e8a-9b71-2f0c8d9e4a10}">
+          <p14:sldIdLst>
+            <p14:sldId id="256"/>
+          </p14:sldIdLst>
+        </p14:section>
+        <p14:section name="Personas (Tiago Teixeira)" id="{7a9e2b44-1c3d-4f6a-8e25-5b0d7c1f9e32}">
+          <p14:sldIdLst>
+            <p14:sldId id="259"/>
+          </p14:sldIdLst>
+        </p14:section>
         <p14:section name="Main features (Bruno Lopes)" id="{b2ef1337-627e-81ae-c510-0d08fb5c3d36}">
           <p14:sldIdLst>
-            <p14:sldId id="256"/>
             <p14:sldId id="257"/>
             <p14:sldId id="258"/>
           </p14:sldIdLst>
@@ -720,6 +730,94 @@
             <a:fld id="{F7021451-1387-4CA6-816F-3879F97B5CBC}" type="slidenum">
               <a:rPr lang="en-US"/>
               <a:t>3</a:t>
+            </a:fld>
+            <a:endParaRPr lang="en-US"/>
+          </a:p>
+        </p:txBody>
+      </p:sp>
+    </p:spTree>
+    <p:extLst>
+      <p:ext uri="{BB962C8B-B14F-4D97-AF65-F5344CB8AC3E}">
+        <p14:creationId xmlns:p14="http://schemas.microsoft.com/office/powerpoint/2010/main" val="1024086991"/>
+      </p:ext>
+    </p:extLst>
+  </p:cSld>
+  <p:clrMapOvr>
+    <a:masterClrMapping/>
+  </p:clrMapOvr>
+</p:notes>
+</file>
+
+<file path=ppt/notesSlides/notesSlide4.xml><?xml version="1.0" encoding="utf-8"?>
+<p:notes xmlns:a="http://schemas.openxmlformats.org/drawingml/2006/main" xmlns:r="http://schemas.openxmlformats.org/officeDocument/2006/relationships" xmlns:p="http://schemas.openxmlformats.org/presentationml/2006/main">
+  <p:cSld>
+    <p:spTree>
+      <p:nvGrpSpPr>
+        <p:cNvPr id="1" name=""/>
+        <p:cNvGrpSpPr/>
+        <p:nvPr/>
+      </p:nvGrpSpPr>
+      <p:grpSpPr>
+        <a:xfrm>
+          <a:off x="0" y="0"/>
+          <a:ext cx="0" cy="0"/>
+          <a:chOff x="0" y="0"/>
+          <a:chExt cx="0" cy="0"/>
+        </a:xfrm>
+      </p:grpSpPr>
+      <p:sp>
+        <p:nvSpPr>
+          <p:cNvPr id="2" name="Slide Image Placeholder 1"/>
+          <p:cNvSpPr>
+            <a:spLocks noGrp="1" noRot="1" noChangeAspect="1"/>
+          </p:cNvSpPr>
+          <p:nvPr>
+            <p:ph type="sldImg"/>
+          </p:nvPr>
+        </p:nvSpPr>
+        <p:spPr/>
+      </p:sp>
+      <p:sp>
+        <p:nvSpPr>
+          <p:cNvPr id="3" name="Notes Placeholder 2"/>
+          <p:cNvSpPr>
+            <a:spLocks noGrp="1"/>
+          </p:cNvSpPr>
+          <p:nvPr>
+            <p:ph type="body" idx="1"/>
+          </p:nvPr>
+        </p:nvSpPr>
+        <p:spPr/>
+        <p:txBody>
+          <a:bodyPr/>
+          <a:lstStyle/>
+          <a:p>
+            <a:r>
+              <a:rPr lang="en-US" dirty="0"/>
+              <a:t>(~70 s) Desenhámos o Farol para quatro pessoas. O relatório tem dois grupos de utilizadores, os participantes e a equipa do evento, mas dentro da equipa há dois trabalhos diferentes: quem configura o evento e quem trata os pedidos de ajuda durante a noite. A Rita é estudante: está no recinto à noite, com pouca bateria e muito barulho, e quer encontrar a casa de banho, os primeiros socorros e o caminho para casa. Hoje a informação fica desatualizada e a planta é uma imagem nas redes sociais. Para ela, sucesso é pedir ajuda para uma amiga em menos de 30 segundos. O Miguel é voluntário da PCR: recebe muitos pedidos ao mesmo tempo, por rádio e telefone, sem localização nem prioridade. Precisa de ver cada pedido em segundos, já com a triagem da IA. A Sofia é da organização: configura o evento e publica alterações durante as noites, mas só gere o seu evento. Como o Farol tem vários festivais, a Queima do Porto, de Braga, de Coimbra, alguém tem de os criar: é o Daniel, da equipa Farol. Confirma que quem pede o evento é mesmo a organização, cria-o e nomeia o responsável, e transfere esse papel quando a direção muda. Nunca vê os pedidos de ajuda nem os dados dos eventos. Importante: são proto-personas, construídas a partir do relatório e de dados públicos, com nomes fictícios. Vamos validá-las com o inquérito aos estudantes, a entrevista ao voluntário de segurança e uma conversa com a organização.</a:t>
+            </a:r>
+            <a:endParaRPr lang="en-US" dirty="0"/>
+          </a:p>
+        </p:txBody>
+      </p:sp>
+      <p:sp>
+        <p:nvSpPr>
+          <p:cNvPr id="4" name="Slide Number Placeholder 3"/>
+          <p:cNvSpPr>
+            <a:spLocks noGrp="1"/>
+          </p:cNvSpPr>
+          <p:nvPr>
+            <p:ph type="sldNum" sz="quarter" idx="10"/>
+          </p:nvPr>
+        </p:nvSpPr>
+        <p:spPr/>
+        <p:txBody>
+          <a:bodyPr/>
+          <a:lstStyle/>
+          <a:p>
+            <a:fld id="{F7021451-1387-4CA6-816F-3879F97B5CBC}" type="slidenum">
+              <a:rPr lang="en-US"/>
+              <a:t>1</a:t>
             </a:fld>
             <a:endParaRPr lang="en-US"/>
           </a:p>
@@ -3755,6 +3853,2239 @@
 </p:sld>
 </file>
 
+<file path=ppt/slides/slide4.xml><?xml version="1.0" encoding="utf-8"?>
+<p:sld xmlns:a="http://schemas.openxmlformats.org/drawingml/2006/main" xmlns:r="http://schemas.openxmlformats.org/officeDocument/2006/relationships" xmlns:p="http://schemas.openxmlformats.org/presentationml/2006/main">
+  <p:cSld name="Slide 1">
+    <p:spTree>
+      <p:nvGrpSpPr>
+        <p:cNvPr id="1" name=""/>
+        <p:cNvGrpSpPr/>
+        <p:nvPr/>
+      </p:nvGrpSpPr>
+      <p:grpSpPr>
+        <a:xfrm>
+          <a:off x="0" y="0"/>
+          <a:ext cx="0" cy="0"/>
+          <a:chOff x="0" y="0"/>
+          <a:chExt cx="0" cy="0"/>
+        </a:xfrm>
+      </p:grpSpPr>
+      <p:sp>
+        <p:nvSpPr>
+          <p:cNvPr id="2" name="Text 0"/>
+          <p:cNvSpPr/>
+          <p:nvPr>
+            <p:ph idx="100" type="title" hasCustomPrompt="1"/>
+          </p:nvPr>
+        </p:nvSpPr>
+        <p:spPr>
+          <a:xfrm>
+            <a:off x="457200" y="274320"/>
+            <a:ext cx="8229600" cy="640080"/>
+          </a:xfrm>
+          <a:prstGeom prst="rect">
+            <a:avLst/>
+          </a:prstGeom>
+          <a:noFill/>
+          <a:ln/>
+        </p:spPr>
+        <p:txBody>
+          <a:bodyPr wrap="square" lIns="0" tIns="0" rIns="0" bIns="0" rtlCol="0" anchor="ctr"/>
+          <a:lstStyle/>
+          <a:p>
+            <a:pPr algn="ctr" indent="0" marL="0">
+              <a:buNone/>
+            </a:pPr>
+            <a:r>
+              <a:rPr lang="en-US" sz="3200" b="1" dirty="0">
+                <a:solidFill>
+                  <a:schemeClr val="tx2"/>
+                </a:solidFill>
+              </a:rPr>
+              <a:t>Who we design for</a:t>
+            </a:r>
+            <a:endParaRPr lang="en-US" sz="3200" dirty="0"/>
+          </a:p>
+        </p:txBody>
+      </p:sp>
+      <p:sp>
+        <p:nvSpPr>
+          <p:cNvPr id="3" name="Rita card"/>
+          <p:cNvSpPr/>
+          <p:nvPr/>
+        </p:nvSpPr>
+        <p:spPr>
+          <a:xfrm>
+            <a:off x="457200" y="1005840"/>
+            <a:ext cx="1920240" cy="2761488"/>
+          </a:xfrm>
+          <a:prstGeom prst="roundRect">
+            <a:avLst>
+              <a:gd name="adj" fmla="val 5714"/>
+            </a:avLst>
+          </a:prstGeom>
+          <a:solidFill>
+            <a:schemeClr val="bg2"/>
+          </a:solidFill>
+          <a:ln/>
+        </p:spPr>
+      </p:sp>
+      <p:sp>
+        <p:nvSpPr>
+          <p:cNvPr id="4" name="Rita icon circle"/>
+          <p:cNvSpPr/>
+          <p:nvPr/>
+        </p:nvSpPr>
+        <p:spPr>
+          <a:xfrm>
+            <a:off x="621792" y="1161288"/>
+            <a:ext cx="402336" cy="402336"/>
+          </a:xfrm>
+          <a:prstGeom prst="ellipse">
+            <a:avLst/>
+          </a:prstGeom>
+          <a:solidFill>
+            <a:schemeClr val="tx2"/>
+          </a:solidFill>
+          <a:ln/>
+        </p:spPr>
+      </p:sp>
+      <p:pic>
+        <p:nvPicPr>
+          <p:cNvPr id="5" name="Rita icon" descr="Rita icon">    </p:cNvPr>
+          <p:cNvPicPr>
+            <a:picLocks noChangeAspect="1"/>
+          </p:cNvPicPr>
+          <p:nvPr/>
+        </p:nvPicPr>
+        <p:blipFill>
+          <a:blip r:embed="rId1"/>
+          <a:stretch>
+            <a:fillRect/>
+          </a:stretch>
+        </p:blipFill>
+        <p:spPr>
+          <a:xfrm>
+            <a:off x="722376" y="1261872"/>
+            <a:ext cx="201168" cy="201168"/>
+          </a:xfrm>
+          <a:prstGeom prst="rect">
+            <a:avLst/>
+          </a:prstGeom>
+        </p:spPr>
+      </p:pic>
+      <p:sp>
+        <p:nvSpPr>
+          <p:cNvPr id="6" name="Rita name"/>
+          <p:cNvSpPr txBox="1"/>
+          <p:nvPr/>
+        </p:nvSpPr>
+        <p:spPr>
+          <a:xfrm>
+            <a:off x="1115568" y="1161288"/>
+            <a:ext cx="1188720" cy="402336"/>
+          </a:xfrm>
+          <a:prstGeom prst="rect">
+            <a:avLst/>
+          </a:prstGeom>
+          <a:noFill/>
+          <a:ln/>
+        </p:spPr>
+        <p:txBody>
+          <a:bodyPr wrap="square" lIns="0" tIns="0" rIns="0" bIns="0" rtlCol="0" anchor="ctr"/>
+          <a:lstStyle/>
+          <a:p>
+            <a:pPr indent="0" marL="0">
+              <a:buNone/>
+            </a:pPr>
+            <a:r>
+              <a:rPr lang="en-US" sz="1600" b="1" dirty="0">
+                <a:solidFill>
+                  <a:schemeClr val="tx2"/>
+                </a:solidFill>
+              </a:rPr>
+              <a:t>Rita, 21</a:t>
+            </a:r>
+            <a:endParaRPr lang="en-US" sz="1600" dirty="0"/>
+          </a:p>
+        </p:txBody>
+      </p:sp>
+      <p:sp>
+        <p:nvSpPr>
+          <p:cNvPr id="7" name="Rita role"/>
+          <p:cNvSpPr txBox="1"/>
+          <p:nvPr/>
+        </p:nvSpPr>
+        <p:spPr>
+          <a:xfrm>
+            <a:off x="621792" y="1627632"/>
+            <a:ext cx="1645920" cy="201168"/>
+          </a:xfrm>
+          <a:prstGeom prst="rect">
+            <a:avLst/>
+          </a:prstGeom>
+          <a:noFill/>
+          <a:ln/>
+        </p:spPr>
+        <p:txBody>
+          <a:bodyPr wrap="square" lIns="0" tIns="0" rIns="0" bIns="0" rtlCol="0" anchor="ctr"/>
+          <a:lstStyle/>
+          <a:p>
+            <a:pPr indent="0" marL="0">
+              <a:buNone/>
+            </a:pPr>
+            <a:r>
+              <a:rPr lang="en-US" sz="1100" b="1" dirty="0">
+                <a:solidFill>
+                  <a:schemeClr val="accent2"/>
+                </a:solidFill>
+              </a:rPr>
+              <a:t>Student · participant app</a:t>
+            </a:r>
+            <a:endParaRPr lang="en-US" sz="1100" dirty="0"/>
+          </a:p>
+        </p:txBody>
+      </p:sp>
+      <p:pic>
+        <p:nvPicPr>
+          <p:cNvPr id="8" name="Rita Goal icon" descr="Goal">    </p:cNvPr>
+          <p:cNvPicPr>
+            <a:picLocks noChangeAspect="1"/>
+          </p:cNvPicPr>
+          <p:nvPr/>
+        </p:nvPicPr>
+        <p:blipFill>
+          <a:blip r:embed="rId2"/>
+          <a:stretch>
+            <a:fillRect/>
+          </a:stretch>
+        </p:blipFill>
+        <p:spPr>
+          <a:xfrm>
+            <a:off x="621792" y="1943100"/>
+            <a:ext cx="146304" cy="146304"/>
+          </a:xfrm>
+          <a:prstGeom prst="rect">
+            <a:avLst/>
+          </a:prstGeom>
+        </p:spPr>
+      </p:pic>
+      <p:sp>
+        <p:nvSpPr>
+          <p:cNvPr id="9" name="Rita Goal label"/>
+          <p:cNvSpPr txBox="1"/>
+          <p:nvPr/>
+        </p:nvSpPr>
+        <p:spPr>
+          <a:xfrm>
+            <a:off x="841248" y="1920240"/>
+            <a:ext cx="1371600" cy="182880"/>
+          </a:xfrm>
+          <a:prstGeom prst="rect">
+            <a:avLst/>
+          </a:prstGeom>
+          <a:noFill/>
+          <a:ln/>
+        </p:spPr>
+        <p:txBody>
+          <a:bodyPr wrap="square" lIns="0" tIns="0" rIns="0" bIns="0" rtlCol="0" anchor="ctr"/>
+          <a:lstStyle/>
+          <a:p>
+            <a:pPr indent="0" marL="0">
+              <a:buNone/>
+            </a:pPr>
+            <a:r>
+              <a:rPr lang="en-US" sz="1100" b="1" dirty="0">
+                <a:solidFill>
+                  <a:schemeClr val="tx2"/>
+                </a:solidFill>
+              </a:rPr>
+              <a:t>Goal</a:t>
+            </a:r>
+            <a:endParaRPr lang="en-US" sz="1100" dirty="0"/>
+          </a:p>
+        </p:txBody>
+      </p:sp>
+      <p:sp>
+        <p:nvSpPr>
+          <p:cNvPr id="10" name="Rita Goal"/>
+          <p:cNvSpPr txBox="1"/>
+          <p:nvPr/>
+        </p:nvSpPr>
+        <p:spPr>
+          <a:xfrm>
+            <a:off x="621792" y="2112264"/>
+            <a:ext cx="1645920" cy="347472"/>
+          </a:xfrm>
+          <a:prstGeom prst="rect">
+            <a:avLst/>
+          </a:prstGeom>
+          <a:noFill/>
+          <a:ln/>
+        </p:spPr>
+        <p:txBody>
+          <a:bodyPr wrap="square" lIns="0" tIns="0" rIns="0" bIns="0" rtlCol="0" anchor="t"/>
+          <a:lstStyle/>
+          <a:p>
+            <a:pPr indent="0" marL="0">
+              <a:buNone/>
+            </a:pPr>
+            <a:r>
+              <a:rPr lang="en-US" sz="1200" dirty="0">
+                <a:solidFill>
+                  <a:schemeClr val="tx1"/>
+                </a:solidFill>
+              </a:rPr>
+              <a:t>find WC, first aid and the way home, fast</a:t>
+            </a:r>
+            <a:endParaRPr lang="en-US" sz="1200" dirty="0"/>
+          </a:p>
+        </p:txBody>
+      </p:sp>
+      <p:pic>
+        <p:nvPicPr>
+          <p:cNvPr id="11" name="Rita Pain icon" descr="Pain">    </p:cNvPr>
+          <p:cNvPicPr>
+            <a:picLocks noChangeAspect="1"/>
+          </p:cNvPicPr>
+          <p:nvPr/>
+        </p:nvPicPr>
+        <p:blipFill>
+          <a:blip r:embed="rId3"/>
+          <a:stretch>
+            <a:fillRect/>
+          </a:stretch>
+        </p:blipFill>
+        <p:spPr>
+          <a:xfrm>
+            <a:off x="621792" y="2546604"/>
+            <a:ext cx="146304" cy="146304"/>
+          </a:xfrm>
+          <a:prstGeom prst="rect">
+            <a:avLst/>
+          </a:prstGeom>
+        </p:spPr>
+      </p:pic>
+      <p:sp>
+        <p:nvSpPr>
+          <p:cNvPr id="12" name="Rita Pain label"/>
+          <p:cNvSpPr txBox="1"/>
+          <p:nvPr/>
+        </p:nvSpPr>
+        <p:spPr>
+          <a:xfrm>
+            <a:off x="841248" y="2523744"/>
+            <a:ext cx="1371600" cy="182880"/>
+          </a:xfrm>
+          <a:prstGeom prst="rect">
+            <a:avLst/>
+          </a:prstGeom>
+          <a:noFill/>
+          <a:ln/>
+        </p:spPr>
+        <p:txBody>
+          <a:bodyPr wrap="square" lIns="0" tIns="0" rIns="0" bIns="0" rtlCol="0" anchor="ctr"/>
+          <a:lstStyle/>
+          <a:p>
+            <a:pPr indent="0" marL="0">
+              <a:buNone/>
+            </a:pPr>
+            <a:r>
+              <a:rPr lang="en-US" sz="1100" b="1" dirty="0">
+                <a:solidFill>
+                  <a:schemeClr val="tx2"/>
+                </a:solidFill>
+              </a:rPr>
+              <a:t>Pain</a:t>
+            </a:r>
+            <a:endParaRPr lang="en-US" sz="1100" dirty="0"/>
+          </a:p>
+        </p:txBody>
+      </p:sp>
+      <p:sp>
+        <p:nvSpPr>
+          <p:cNvPr id="13" name="Rita Pain"/>
+          <p:cNvSpPr txBox="1"/>
+          <p:nvPr/>
+        </p:nvSpPr>
+        <p:spPr>
+          <a:xfrm>
+            <a:off x="621792" y="2715768"/>
+            <a:ext cx="1645920" cy="347472"/>
+          </a:xfrm>
+          <a:prstGeom prst="rect">
+            <a:avLst/>
+          </a:prstGeom>
+          <a:noFill/>
+          <a:ln/>
+        </p:spPr>
+        <p:txBody>
+          <a:bodyPr wrap="square" lIns="0" tIns="0" rIns="0" bIns="0" rtlCol="0" anchor="t"/>
+          <a:lstStyle/>
+          <a:p>
+            <a:pPr indent="0" marL="0">
+              <a:buNone/>
+            </a:pPr>
+            <a:r>
+              <a:rPr lang="en-US" sz="1200" dirty="0">
+                <a:solidFill>
+                  <a:schemeClr val="tx1"/>
+                </a:solidFill>
+              </a:rPr>
+              <a:t>info goes stale; the map is an image</a:t>
+            </a:r>
+            <a:endParaRPr lang="en-US" sz="1200" dirty="0"/>
+          </a:p>
+        </p:txBody>
+      </p:sp>
+      <p:pic>
+        <p:nvPicPr>
+          <p:cNvPr id="14" name="Rita Success icon" descr="Success">    </p:cNvPr>
+          <p:cNvPicPr>
+            <a:picLocks noChangeAspect="1"/>
+          </p:cNvPicPr>
+          <p:nvPr/>
+        </p:nvPicPr>
+        <p:blipFill>
+          <a:blip r:embed="rId4"/>
+          <a:stretch>
+            <a:fillRect/>
+          </a:stretch>
+        </p:blipFill>
+        <p:spPr>
+          <a:xfrm>
+            <a:off x="621792" y="3150108"/>
+            <a:ext cx="146304" cy="146304"/>
+          </a:xfrm>
+          <a:prstGeom prst="rect">
+            <a:avLst/>
+          </a:prstGeom>
+        </p:spPr>
+      </p:pic>
+      <p:sp>
+        <p:nvSpPr>
+          <p:cNvPr id="15" name="Rita Success label"/>
+          <p:cNvSpPr txBox="1"/>
+          <p:nvPr/>
+        </p:nvSpPr>
+        <p:spPr>
+          <a:xfrm>
+            <a:off x="841248" y="3127248"/>
+            <a:ext cx="1371600" cy="182880"/>
+          </a:xfrm>
+          <a:prstGeom prst="rect">
+            <a:avLst/>
+          </a:prstGeom>
+          <a:noFill/>
+          <a:ln/>
+        </p:spPr>
+        <p:txBody>
+          <a:bodyPr wrap="square" lIns="0" tIns="0" rIns="0" bIns="0" rtlCol="0" anchor="ctr"/>
+          <a:lstStyle/>
+          <a:p>
+            <a:pPr indent="0" marL="0">
+              <a:buNone/>
+            </a:pPr>
+            <a:r>
+              <a:rPr lang="en-US" sz="1100" b="1" dirty="0">
+                <a:solidFill>
+                  <a:schemeClr val="tx2"/>
+                </a:solidFill>
+              </a:rPr>
+              <a:t>Success</a:t>
+            </a:r>
+            <a:endParaRPr lang="en-US" sz="1100" dirty="0"/>
+          </a:p>
+        </p:txBody>
+      </p:sp>
+      <p:sp>
+        <p:nvSpPr>
+          <p:cNvPr id="16" name="Rita Success"/>
+          <p:cNvSpPr txBox="1"/>
+          <p:nvPr/>
+        </p:nvSpPr>
+        <p:spPr>
+          <a:xfrm>
+            <a:off x="621792" y="3319272"/>
+            <a:ext cx="1645920" cy="347472"/>
+          </a:xfrm>
+          <a:prstGeom prst="rect">
+            <a:avLst/>
+          </a:prstGeom>
+          <a:noFill/>
+          <a:ln/>
+        </p:spPr>
+        <p:txBody>
+          <a:bodyPr wrap="square" lIns="0" tIns="0" rIns="0" bIns="0" rtlCol="0" anchor="t"/>
+          <a:lstStyle/>
+          <a:p>
+            <a:pPr indent="0" marL="0">
+              <a:buNone/>
+            </a:pPr>
+            <a:r>
+              <a:rPr lang="en-US" sz="1200" dirty="0">
+                <a:solidFill>
+                  <a:schemeClr val="tx1"/>
+                </a:solidFill>
+              </a:rPr>
+              <a:t>asks help for a friend in under 30 s</a:t>
+            </a:r>
+            <a:endParaRPr lang="en-US" sz="1200" dirty="0"/>
+          </a:p>
+        </p:txBody>
+      </p:sp>
+      <p:sp>
+        <p:nvSpPr>
+          <p:cNvPr id="17" name="Miguel card"/>
+          <p:cNvSpPr/>
+          <p:nvPr/>
+        </p:nvSpPr>
+        <p:spPr>
+          <a:xfrm>
+            <a:off x="2560320" y="1005840"/>
+            <a:ext cx="1920240" cy="2761488"/>
+          </a:xfrm>
+          <a:prstGeom prst="roundRect">
+            <a:avLst>
+              <a:gd name="adj" fmla="val 5714"/>
+            </a:avLst>
+          </a:prstGeom>
+          <a:solidFill>
+            <a:schemeClr val="bg2"/>
+          </a:solidFill>
+          <a:ln/>
+        </p:spPr>
+      </p:sp>
+      <p:sp>
+        <p:nvSpPr>
+          <p:cNvPr id="18" name="Miguel icon circle"/>
+          <p:cNvSpPr/>
+          <p:nvPr/>
+        </p:nvSpPr>
+        <p:spPr>
+          <a:xfrm>
+            <a:off x="2724912" y="1161288"/>
+            <a:ext cx="402336" cy="402336"/>
+          </a:xfrm>
+          <a:prstGeom prst="ellipse">
+            <a:avLst/>
+          </a:prstGeom>
+          <a:solidFill>
+            <a:schemeClr val="tx2"/>
+          </a:solidFill>
+          <a:ln/>
+        </p:spPr>
+      </p:sp>
+      <p:pic>
+        <p:nvPicPr>
+          <p:cNvPr id="19" name="Miguel icon" descr="Miguel icon">    </p:cNvPr>
+          <p:cNvPicPr>
+            <a:picLocks noChangeAspect="1"/>
+          </p:cNvPicPr>
+          <p:nvPr/>
+        </p:nvPicPr>
+        <p:blipFill>
+          <a:blip r:embed="rId5"/>
+          <a:stretch>
+            <a:fillRect/>
+          </a:stretch>
+        </p:blipFill>
+        <p:spPr>
+          <a:xfrm>
+            <a:off x="2825496" y="1261872"/>
+            <a:ext cx="201168" cy="201168"/>
+          </a:xfrm>
+          <a:prstGeom prst="rect">
+            <a:avLst/>
+          </a:prstGeom>
+        </p:spPr>
+      </p:pic>
+      <p:sp>
+        <p:nvSpPr>
+          <p:cNvPr id="20" name="Miguel name"/>
+          <p:cNvSpPr txBox="1"/>
+          <p:nvPr/>
+        </p:nvSpPr>
+        <p:spPr>
+          <a:xfrm>
+            <a:off x="3218688" y="1161288"/>
+            <a:ext cx="1188720" cy="402336"/>
+          </a:xfrm>
+          <a:prstGeom prst="rect">
+            <a:avLst/>
+          </a:prstGeom>
+          <a:noFill/>
+          <a:ln/>
+        </p:spPr>
+        <p:txBody>
+          <a:bodyPr wrap="square" lIns="0" tIns="0" rIns="0" bIns="0" rtlCol="0" anchor="ctr"/>
+          <a:lstStyle/>
+          <a:p>
+            <a:pPr indent="0" marL="0">
+              <a:buNone/>
+            </a:pPr>
+            <a:r>
+              <a:rPr lang="en-US" sz="1600" b="1" dirty="0">
+                <a:solidFill>
+                  <a:schemeClr val="tx2"/>
+                </a:solidFill>
+              </a:rPr>
+              <a:t>Miguel, 24</a:t>
+            </a:r>
+            <a:endParaRPr lang="en-US" sz="1600" dirty="0"/>
+          </a:p>
+        </p:txBody>
+      </p:sp>
+      <p:sp>
+        <p:nvSpPr>
+          <p:cNvPr id="21" name="Miguel role"/>
+          <p:cNvSpPr txBox="1"/>
+          <p:nvPr/>
+        </p:nvSpPr>
+        <p:spPr>
+          <a:xfrm>
+            <a:off x="2724912" y="1627632"/>
+            <a:ext cx="1645920" cy="201168"/>
+          </a:xfrm>
+          <a:prstGeom prst="rect">
+            <a:avLst/>
+          </a:prstGeom>
+          <a:noFill/>
+          <a:ln/>
+        </p:spPr>
+        <p:txBody>
+          <a:bodyPr wrap="square" lIns="0" tIns="0" rIns="0" bIns="0" rtlCol="0" anchor="ctr"/>
+          <a:lstStyle/>
+          <a:p>
+            <a:pPr indent="0" marL="0">
+              <a:buNone/>
+            </a:pPr>
+            <a:r>
+              <a:rPr lang="en-US" sz="1100" b="1" dirty="0">
+                <a:solidFill>
+                  <a:schemeClr val="accent2"/>
+                </a:solidFill>
+              </a:rPr>
+              <a:t>PCR volunteer · operator</a:t>
+            </a:r>
+            <a:endParaRPr lang="en-US" sz="1100" dirty="0"/>
+          </a:p>
+        </p:txBody>
+      </p:sp>
+      <p:pic>
+        <p:nvPicPr>
+          <p:cNvPr id="22" name="Miguel Goal icon" descr="Goal">    </p:cNvPr>
+          <p:cNvPicPr>
+            <a:picLocks noChangeAspect="1"/>
+          </p:cNvPicPr>
+          <p:nvPr/>
+        </p:nvPicPr>
+        <p:blipFill>
+          <a:blip r:embed="rId6"/>
+          <a:stretch>
+            <a:fillRect/>
+          </a:stretch>
+        </p:blipFill>
+        <p:spPr>
+          <a:xfrm>
+            <a:off x="2724912" y="1943100"/>
+            <a:ext cx="146304" cy="146304"/>
+          </a:xfrm>
+          <a:prstGeom prst="rect">
+            <a:avLst/>
+          </a:prstGeom>
+        </p:spPr>
+      </p:pic>
+      <p:sp>
+        <p:nvSpPr>
+          <p:cNvPr id="23" name="Miguel Goal label"/>
+          <p:cNvSpPr txBox="1"/>
+          <p:nvPr/>
+        </p:nvSpPr>
+        <p:spPr>
+          <a:xfrm>
+            <a:off x="2944368" y="1920240"/>
+            <a:ext cx="1371600" cy="182880"/>
+          </a:xfrm>
+          <a:prstGeom prst="rect">
+            <a:avLst/>
+          </a:prstGeom>
+          <a:noFill/>
+          <a:ln/>
+        </p:spPr>
+        <p:txBody>
+          <a:bodyPr wrap="square" lIns="0" tIns="0" rIns="0" bIns="0" rtlCol="0" anchor="ctr"/>
+          <a:lstStyle/>
+          <a:p>
+            <a:pPr indent="0" marL="0">
+              <a:buNone/>
+            </a:pPr>
+            <a:r>
+              <a:rPr lang="en-US" sz="1100" b="1" dirty="0">
+                <a:solidFill>
+                  <a:schemeClr val="tx2"/>
+                </a:solidFill>
+              </a:rPr>
+              <a:t>Goal</a:t>
+            </a:r>
+            <a:endParaRPr lang="en-US" sz="1100" dirty="0"/>
+          </a:p>
+        </p:txBody>
+      </p:sp>
+      <p:sp>
+        <p:nvSpPr>
+          <p:cNvPr id="24" name="Miguel Goal"/>
+          <p:cNvSpPr txBox="1"/>
+          <p:nvPr/>
+        </p:nvSpPr>
+        <p:spPr>
+          <a:xfrm>
+            <a:off x="2724912" y="2112264"/>
+            <a:ext cx="1645920" cy="347472"/>
+          </a:xfrm>
+          <a:prstGeom prst="rect">
+            <a:avLst/>
+          </a:prstGeom>
+          <a:noFill/>
+          <a:ln/>
+        </p:spPr>
+        <p:txBody>
+          <a:bodyPr wrap="square" lIns="0" tIns="0" rIns="0" bIns="0" rtlCol="0" anchor="t"/>
+          <a:lstStyle/>
+          <a:p>
+            <a:pPr indent="0" marL="0">
+              <a:buNone/>
+            </a:pPr>
+            <a:r>
+              <a:rPr lang="en-US" sz="1200" dirty="0">
+                <a:solidFill>
+                  <a:schemeClr val="tx1"/>
+                </a:solidFill>
+              </a:rPr>
+              <a:t>see every request: what, where, status</a:t>
+            </a:r>
+            <a:endParaRPr lang="en-US" sz="1200" dirty="0"/>
+          </a:p>
+        </p:txBody>
+      </p:sp>
+      <p:pic>
+        <p:nvPicPr>
+          <p:cNvPr id="25" name="Miguel Pain icon" descr="Pain">    </p:cNvPr>
+          <p:cNvPicPr>
+            <a:picLocks noChangeAspect="1"/>
+          </p:cNvPicPr>
+          <p:nvPr/>
+        </p:nvPicPr>
+        <p:blipFill>
+          <a:blip r:embed="rId7"/>
+          <a:stretch>
+            <a:fillRect/>
+          </a:stretch>
+        </p:blipFill>
+        <p:spPr>
+          <a:xfrm>
+            <a:off x="2724912" y="2546604"/>
+            <a:ext cx="146304" cy="146304"/>
+          </a:xfrm>
+          <a:prstGeom prst="rect">
+            <a:avLst/>
+          </a:prstGeom>
+        </p:spPr>
+      </p:pic>
+      <p:sp>
+        <p:nvSpPr>
+          <p:cNvPr id="26" name="Miguel Pain label"/>
+          <p:cNvSpPr txBox="1"/>
+          <p:nvPr/>
+        </p:nvSpPr>
+        <p:spPr>
+          <a:xfrm>
+            <a:off x="2944368" y="2523744"/>
+            <a:ext cx="1371600" cy="182880"/>
+          </a:xfrm>
+          <a:prstGeom prst="rect">
+            <a:avLst/>
+          </a:prstGeom>
+          <a:noFill/>
+          <a:ln/>
+        </p:spPr>
+        <p:txBody>
+          <a:bodyPr wrap="square" lIns="0" tIns="0" rIns="0" bIns="0" rtlCol="0" anchor="ctr"/>
+          <a:lstStyle/>
+          <a:p>
+            <a:pPr indent="0" marL="0">
+              <a:buNone/>
+            </a:pPr>
+            <a:r>
+              <a:rPr lang="en-US" sz="1100" b="1" dirty="0">
+                <a:solidFill>
+                  <a:schemeClr val="tx2"/>
+                </a:solidFill>
+              </a:rPr>
+              <a:t>Pain</a:t>
+            </a:r>
+            <a:endParaRPr lang="en-US" sz="1100" dirty="0"/>
+          </a:p>
+        </p:txBody>
+      </p:sp>
+      <p:sp>
+        <p:nvSpPr>
+          <p:cNvPr id="27" name="Miguel Pain"/>
+          <p:cNvSpPr txBox="1"/>
+          <p:nvPr/>
+        </p:nvSpPr>
+        <p:spPr>
+          <a:xfrm>
+            <a:off x="2724912" y="2715768"/>
+            <a:ext cx="1645920" cy="347472"/>
+          </a:xfrm>
+          <a:prstGeom prst="rect">
+            <a:avLst/>
+          </a:prstGeom>
+          <a:noFill/>
+          <a:ln/>
+        </p:spPr>
+        <p:txBody>
+          <a:bodyPr wrap="square" lIns="0" tIns="0" rIns="0" bIns="0" rtlCol="0" anchor="t"/>
+          <a:lstStyle/>
+          <a:p>
+            <a:pPr indent="0" marL="0">
+              <a:buNone/>
+            </a:pPr>
+            <a:r>
+              <a:rPr lang="en-US" sz="1200" dirty="0">
+                <a:solidFill>
+                  <a:schemeClr val="tx1"/>
+                </a:solidFill>
+              </a:rPr>
+              <a:t>radio and phone, no location or priority</a:t>
+            </a:r>
+            <a:endParaRPr lang="en-US" sz="1200" dirty="0"/>
+          </a:p>
+        </p:txBody>
+      </p:sp>
+      <p:pic>
+        <p:nvPicPr>
+          <p:cNvPr id="28" name="Miguel Success icon" descr="Success">    </p:cNvPr>
+          <p:cNvPicPr>
+            <a:picLocks noChangeAspect="1"/>
+          </p:cNvPicPr>
+          <p:nvPr/>
+        </p:nvPicPr>
+        <p:blipFill>
+          <a:blip r:embed="rId8"/>
+          <a:stretch>
+            <a:fillRect/>
+          </a:stretch>
+        </p:blipFill>
+        <p:spPr>
+          <a:xfrm>
+            <a:off x="2724912" y="3150108"/>
+            <a:ext cx="146304" cy="146304"/>
+          </a:xfrm>
+          <a:prstGeom prst="rect">
+            <a:avLst/>
+          </a:prstGeom>
+        </p:spPr>
+      </p:pic>
+      <p:sp>
+        <p:nvSpPr>
+          <p:cNvPr id="29" name="Miguel Success label"/>
+          <p:cNvSpPr txBox="1"/>
+          <p:nvPr/>
+        </p:nvSpPr>
+        <p:spPr>
+          <a:xfrm>
+            <a:off x="2944368" y="3127248"/>
+            <a:ext cx="1371600" cy="182880"/>
+          </a:xfrm>
+          <a:prstGeom prst="rect">
+            <a:avLst/>
+          </a:prstGeom>
+          <a:noFill/>
+          <a:ln/>
+        </p:spPr>
+        <p:txBody>
+          <a:bodyPr wrap="square" lIns="0" tIns="0" rIns="0" bIns="0" rtlCol="0" anchor="ctr"/>
+          <a:lstStyle/>
+          <a:p>
+            <a:pPr indent="0" marL="0">
+              <a:buNone/>
+            </a:pPr>
+            <a:r>
+              <a:rPr lang="en-US" sz="1100" b="1" dirty="0">
+                <a:solidFill>
+                  <a:schemeClr val="tx2"/>
+                </a:solidFill>
+              </a:rPr>
+              <a:t>Success</a:t>
+            </a:r>
+            <a:endParaRPr lang="en-US" sz="1100" dirty="0"/>
+          </a:p>
+        </p:txBody>
+      </p:sp>
+      <p:sp>
+        <p:nvSpPr>
+          <p:cNvPr id="30" name="Miguel Success"/>
+          <p:cNvSpPr txBox="1"/>
+          <p:nvPr/>
+        </p:nvSpPr>
+        <p:spPr>
+          <a:xfrm>
+            <a:off x="2724912" y="3319272"/>
+            <a:ext cx="1645920" cy="347472"/>
+          </a:xfrm>
+          <a:prstGeom prst="rect">
+            <a:avLst/>
+          </a:prstGeom>
+          <a:noFill/>
+          <a:ln/>
+        </p:spPr>
+        <p:txBody>
+          <a:bodyPr wrap="square" lIns="0" tIns="0" rIns="0" bIns="0" rtlCol="0" anchor="t"/>
+          <a:lstStyle/>
+          <a:p>
+            <a:pPr indent="0" marL="0">
+              <a:buNone/>
+            </a:pPr>
+            <a:r>
+              <a:rPr lang="en-US" sz="1200" dirty="0">
+                <a:solidFill>
+                  <a:schemeClr val="tx1"/>
+                </a:solidFill>
+              </a:rPr>
+              <a:t>each request in seconds, triaged in ≤ 30 s</a:t>
+            </a:r>
+            <a:endParaRPr lang="en-US" sz="1200" dirty="0"/>
+          </a:p>
+        </p:txBody>
+      </p:sp>
+      <p:sp>
+        <p:nvSpPr>
+          <p:cNvPr id="31" name="Sofia card"/>
+          <p:cNvSpPr/>
+          <p:nvPr/>
+        </p:nvSpPr>
+        <p:spPr>
+          <a:xfrm>
+            <a:off x="4663440" y="1005840"/>
+            <a:ext cx="1920240" cy="2761488"/>
+          </a:xfrm>
+          <a:prstGeom prst="roundRect">
+            <a:avLst>
+              <a:gd name="adj" fmla="val 5714"/>
+            </a:avLst>
+          </a:prstGeom>
+          <a:solidFill>
+            <a:schemeClr val="bg2"/>
+          </a:solidFill>
+          <a:ln/>
+        </p:spPr>
+      </p:sp>
+      <p:sp>
+        <p:nvSpPr>
+          <p:cNvPr id="32" name="Sofia icon circle"/>
+          <p:cNvSpPr/>
+          <p:nvPr/>
+        </p:nvSpPr>
+        <p:spPr>
+          <a:xfrm>
+            <a:off x="4828032" y="1161288"/>
+            <a:ext cx="402336" cy="402336"/>
+          </a:xfrm>
+          <a:prstGeom prst="ellipse">
+            <a:avLst/>
+          </a:prstGeom>
+          <a:solidFill>
+            <a:schemeClr val="tx2"/>
+          </a:solidFill>
+          <a:ln/>
+        </p:spPr>
+      </p:sp>
+      <p:pic>
+        <p:nvPicPr>
+          <p:cNvPr id="33" name="Sofia icon" descr="Sofia icon">    </p:cNvPr>
+          <p:cNvPicPr>
+            <a:picLocks noChangeAspect="1"/>
+          </p:cNvPicPr>
+          <p:nvPr/>
+        </p:nvPicPr>
+        <p:blipFill>
+          <a:blip r:embed="rId9"/>
+          <a:stretch>
+            <a:fillRect/>
+          </a:stretch>
+        </p:blipFill>
+        <p:spPr>
+          <a:xfrm>
+            <a:off x="4928616" y="1261872"/>
+            <a:ext cx="201168" cy="201168"/>
+          </a:xfrm>
+          <a:prstGeom prst="rect">
+            <a:avLst/>
+          </a:prstGeom>
+        </p:spPr>
+      </p:pic>
+      <p:sp>
+        <p:nvSpPr>
+          <p:cNvPr id="34" name="Sofia name"/>
+          <p:cNvSpPr txBox="1"/>
+          <p:nvPr/>
+        </p:nvSpPr>
+        <p:spPr>
+          <a:xfrm>
+            <a:off x="5321808" y="1161288"/>
+            <a:ext cx="1188720" cy="402336"/>
+          </a:xfrm>
+          <a:prstGeom prst="rect">
+            <a:avLst/>
+          </a:prstGeom>
+          <a:noFill/>
+          <a:ln/>
+        </p:spPr>
+        <p:txBody>
+          <a:bodyPr wrap="square" lIns="0" tIns="0" rIns="0" bIns="0" rtlCol="0" anchor="ctr"/>
+          <a:lstStyle/>
+          <a:p>
+            <a:pPr indent="0" marL="0">
+              <a:buNone/>
+            </a:pPr>
+            <a:r>
+              <a:rPr lang="en-US" sz="1600" b="1" dirty="0">
+                <a:solidFill>
+                  <a:schemeClr val="tx2"/>
+                </a:solidFill>
+              </a:rPr>
+              <a:t>Sofia, 23</a:t>
+            </a:r>
+            <a:endParaRPr lang="en-US" sz="1600" dirty="0"/>
+          </a:p>
+        </p:txBody>
+      </p:sp>
+      <p:sp>
+        <p:nvSpPr>
+          <p:cNvPr id="35" name="Sofia role"/>
+          <p:cNvSpPr txBox="1"/>
+          <p:nvPr/>
+        </p:nvSpPr>
+        <p:spPr>
+          <a:xfrm>
+            <a:off x="4828032" y="1627632"/>
+            <a:ext cx="1645920" cy="201168"/>
+          </a:xfrm>
+          <a:prstGeom prst="rect">
+            <a:avLst/>
+          </a:prstGeom>
+          <a:noFill/>
+          <a:ln/>
+        </p:spPr>
+        <p:txBody>
+          <a:bodyPr wrap="square" lIns="0" tIns="0" rIns="0" bIns="0" rtlCol="0" anchor="ctr"/>
+          <a:lstStyle/>
+          <a:p>
+            <a:pPr indent="0" marL="0">
+              <a:buNone/>
+            </a:pPr>
+            <a:r>
+              <a:rPr lang="en-US" sz="1100" b="1" dirty="0">
+                <a:solidFill>
+                  <a:schemeClr val="accent2"/>
+                </a:solidFill>
+              </a:rPr>
+              <a:t>Organiser · her event only</a:t>
+            </a:r>
+            <a:endParaRPr lang="en-US" sz="1100" dirty="0"/>
+          </a:p>
+        </p:txBody>
+      </p:sp>
+      <p:pic>
+        <p:nvPicPr>
+          <p:cNvPr id="36" name="Sofia Goal icon" descr="Goal">    </p:cNvPr>
+          <p:cNvPicPr>
+            <a:picLocks noChangeAspect="1"/>
+          </p:cNvPicPr>
+          <p:nvPr/>
+        </p:nvPicPr>
+        <p:blipFill>
+          <a:blip r:embed="rId10"/>
+          <a:stretch>
+            <a:fillRect/>
+          </a:stretch>
+        </p:blipFill>
+        <p:spPr>
+          <a:xfrm>
+            <a:off x="4828032" y="1943100"/>
+            <a:ext cx="146304" cy="146304"/>
+          </a:xfrm>
+          <a:prstGeom prst="rect">
+            <a:avLst/>
+          </a:prstGeom>
+        </p:spPr>
+      </p:pic>
+      <p:sp>
+        <p:nvSpPr>
+          <p:cNvPr id="37" name="Sofia Goal label"/>
+          <p:cNvSpPr txBox="1"/>
+          <p:nvPr/>
+        </p:nvSpPr>
+        <p:spPr>
+          <a:xfrm>
+            <a:off x="5047488" y="1920240"/>
+            <a:ext cx="1371600" cy="182880"/>
+          </a:xfrm>
+          <a:prstGeom prst="rect">
+            <a:avLst/>
+          </a:prstGeom>
+          <a:noFill/>
+          <a:ln/>
+        </p:spPr>
+        <p:txBody>
+          <a:bodyPr wrap="square" lIns="0" tIns="0" rIns="0" bIns="0" rtlCol="0" anchor="ctr"/>
+          <a:lstStyle/>
+          <a:p>
+            <a:pPr indent="0" marL="0">
+              <a:buNone/>
+            </a:pPr>
+            <a:r>
+              <a:rPr lang="en-US" sz="1100" b="1" dirty="0">
+                <a:solidFill>
+                  <a:schemeClr val="tx2"/>
+                </a:solidFill>
+              </a:rPr>
+              <a:t>Goal</a:t>
+            </a:r>
+            <a:endParaRPr lang="en-US" sz="1100" dirty="0"/>
+          </a:p>
+        </p:txBody>
+      </p:sp>
+      <p:sp>
+        <p:nvSpPr>
+          <p:cNvPr id="38" name="Sofia Goal"/>
+          <p:cNvSpPr txBox="1"/>
+          <p:nvPr/>
+        </p:nvSpPr>
+        <p:spPr>
+          <a:xfrm>
+            <a:off x="4828032" y="2112264"/>
+            <a:ext cx="1645920" cy="347472"/>
+          </a:xfrm>
+          <a:prstGeom prst="rect">
+            <a:avLst/>
+          </a:prstGeom>
+          <a:noFill/>
+          <a:ln/>
+        </p:spPr>
+        <p:txBody>
+          <a:bodyPr wrap="square" lIns="0" tIns="0" rIns="0" bIns="0" rtlCol="0" anchor="t"/>
+          <a:lstStyle/>
+          <a:p>
+            <a:pPr indent="0" marL="0">
+              <a:buNone/>
+            </a:pPr>
+            <a:r>
+              <a:rPr lang="en-US" sz="1200" dirty="0">
+                <a:solidFill>
+                  <a:schemeClr val="tx1"/>
+                </a:solidFill>
+              </a:rPr>
+              <a:t>configure once, publish changes live</a:t>
+            </a:r>
+            <a:endParaRPr lang="en-US" sz="1200" dirty="0"/>
+          </a:p>
+        </p:txBody>
+      </p:sp>
+      <p:pic>
+        <p:nvPicPr>
+          <p:cNvPr id="39" name="Sofia Pain icon" descr="Pain">    </p:cNvPr>
+          <p:cNvPicPr>
+            <a:picLocks noChangeAspect="1"/>
+          </p:cNvPicPr>
+          <p:nvPr/>
+        </p:nvPicPr>
+        <p:blipFill>
+          <a:blip r:embed="rId11"/>
+          <a:stretch>
+            <a:fillRect/>
+          </a:stretch>
+        </p:blipFill>
+        <p:spPr>
+          <a:xfrm>
+            <a:off x="4828032" y="2546604"/>
+            <a:ext cx="146304" cy="146304"/>
+          </a:xfrm>
+          <a:prstGeom prst="rect">
+            <a:avLst/>
+          </a:prstGeom>
+        </p:spPr>
+      </p:pic>
+      <p:sp>
+        <p:nvSpPr>
+          <p:cNvPr id="40" name="Sofia Pain label"/>
+          <p:cNvSpPr txBox="1"/>
+          <p:nvPr/>
+        </p:nvSpPr>
+        <p:spPr>
+          <a:xfrm>
+            <a:off x="5047488" y="2523744"/>
+            <a:ext cx="1371600" cy="182880"/>
+          </a:xfrm>
+          <a:prstGeom prst="rect">
+            <a:avLst/>
+          </a:prstGeom>
+          <a:noFill/>
+          <a:ln/>
+        </p:spPr>
+        <p:txBody>
+          <a:bodyPr wrap="square" lIns="0" tIns="0" rIns="0" bIns="0" rtlCol="0" anchor="ctr"/>
+          <a:lstStyle/>
+          <a:p>
+            <a:pPr indent="0" marL="0">
+              <a:buNone/>
+            </a:pPr>
+            <a:r>
+              <a:rPr lang="en-US" sz="1100" b="1" dirty="0">
+                <a:solidFill>
+                  <a:schemeClr val="tx2"/>
+                </a:solidFill>
+              </a:rPr>
+              <a:t>Pain</a:t>
+            </a:r>
+            <a:endParaRPr lang="en-US" sz="1100" dirty="0"/>
+          </a:p>
+        </p:txBody>
+      </p:sp>
+      <p:sp>
+        <p:nvSpPr>
+          <p:cNvPr id="41" name="Sofia Pain"/>
+          <p:cNvSpPr txBox="1"/>
+          <p:nvPr/>
+        </p:nvSpPr>
+        <p:spPr>
+          <a:xfrm>
+            <a:off x="4828032" y="2715768"/>
+            <a:ext cx="1645920" cy="347472"/>
+          </a:xfrm>
+          <a:prstGeom prst="rect">
+            <a:avLst/>
+          </a:prstGeom>
+          <a:noFill/>
+          <a:ln/>
+        </p:spPr>
+        <p:txBody>
+          <a:bodyPr wrap="square" lIns="0" tIns="0" rIns="0" bIns="0" rtlCol="0" anchor="t"/>
+          <a:lstStyle/>
+          <a:p>
+            <a:pPr indent="0" marL="0">
+              <a:buNone/>
+            </a:pPr>
+            <a:r>
+              <a:rPr lang="en-US" sz="1200" dirty="0">
+                <a:solidFill>
+                  <a:schemeClr val="tx1"/>
+                </a:solidFill>
+              </a:rPr>
+              <a:t>each partner talks on its own channel</a:t>
+            </a:r>
+            <a:endParaRPr lang="en-US" sz="1200" dirty="0"/>
+          </a:p>
+        </p:txBody>
+      </p:sp>
+      <p:pic>
+        <p:nvPicPr>
+          <p:cNvPr id="42" name="Sofia Success icon" descr="Success">    </p:cNvPr>
+          <p:cNvPicPr>
+            <a:picLocks noChangeAspect="1"/>
+          </p:cNvPicPr>
+          <p:nvPr/>
+        </p:nvPicPr>
+        <p:blipFill>
+          <a:blip r:embed="rId12"/>
+          <a:stretch>
+            <a:fillRect/>
+          </a:stretch>
+        </p:blipFill>
+        <p:spPr>
+          <a:xfrm>
+            <a:off x="4828032" y="3150108"/>
+            <a:ext cx="146304" cy="146304"/>
+          </a:xfrm>
+          <a:prstGeom prst="rect">
+            <a:avLst/>
+          </a:prstGeom>
+        </p:spPr>
+      </p:pic>
+      <p:sp>
+        <p:nvSpPr>
+          <p:cNvPr id="43" name="Sofia Success label"/>
+          <p:cNvSpPr txBox="1"/>
+          <p:nvPr/>
+        </p:nvSpPr>
+        <p:spPr>
+          <a:xfrm>
+            <a:off x="5047488" y="3127248"/>
+            <a:ext cx="1371600" cy="182880"/>
+          </a:xfrm>
+          <a:prstGeom prst="rect">
+            <a:avLst/>
+          </a:prstGeom>
+          <a:noFill/>
+          <a:ln/>
+        </p:spPr>
+        <p:txBody>
+          <a:bodyPr wrap="square" lIns="0" tIns="0" rIns="0" bIns="0" rtlCol="0" anchor="ctr"/>
+          <a:lstStyle/>
+          <a:p>
+            <a:pPr indent="0" marL="0">
+              <a:buNone/>
+            </a:pPr>
+            <a:r>
+              <a:rPr lang="en-US" sz="1100" b="1" dirty="0">
+                <a:solidFill>
+                  <a:schemeClr val="tx2"/>
+                </a:solidFill>
+              </a:rPr>
+              <a:t>Success</a:t>
+            </a:r>
+            <a:endParaRPr lang="en-US" sz="1100" dirty="0"/>
+          </a:p>
+        </p:txBody>
+      </p:sp>
+      <p:sp>
+        <p:nvSpPr>
+          <p:cNvPr id="44" name="Sofia Success"/>
+          <p:cNvSpPr txBox="1"/>
+          <p:nvPr/>
+        </p:nvSpPr>
+        <p:spPr>
+          <a:xfrm>
+            <a:off x="4828032" y="3319272"/>
+            <a:ext cx="1645920" cy="347472"/>
+          </a:xfrm>
+          <a:prstGeom prst="rect">
+            <a:avLst/>
+          </a:prstGeom>
+          <a:noFill/>
+          <a:ln/>
+        </p:spPr>
+        <p:txBody>
+          <a:bodyPr wrap="square" lIns="0" tIns="0" rIns="0" bIns="0" rtlCol="0" anchor="t"/>
+          <a:lstStyle/>
+          <a:p>
+            <a:pPr indent="0" marL="0">
+              <a:buNone/>
+            </a:pPr>
+            <a:r>
+              <a:rPr lang="en-US" sz="1200" dirty="0">
+                <a:solidFill>
+                  <a:schemeClr val="tx1"/>
+                </a:solidFill>
+              </a:rPr>
+              <a:t>next night ready with configuration only</a:t>
+            </a:r>
+            <a:endParaRPr lang="en-US" sz="1200" dirty="0"/>
+          </a:p>
+        </p:txBody>
+      </p:sp>
+      <p:sp>
+        <p:nvSpPr>
+          <p:cNvPr id="45" name="Daniel card"/>
+          <p:cNvSpPr/>
+          <p:nvPr/>
+        </p:nvSpPr>
+        <p:spPr>
+          <a:xfrm>
+            <a:off x="6766560" y="1005840"/>
+            <a:ext cx="1920240" cy="2761488"/>
+          </a:xfrm>
+          <a:prstGeom prst="roundRect">
+            <a:avLst>
+              <a:gd name="adj" fmla="val 5714"/>
+            </a:avLst>
+          </a:prstGeom>
+          <a:solidFill>
+            <a:schemeClr val="bg2"/>
+          </a:solidFill>
+          <a:ln/>
+        </p:spPr>
+      </p:sp>
+      <p:sp>
+        <p:nvSpPr>
+          <p:cNvPr id="46" name="Daniel icon circle"/>
+          <p:cNvSpPr/>
+          <p:nvPr/>
+        </p:nvSpPr>
+        <p:spPr>
+          <a:xfrm>
+            <a:off x="6931152" y="1161288"/>
+            <a:ext cx="402336" cy="402336"/>
+          </a:xfrm>
+          <a:prstGeom prst="ellipse">
+            <a:avLst/>
+          </a:prstGeom>
+          <a:solidFill>
+            <a:schemeClr val="tx2"/>
+          </a:solidFill>
+          <a:ln/>
+        </p:spPr>
+      </p:sp>
+      <p:pic>
+        <p:nvPicPr>
+          <p:cNvPr id="47" name="Daniel icon" descr="Daniel icon">    </p:cNvPr>
+          <p:cNvPicPr>
+            <a:picLocks noChangeAspect="1"/>
+          </p:cNvPicPr>
+          <p:nvPr/>
+        </p:nvPicPr>
+        <p:blipFill>
+          <a:blip r:embed="rId13"/>
+          <a:stretch>
+            <a:fillRect/>
+          </a:stretch>
+        </p:blipFill>
+        <p:spPr>
+          <a:xfrm>
+            <a:off x="7031736" y="1261872"/>
+            <a:ext cx="201168" cy="201168"/>
+          </a:xfrm>
+          <a:prstGeom prst="rect">
+            <a:avLst/>
+          </a:prstGeom>
+        </p:spPr>
+      </p:pic>
+      <p:sp>
+        <p:nvSpPr>
+          <p:cNvPr id="48" name="Daniel name"/>
+          <p:cNvSpPr txBox="1"/>
+          <p:nvPr/>
+        </p:nvSpPr>
+        <p:spPr>
+          <a:xfrm>
+            <a:off x="7424928" y="1161288"/>
+            <a:ext cx="1188720" cy="402336"/>
+          </a:xfrm>
+          <a:prstGeom prst="rect">
+            <a:avLst/>
+          </a:prstGeom>
+          <a:noFill/>
+          <a:ln/>
+        </p:spPr>
+        <p:txBody>
+          <a:bodyPr wrap="square" lIns="0" tIns="0" rIns="0" bIns="0" rtlCol="0" anchor="ctr"/>
+          <a:lstStyle/>
+          <a:p>
+            <a:pPr indent="0" marL="0">
+              <a:buNone/>
+            </a:pPr>
+            <a:r>
+              <a:rPr lang="en-US" sz="1600" b="1" dirty="0">
+                <a:solidFill>
+                  <a:schemeClr val="tx2"/>
+                </a:solidFill>
+              </a:rPr>
+              <a:t>Daniel, 27</a:t>
+            </a:r>
+            <a:endParaRPr lang="en-US" sz="1600" dirty="0"/>
+          </a:p>
+        </p:txBody>
+      </p:sp>
+      <p:sp>
+        <p:nvSpPr>
+          <p:cNvPr id="49" name="Daniel role"/>
+          <p:cNvSpPr txBox="1"/>
+          <p:nvPr/>
+        </p:nvSpPr>
+        <p:spPr>
+          <a:xfrm>
+            <a:off x="6931152" y="1627632"/>
+            <a:ext cx="1645920" cy="201168"/>
+          </a:xfrm>
+          <a:prstGeom prst="rect">
+            <a:avLst/>
+          </a:prstGeom>
+          <a:noFill/>
+          <a:ln/>
+        </p:spPr>
+        <p:txBody>
+          <a:bodyPr wrap="square" lIns="0" tIns="0" rIns="0" bIns="0" rtlCol="0" anchor="ctr"/>
+          <a:lstStyle/>
+          <a:p>
+            <a:pPr indent="0" marL="0">
+              <a:buNone/>
+            </a:pPr>
+            <a:r>
+              <a:rPr lang="en-US" sz="1100" b="1" dirty="0">
+                <a:solidFill>
+                  <a:schemeClr val="accent2"/>
+                </a:solidFill>
+              </a:rPr>
+              <a:t>Farol team · all events</a:t>
+            </a:r>
+            <a:endParaRPr lang="en-US" sz="1100" dirty="0"/>
+          </a:p>
+        </p:txBody>
+      </p:sp>
+      <p:pic>
+        <p:nvPicPr>
+          <p:cNvPr id="50" name="Daniel Goal icon" descr="Goal">    </p:cNvPr>
+          <p:cNvPicPr>
+            <a:picLocks noChangeAspect="1"/>
+          </p:cNvPicPr>
+          <p:nvPr/>
+        </p:nvPicPr>
+        <p:blipFill>
+          <a:blip r:embed="rId14"/>
+          <a:stretch>
+            <a:fillRect/>
+          </a:stretch>
+        </p:blipFill>
+        <p:spPr>
+          <a:xfrm>
+            <a:off x="6931152" y="1943100"/>
+            <a:ext cx="146304" cy="146304"/>
+          </a:xfrm>
+          <a:prstGeom prst="rect">
+            <a:avLst/>
+          </a:prstGeom>
+        </p:spPr>
+      </p:pic>
+      <p:sp>
+        <p:nvSpPr>
+          <p:cNvPr id="51" name="Daniel Goal label"/>
+          <p:cNvSpPr txBox="1"/>
+          <p:nvPr/>
+        </p:nvSpPr>
+        <p:spPr>
+          <a:xfrm>
+            <a:off x="7150608" y="1920240"/>
+            <a:ext cx="1371600" cy="182880"/>
+          </a:xfrm>
+          <a:prstGeom prst="rect">
+            <a:avLst/>
+          </a:prstGeom>
+          <a:noFill/>
+          <a:ln/>
+        </p:spPr>
+        <p:txBody>
+          <a:bodyPr wrap="square" lIns="0" tIns="0" rIns="0" bIns="0" rtlCol="0" anchor="ctr"/>
+          <a:lstStyle/>
+          <a:p>
+            <a:pPr indent="0" marL="0">
+              <a:buNone/>
+            </a:pPr>
+            <a:r>
+              <a:rPr lang="en-US" sz="1100" b="1" dirty="0">
+                <a:solidFill>
+                  <a:schemeClr val="tx2"/>
+                </a:solidFill>
+              </a:rPr>
+              <a:t>Goal</a:t>
+            </a:r>
+            <a:endParaRPr lang="en-US" sz="1100" dirty="0"/>
+          </a:p>
+        </p:txBody>
+      </p:sp>
+      <p:sp>
+        <p:nvSpPr>
+          <p:cNvPr id="52" name="Daniel Goal"/>
+          <p:cNvSpPr txBox="1"/>
+          <p:nvPr/>
+        </p:nvSpPr>
+        <p:spPr>
+          <a:xfrm>
+            <a:off x="6931152" y="2112264"/>
+            <a:ext cx="1645920" cy="347472"/>
+          </a:xfrm>
+          <a:prstGeom prst="rect">
+            <a:avLst/>
+          </a:prstGeom>
+          <a:noFill/>
+          <a:ln/>
+        </p:spPr>
+        <p:txBody>
+          <a:bodyPr wrap="square" lIns="0" tIns="0" rIns="0" bIns="0" rtlCol="0" anchor="t"/>
+          <a:lstStyle/>
+          <a:p>
+            <a:pPr indent="0" marL="0">
+              <a:buNone/>
+            </a:pPr>
+            <a:r>
+              <a:rPr lang="en-US" sz="1200" dirty="0">
+                <a:solidFill>
+                  <a:schemeClr val="tx1"/>
+                </a:solidFill>
+              </a:rPr>
+              <a:t>onboard real festivals, no new code</a:t>
+            </a:r>
+            <a:endParaRPr lang="en-US" sz="1200" dirty="0"/>
+          </a:p>
+        </p:txBody>
+      </p:sp>
+      <p:pic>
+        <p:nvPicPr>
+          <p:cNvPr id="53" name="Daniel Pain icon" descr="Pain">    </p:cNvPr>
+          <p:cNvPicPr>
+            <a:picLocks noChangeAspect="1"/>
+          </p:cNvPicPr>
+          <p:nvPr/>
+        </p:nvPicPr>
+        <p:blipFill>
+          <a:blip r:embed="rId15"/>
+          <a:stretch>
+            <a:fillRect/>
+          </a:stretch>
+        </p:blipFill>
+        <p:spPr>
+          <a:xfrm>
+            <a:off x="6931152" y="2546604"/>
+            <a:ext cx="146304" cy="146304"/>
+          </a:xfrm>
+          <a:prstGeom prst="rect">
+            <a:avLst/>
+          </a:prstGeom>
+        </p:spPr>
+      </p:pic>
+      <p:sp>
+        <p:nvSpPr>
+          <p:cNvPr id="54" name="Daniel Pain label"/>
+          <p:cNvSpPr txBox="1"/>
+          <p:nvPr/>
+        </p:nvSpPr>
+        <p:spPr>
+          <a:xfrm>
+            <a:off x="7150608" y="2523744"/>
+            <a:ext cx="1371600" cy="182880"/>
+          </a:xfrm>
+          <a:prstGeom prst="rect">
+            <a:avLst/>
+          </a:prstGeom>
+          <a:noFill/>
+          <a:ln/>
+        </p:spPr>
+        <p:txBody>
+          <a:bodyPr wrap="square" lIns="0" tIns="0" rIns="0" bIns="0" rtlCol="0" anchor="ctr"/>
+          <a:lstStyle/>
+          <a:p>
+            <a:pPr indent="0" marL="0">
+              <a:buNone/>
+            </a:pPr>
+            <a:r>
+              <a:rPr lang="en-US" sz="1100" b="1" dirty="0">
+                <a:solidFill>
+                  <a:schemeClr val="tx2"/>
+                </a:solidFill>
+              </a:rPr>
+              <a:t>Pain</a:t>
+            </a:r>
+            <a:endParaRPr lang="en-US" sz="1100" dirty="0"/>
+          </a:p>
+        </p:txBody>
+      </p:sp>
+      <p:sp>
+        <p:nvSpPr>
+          <p:cNvPr id="55" name="Daniel Pain"/>
+          <p:cNvSpPr txBox="1"/>
+          <p:nvPr/>
+        </p:nvSpPr>
+        <p:spPr>
+          <a:xfrm>
+            <a:off x="6931152" y="2715768"/>
+            <a:ext cx="1645920" cy="347472"/>
+          </a:xfrm>
+          <a:prstGeom prst="rect">
+            <a:avLst/>
+          </a:prstGeom>
+          <a:noFill/>
+          <a:ln/>
+        </p:spPr>
+        <p:txBody>
+          <a:bodyPr wrap="square" lIns="0" tIns="0" rIns="0" bIns="0" rtlCol="0" anchor="t"/>
+          <a:lstStyle/>
+          <a:p>
+            <a:pPr indent="0" marL="0">
+              <a:buNone/>
+            </a:pPr>
+            <a:r>
+              <a:rPr lang="en-US" sz="1200" dirty="0">
+                <a:solidFill>
+                  <a:schemeClr val="tx1"/>
+                </a:solidFill>
+              </a:rPr>
+              <a:t>fake events; owners change every year</a:t>
+            </a:r>
+            <a:endParaRPr lang="en-US" sz="1200" dirty="0"/>
+          </a:p>
+        </p:txBody>
+      </p:sp>
+      <p:pic>
+        <p:nvPicPr>
+          <p:cNvPr id="56" name="Daniel Success icon" descr="Success">    </p:cNvPr>
+          <p:cNvPicPr>
+            <a:picLocks noChangeAspect="1"/>
+          </p:cNvPicPr>
+          <p:nvPr/>
+        </p:nvPicPr>
+        <p:blipFill>
+          <a:blip r:embed="rId16"/>
+          <a:stretch>
+            <a:fillRect/>
+          </a:stretch>
+        </p:blipFill>
+        <p:spPr>
+          <a:xfrm>
+            <a:off x="6931152" y="3150108"/>
+            <a:ext cx="146304" cy="146304"/>
+          </a:xfrm>
+          <a:prstGeom prst="rect">
+            <a:avLst/>
+          </a:prstGeom>
+        </p:spPr>
+      </p:pic>
+      <p:sp>
+        <p:nvSpPr>
+          <p:cNvPr id="57" name="Daniel Success label"/>
+          <p:cNvSpPr txBox="1"/>
+          <p:nvPr/>
+        </p:nvSpPr>
+        <p:spPr>
+          <a:xfrm>
+            <a:off x="7150608" y="3127248"/>
+            <a:ext cx="1371600" cy="182880"/>
+          </a:xfrm>
+          <a:prstGeom prst="rect">
+            <a:avLst/>
+          </a:prstGeom>
+          <a:noFill/>
+          <a:ln/>
+        </p:spPr>
+        <p:txBody>
+          <a:bodyPr wrap="square" lIns="0" tIns="0" rIns="0" bIns="0" rtlCol="0" anchor="ctr"/>
+          <a:lstStyle/>
+          <a:p>
+            <a:pPr indent="0" marL="0">
+              <a:buNone/>
+            </a:pPr>
+            <a:r>
+              <a:rPr lang="en-US" sz="1100" b="1" dirty="0">
+                <a:solidFill>
+                  <a:schemeClr val="tx2"/>
+                </a:solidFill>
+              </a:rPr>
+              <a:t>Success</a:t>
+            </a:r>
+            <a:endParaRPr lang="en-US" sz="1100" dirty="0"/>
+          </a:p>
+        </p:txBody>
+      </p:sp>
+      <p:sp>
+        <p:nvSpPr>
+          <p:cNvPr id="58" name="Daniel Success"/>
+          <p:cNvSpPr txBox="1"/>
+          <p:nvPr/>
+        </p:nvSpPr>
+        <p:spPr>
+          <a:xfrm>
+            <a:off x="6931152" y="3319272"/>
+            <a:ext cx="1645920" cy="347472"/>
+          </a:xfrm>
+          <a:prstGeom prst="rect">
+            <a:avLst/>
+          </a:prstGeom>
+          <a:noFill/>
+          <a:ln/>
+        </p:spPr>
+        <p:txBody>
+          <a:bodyPr wrap="square" lIns="0" tIns="0" rIns="0" bIns="0" rtlCol="0" anchor="t"/>
+          <a:lstStyle/>
+          <a:p>
+            <a:pPr indent="0" marL="0">
+              <a:buNone/>
+            </a:pPr>
+            <a:r>
+              <a:rPr lang="en-US" sz="1200" dirty="0">
+                <a:solidFill>
+                  <a:schemeClr val="tx1"/>
+                </a:solidFill>
+              </a:rPr>
+              <a:t>new festival live, its data never seen</a:t>
+            </a:r>
+            <a:endParaRPr lang="en-US" sz="1200" dirty="0"/>
+          </a:p>
+        </p:txBody>
+      </p:sp>
+      <p:sp>
+        <p:nvSpPr>
+          <p:cNvPr id="59" name="Validation band"/>
+          <p:cNvSpPr/>
+          <p:nvPr/>
+        </p:nvSpPr>
+        <p:spPr>
+          <a:xfrm>
+            <a:off x="457200" y="3904488"/>
+            <a:ext cx="8229600" cy="868680"/>
+          </a:xfrm>
+          <a:prstGeom prst="roundRect">
+            <a:avLst>
+              <a:gd name="adj" fmla="val 12632"/>
+            </a:avLst>
+          </a:prstGeom>
+          <a:solidFill>
+            <a:schemeClr val="tx2"/>
+          </a:solidFill>
+          <a:ln/>
+        </p:spPr>
+      </p:sp>
+      <p:pic>
+        <p:nvPicPr>
+          <p:cNvPr id="60" name="Proto-personas icon" descr="Proto-personas icon">    </p:cNvPr>
+          <p:cNvPicPr>
+            <a:picLocks noChangeAspect="1"/>
+          </p:cNvPicPr>
+          <p:nvPr/>
+        </p:nvPicPr>
+        <p:blipFill>
+          <a:blip r:embed="rId17"/>
+          <a:stretch>
+            <a:fillRect/>
+          </a:stretch>
+        </p:blipFill>
+        <p:spPr>
+          <a:xfrm>
+            <a:off x="658368" y="4023360"/>
+            <a:ext cx="274320" cy="274320"/>
+          </a:xfrm>
+          <a:prstGeom prst="rect">
+            <a:avLst/>
+          </a:prstGeom>
+        </p:spPr>
+      </p:pic>
+      <p:sp>
+        <p:nvSpPr>
+          <p:cNvPr id="61" name="Proto-personas heading"/>
+          <p:cNvSpPr txBox="1"/>
+          <p:nvPr/>
+        </p:nvSpPr>
+        <p:spPr>
+          <a:xfrm>
+            <a:off x="1024128" y="3995928"/>
+            <a:ext cx="2194560" cy="329184"/>
+          </a:xfrm>
+          <a:prstGeom prst="rect">
+            <a:avLst/>
+          </a:prstGeom>
+          <a:noFill/>
+          <a:ln/>
+        </p:spPr>
+        <p:txBody>
+          <a:bodyPr wrap="square" lIns="0" tIns="0" rIns="0" bIns="0" rtlCol="0" anchor="ctr"/>
+          <a:lstStyle/>
+          <a:p>
+            <a:pPr indent="0" marL="0">
+              <a:buNone/>
+            </a:pPr>
+            <a:r>
+              <a:rPr lang="en-US" sz="1600" b="1" dirty="0">
+                <a:solidFill>
+                  <a:schemeClr val="bg1"/>
+                </a:solidFill>
+              </a:rPr>
+              <a:t>Proto-personas</a:t>
+            </a:r>
+            <a:endParaRPr lang="en-US" sz="1600" dirty="0"/>
+          </a:p>
+        </p:txBody>
+      </p:sp>
+      <p:sp>
+        <p:nvSpPr>
+          <p:cNvPr id="62" name="Proto-personas text"/>
+          <p:cNvSpPr txBox="1"/>
+          <p:nvPr/>
+        </p:nvSpPr>
+        <p:spPr>
+          <a:xfrm>
+            <a:off x="658368" y="4370832"/>
+            <a:ext cx="2514600" cy="329184"/>
+          </a:xfrm>
+          <a:prstGeom prst="rect">
+            <a:avLst/>
+          </a:prstGeom>
+          <a:noFill/>
+          <a:ln/>
+        </p:spPr>
+        <p:txBody>
+          <a:bodyPr wrap="square" lIns="0" tIns="0" rIns="0" bIns="0" rtlCol="0" anchor="t"/>
+          <a:lstStyle/>
+          <a:p>
+            <a:pPr indent="0" marL="0">
+              <a:buNone/>
+            </a:pPr>
+            <a:r>
+              <a:rPr lang="en-US" sz="1050" dirty="0">
+                <a:solidFill>
+                  <a:schemeClr val="bg1"/>
+                </a:solidFill>
+              </a:rPr>
+              <a:t>From the report and public evidence. Names are fictional; no user data yet.</a:t>
+            </a:r>
+            <a:endParaRPr lang="en-US" sz="1050" dirty="0"/>
+          </a:p>
+        </p:txBody>
+      </p:sp>
+      <p:sp>
+        <p:nvSpPr>
+          <p:cNvPr id="63" name="Student survey circle"/>
+          <p:cNvSpPr/>
+          <p:nvPr/>
+        </p:nvSpPr>
+        <p:spPr>
+          <a:xfrm>
+            <a:off x="3337560" y="4142232"/>
+            <a:ext cx="365760" cy="365760"/>
+          </a:xfrm>
+          <a:prstGeom prst="ellipse">
+            <a:avLst/>
+          </a:prstGeom>
+          <a:solidFill>
+            <a:schemeClr val="accent1"/>
+          </a:solidFill>
+          <a:ln/>
+        </p:spPr>
+      </p:sp>
+      <p:pic>
+        <p:nvPicPr>
+          <p:cNvPr id="64" name="Student survey icon" descr="Student survey">    </p:cNvPr>
+          <p:cNvPicPr>
+            <a:picLocks noChangeAspect="1"/>
+          </p:cNvPicPr>
+          <p:nvPr/>
+        </p:nvPicPr>
+        <p:blipFill>
+          <a:blip r:embed="rId18"/>
+          <a:stretch>
+            <a:fillRect/>
+          </a:stretch>
+        </p:blipFill>
+        <p:spPr>
+          <a:xfrm>
+            <a:off x="3419856" y="4224528"/>
+            <a:ext cx="201168" cy="201168"/>
+          </a:xfrm>
+          <a:prstGeom prst="rect">
+            <a:avLst/>
+          </a:prstGeom>
+        </p:spPr>
+      </p:pic>
+      <p:sp>
+        <p:nvSpPr>
+          <p:cNvPr id="65" name="Student survey label"/>
+          <p:cNvSpPr txBox="1"/>
+          <p:nvPr/>
+        </p:nvSpPr>
+        <p:spPr>
+          <a:xfrm>
+            <a:off x="3794760" y="4114800"/>
+            <a:ext cx="1234440" cy="219456"/>
+          </a:xfrm>
+          <a:prstGeom prst="rect">
+            <a:avLst/>
+          </a:prstGeom>
+          <a:noFill/>
+          <a:ln/>
+        </p:spPr>
+        <p:txBody>
+          <a:bodyPr wrap="square" lIns="0" tIns="0" rIns="0" bIns="0" rtlCol="0" anchor="ctr"/>
+          <a:lstStyle/>
+          <a:p>
+            <a:pPr indent="0" marL="0">
+              <a:buNone/>
+            </a:pPr>
+            <a:r>
+              <a:rPr lang="en-US" sz="1200" b="1" dirty="0">
+                <a:solidFill>
+                  <a:schemeClr val="bg1"/>
+                </a:solidFill>
+              </a:rPr>
+              <a:t>Student survey</a:t>
+            </a:r>
+            <a:endParaRPr lang="en-US" sz="1200" dirty="0"/>
+          </a:p>
+        </p:txBody>
+      </p:sp>
+      <p:sp>
+        <p:nvSpPr>
+          <p:cNvPr id="66" name="Student survey target"/>
+          <p:cNvSpPr txBox="1"/>
+          <p:nvPr/>
+        </p:nvSpPr>
+        <p:spPr>
+          <a:xfrm>
+            <a:off x="3794760" y="4334256"/>
+            <a:ext cx="1234440" cy="201168"/>
+          </a:xfrm>
+          <a:prstGeom prst="rect">
+            <a:avLst/>
+          </a:prstGeom>
+          <a:noFill/>
+          <a:ln/>
+        </p:spPr>
+        <p:txBody>
+          <a:bodyPr wrap="square" lIns="0" tIns="0" rIns="0" bIns="0" rtlCol="0" anchor="ctr"/>
+          <a:lstStyle/>
+          <a:p>
+            <a:pPr indent="0" marL="0">
+              <a:buNone/>
+            </a:pPr>
+            <a:r>
+              <a:rPr lang="en-US" sz="1100" dirty="0">
+                <a:solidFill>
+                  <a:schemeClr val="accent1"/>
+                </a:solidFill>
+              </a:rPr>
+              <a:t>validates Rita</a:t>
+            </a:r>
+            <a:endParaRPr lang="en-US" sz="1100" dirty="0"/>
+          </a:p>
+        </p:txBody>
+      </p:sp>
+      <p:sp>
+        <p:nvSpPr>
+          <p:cNvPr id="67" name="Security interview circle"/>
+          <p:cNvSpPr/>
+          <p:nvPr/>
+        </p:nvSpPr>
+        <p:spPr>
+          <a:xfrm>
+            <a:off x="5120640" y="4142232"/>
+            <a:ext cx="365760" cy="365760"/>
+          </a:xfrm>
+          <a:prstGeom prst="ellipse">
+            <a:avLst/>
+          </a:prstGeom>
+          <a:solidFill>
+            <a:schemeClr val="accent1"/>
+          </a:solidFill>
+          <a:ln/>
+        </p:spPr>
+      </p:sp>
+      <p:pic>
+        <p:nvPicPr>
+          <p:cNvPr id="68" name="Security interview icon" descr="Security interview">    </p:cNvPr>
+          <p:cNvPicPr>
+            <a:picLocks noChangeAspect="1"/>
+          </p:cNvPicPr>
+          <p:nvPr/>
+        </p:nvPicPr>
+        <p:blipFill>
+          <a:blip r:embed="rId19"/>
+          <a:stretch>
+            <a:fillRect/>
+          </a:stretch>
+        </p:blipFill>
+        <p:spPr>
+          <a:xfrm>
+            <a:off x="5202936" y="4224528"/>
+            <a:ext cx="201168" cy="201168"/>
+          </a:xfrm>
+          <a:prstGeom prst="rect">
+            <a:avLst/>
+          </a:prstGeom>
+        </p:spPr>
+      </p:pic>
+      <p:sp>
+        <p:nvSpPr>
+          <p:cNvPr id="69" name="Security interview label"/>
+          <p:cNvSpPr txBox="1"/>
+          <p:nvPr/>
+        </p:nvSpPr>
+        <p:spPr>
+          <a:xfrm>
+            <a:off x="5577840" y="4114800"/>
+            <a:ext cx="1234440" cy="219456"/>
+          </a:xfrm>
+          <a:prstGeom prst="rect">
+            <a:avLst/>
+          </a:prstGeom>
+          <a:noFill/>
+          <a:ln/>
+        </p:spPr>
+        <p:txBody>
+          <a:bodyPr wrap="square" lIns="0" tIns="0" rIns="0" bIns="0" rtlCol="0" anchor="ctr"/>
+          <a:lstStyle/>
+          <a:p>
+            <a:pPr indent="0" marL="0">
+              <a:buNone/>
+            </a:pPr>
+            <a:r>
+              <a:rPr lang="en-US" sz="1200" b="1" dirty="0">
+                <a:solidFill>
+                  <a:schemeClr val="bg1"/>
+                </a:solidFill>
+              </a:rPr>
+              <a:t>Security interview</a:t>
+            </a:r>
+            <a:endParaRPr lang="en-US" sz="1200" dirty="0"/>
+          </a:p>
+        </p:txBody>
+      </p:sp>
+      <p:sp>
+        <p:nvSpPr>
+          <p:cNvPr id="70" name="Security interview target"/>
+          <p:cNvSpPr txBox="1"/>
+          <p:nvPr/>
+        </p:nvSpPr>
+        <p:spPr>
+          <a:xfrm>
+            <a:off x="5577840" y="4334256"/>
+            <a:ext cx="1234440" cy="201168"/>
+          </a:xfrm>
+          <a:prstGeom prst="rect">
+            <a:avLst/>
+          </a:prstGeom>
+          <a:noFill/>
+          <a:ln/>
+        </p:spPr>
+        <p:txBody>
+          <a:bodyPr wrap="square" lIns="0" tIns="0" rIns="0" bIns="0" rtlCol="0" anchor="ctr"/>
+          <a:lstStyle/>
+          <a:p>
+            <a:pPr indent="0" marL="0">
+              <a:buNone/>
+            </a:pPr>
+            <a:r>
+              <a:rPr lang="en-US" sz="1100" dirty="0">
+                <a:solidFill>
+                  <a:schemeClr val="accent1"/>
+                </a:solidFill>
+              </a:rPr>
+              <a:t>validates Miguel</a:t>
+            </a:r>
+            <a:endParaRPr lang="en-US" sz="1100" dirty="0"/>
+          </a:p>
+        </p:txBody>
+      </p:sp>
+      <p:sp>
+        <p:nvSpPr>
+          <p:cNvPr id="71" name="Organiser talk circle"/>
+          <p:cNvSpPr/>
+          <p:nvPr/>
+        </p:nvSpPr>
+        <p:spPr>
+          <a:xfrm>
+            <a:off x="6903720" y="4142232"/>
+            <a:ext cx="365760" cy="365760"/>
+          </a:xfrm>
+          <a:prstGeom prst="ellipse">
+            <a:avLst/>
+          </a:prstGeom>
+          <a:solidFill>
+            <a:schemeClr val="accent1"/>
+          </a:solidFill>
+          <a:ln/>
+        </p:spPr>
+      </p:sp>
+      <p:pic>
+        <p:nvPicPr>
+          <p:cNvPr id="72" name="Organiser talk icon" descr="Organiser talk">    </p:cNvPr>
+          <p:cNvPicPr>
+            <a:picLocks noChangeAspect="1"/>
+          </p:cNvPicPr>
+          <p:nvPr/>
+        </p:nvPicPr>
+        <p:blipFill>
+          <a:blip r:embed="rId20"/>
+          <a:stretch>
+            <a:fillRect/>
+          </a:stretch>
+        </p:blipFill>
+        <p:spPr>
+          <a:xfrm>
+            <a:off x="6986016" y="4224528"/>
+            <a:ext cx="201168" cy="201168"/>
+          </a:xfrm>
+          <a:prstGeom prst="rect">
+            <a:avLst/>
+          </a:prstGeom>
+        </p:spPr>
+      </p:pic>
+      <p:sp>
+        <p:nvSpPr>
+          <p:cNvPr id="73" name="Organiser talk label"/>
+          <p:cNvSpPr txBox="1"/>
+          <p:nvPr/>
+        </p:nvSpPr>
+        <p:spPr>
+          <a:xfrm>
+            <a:off x="7360920" y="4114800"/>
+            <a:ext cx="1234440" cy="219456"/>
+          </a:xfrm>
+          <a:prstGeom prst="rect">
+            <a:avLst/>
+          </a:prstGeom>
+          <a:noFill/>
+          <a:ln/>
+        </p:spPr>
+        <p:txBody>
+          <a:bodyPr wrap="square" lIns="0" tIns="0" rIns="0" bIns="0" rtlCol="0" anchor="ctr"/>
+          <a:lstStyle/>
+          <a:p>
+            <a:pPr indent="0" marL="0">
+              <a:buNone/>
+            </a:pPr>
+            <a:r>
+              <a:rPr lang="en-US" sz="1200" b="1" dirty="0">
+                <a:solidFill>
+                  <a:schemeClr val="bg1"/>
+                </a:solidFill>
+              </a:rPr>
+              <a:t>Organiser talk</a:t>
+            </a:r>
+            <a:endParaRPr lang="en-US" sz="1200" dirty="0"/>
+          </a:p>
+        </p:txBody>
+      </p:sp>
+      <p:sp>
+        <p:nvSpPr>
+          <p:cNvPr id="74" name="Organiser talk target"/>
+          <p:cNvSpPr txBox="1"/>
+          <p:nvPr/>
+        </p:nvSpPr>
+        <p:spPr>
+          <a:xfrm>
+            <a:off x="7360920" y="4334256"/>
+            <a:ext cx="1234440" cy="201168"/>
+          </a:xfrm>
+          <a:prstGeom prst="rect">
+            <a:avLst/>
+          </a:prstGeom>
+          <a:noFill/>
+          <a:ln/>
+        </p:spPr>
+        <p:txBody>
+          <a:bodyPr wrap="square" lIns="0" tIns="0" rIns="0" bIns="0" rtlCol="0" anchor="ctr"/>
+          <a:lstStyle/>
+          <a:p>
+            <a:pPr indent="0" marL="0">
+              <a:buNone/>
+            </a:pPr>
+            <a:r>
+              <a:rPr lang="en-US" sz="1100" dirty="0">
+                <a:solidFill>
+                  <a:schemeClr val="accent1"/>
+                </a:solidFill>
+              </a:rPr>
+              <a:t>validates Sofia</a:t>
+            </a:r>
+            <a:endParaRPr lang="en-US" sz="1100" dirty="0"/>
+          </a:p>
+        </p:txBody>
+      </p:sp>
+    </p:spTree>
+  </p:cSld>
+  <p:clrMapOvr>
+    <a:masterClrMapping/>
+  </p:clrMapOvr>
+</p:sld>
+</file>
+
 <file path=ppt/theme/theme1.xml><?xml version="1.0" encoding="utf-8"?>
 <a:theme xmlns:a="http://schemas.openxmlformats.org/drawingml/2006/main" name="Farol">
   <a:themeElements>

</xml_diff>

<commit_message>
docs (#28): Updated presentation
</commit_message>
<xml_diff>
--- a/Docs/Presentation/Farol_First_Presentation.pptx
+++ b/Docs/Presentation/Farol_First_Presentation.pptx
@@ -9,6 +9,7 @@
   </p:notesMasterIdLst>
   <p:sldIdLst>
     <p:sldId id="256" r:id="rId2"/>
+    <p:sldId id="261" r:id="rId12"/>
     <p:sldId id="259" r:id="rId3"/>
     <p:sldId id="257" r:id="rId4"/>
     <p:sldId id="258" r:id="rId5"/>
@@ -114,6 +115,11 @@
         <p14:section name="Cover (Bruno Lopes)" id="{3C1F5A2E-6D4B-4E8A-9B71-2F0C8D9E4A10}">
           <p14:sldIdLst>
             <p14:sldId id="256"/>
+          </p14:sldIdLst>
+        </p14:section>
+        <p14:section name="Product Vision (Tomás Oliveira)" id="{771975C7-DD32-4345-BD10-F5E181073B3C}">
+          <p14:sldIdLst>
+            <p14:sldId id="261"/>
           </p14:sldIdLst>
         </p14:section>
         <p14:section name="Personas (Tiago Teixeira)" id="{7A9E2B44-1C3D-4F6A-8E25-5B0D7C1F9E32}">
@@ -689,6 +695,124 @@
         </p:txBody>
       </p:sp>
     </p:spTree>
+  </p:cSld>
+  <p:clrMapOvr>
+    <a:masterClrMapping/>
+  </p:clrMapOvr>
+</p:notes>
+</file>
+
+<file path=ppt/notesSlides/notesSlide6.xml><?xml version="1.0" encoding="utf-8"?>
+<p:notes xmlns:a="http://schemas.openxmlformats.org/drawingml/2006/main" xmlns:r="http://schemas.openxmlformats.org/officeDocument/2006/relationships" xmlns:p="http://schemas.openxmlformats.org/presentationml/2006/main">
+  <p:cSld>
+    <p:spTree>
+      <p:nvGrpSpPr>
+        <p:cNvPr id="1" name=""/>
+        <p:cNvGrpSpPr/>
+        <p:nvPr/>
+      </p:nvGrpSpPr>
+      <p:grpSpPr>
+        <a:xfrm>
+          <a:off x="0" y="0"/>
+          <a:ext cx="0" cy="0"/>
+          <a:chOff x="0" y="0"/>
+          <a:chExt cx="0" cy="0"/>
+        </a:xfrm>
+      </p:grpSpPr>
+      <p:sp>
+        <p:nvSpPr>
+          <p:cNvPr id="2" name="Slide Image Placeholder 1"/>
+          <p:cNvSpPr>
+            <a:spLocks noGrp="1" noRot="1" noChangeAspect="1"/>
+          </p:cNvSpPr>
+          <p:nvPr>
+            <p:ph type="sldImg"/>
+          </p:nvPr>
+        </p:nvSpPr>
+        <p:spPr/>
+      </p:sp>
+      <p:sp>
+        <p:nvSpPr>
+          <p:cNvPr id="3" name="Notes Placeholder 2"/>
+          <p:cNvSpPr>
+            <a:spLocks noGrp="1"/>
+          </p:cNvSpPr>
+          <p:nvPr>
+            <p:ph type="body" idx="1"/>
+          </p:nvPr>
+        </p:nvSpPr>
+        <p:spPr/>
+        <p:txBody>
+          <a:bodyPr/>
+          <a:lstStyle/>
+          <a:p>
+            <a:r>
+              <a:t>A visao do Farol liga os participantes e a equipa do evento atraves de informacao fiavel e pedidos de ajuda com contexto e localizacao. Os estudantes acedem por link ou QR, escolhem o evento e encontram a planta, informacao essencial e transportes. A equipa configura o evento, mantem a informacao atualizada, avalia prioridades e encaminha pedidos para a equipa operacional adequada.</a:t>
+            </a:r>
+          </a:p>
+          <a:p>
+            <a:endParaRPr/>
+          </a:p>
+          <a:p>
+            <a:r>
+              <a:t>O MVP inclui a aplicacao web para participantes e o backoffice de cada equipa. O sucesso deve ser avaliado pelo tempo de acesso a informacao, pela facilidade de submeter e gerir pedidos, pela resposta operacional, pela adocao e pelo feedback. A visao ainda nao fixa metas numericas.</a:t>
+            </a:r>
+          </a:p>
+          <a:p>
+            <a:endParaRPr/>
+          </a:p>
+          <a:p>
+            <a:r>
+              <a:t>Integracoes pesadas, previsao avancada de multidoes e automacao completa ficam fora da primeira versao, salvo necessidade de validacao. A capacidade fisica das entradas fica fora do ambito.</a:t>
+            </a:r>
+          </a:p>
+          <a:p>
+            <a:endParaRPr/>
+          </a:p>
+          <a:p>
+            <a:r>
+              <a:t>Fonte: /Users/tomasoliveira21/Desktop/ISEP/2627/LABDSOF/Docs/Deliverables/problem-opportunity-report-queima.md, seccao "Visao de produto" (Personas, Proposta de valor, Principais jornadas do utilizador, Criterios de sucesso e Definicao do MVP).</a:t>
+            </a:r>
+          </a:p>
+          <a:p>
+            <a:endParaRPr/>
+          </a:p>
+          <a:p>
+            <a:r>
+              <a:t>Identidade visual: logotipo original da apresentacao fornecida.</a:t>
+            </a:r>
+          </a:p>
+        </p:txBody>
+      </p:sp>
+      <p:sp>
+        <p:nvSpPr>
+          <p:cNvPr id="4" name="Slide Number Placeholder 3"/>
+          <p:cNvSpPr>
+            <a:spLocks noGrp="1"/>
+          </p:cNvSpPr>
+          <p:nvPr>
+            <p:ph type="sldNum" sz="quarter" idx="10"/>
+          </p:nvPr>
+        </p:nvSpPr>
+        <p:spPr/>
+        <p:txBody>
+          <a:bodyPr/>
+          <a:lstStyle/>
+          <a:p>
+            <a:fld id="{F7021451-1387-4CA6-816F-3879F97B5CBC}" type="slidenum">
+              <a:rPr lang="en-US"/>
+              <a:t>2</a:t>
+            </a:fld>
+            <a:endParaRPr lang="en-US"/>
+          </a:p>
+        </p:txBody>
+      </p:sp>
+    </p:spTree>
+    <p:extLst>
+      <p:ext uri="{BB962C8B-B14F-4D97-AF65-F5344CB8AC3E}">
+        <p14:creationId xmlns:p14="http://schemas.microsoft.com/office/powerpoint/2010/main" val="1024086991"/>
+      </p:ext>
+    </p:extLst>
   </p:cSld>
   <p:clrMapOvr>
     <a:masterClrMapping/>
@@ -7776,6 +7900,956 @@
               <a:t>AI only suggests, the operator decides · unconfirmed reports expire and earn nothing · no badges for help requests</a:t>
             </a:r>
             <a:endParaRPr lang="en-US" sz="1200" dirty="0"/>
+          </a:p>
+        </p:txBody>
+      </p:sp>
+    </p:spTree>
+  </p:cSld>
+  <p:clrMapOvr>
+    <a:masterClrMapping/>
+  </p:clrMapOvr>
+</p:sld>
+</file>
+
+<file path=ppt/slides/slide6.xml><?xml version="1.0" encoding="utf-8"?>
+<p:sld xmlns:a="http://schemas.openxmlformats.org/drawingml/2006/main" xmlns:r="http://schemas.openxmlformats.org/officeDocument/2006/relationships" xmlns:p="http://schemas.openxmlformats.org/presentationml/2006/main">
+  <p:cSld name="Slide 2">
+    <p:spTree>
+      <p:nvGrpSpPr>
+        <p:cNvPr id="1" name=""/>
+        <p:cNvGrpSpPr/>
+        <p:nvPr/>
+      </p:nvGrpSpPr>
+      <p:grpSpPr>
+        <a:xfrm>
+          <a:off x="0" y="0"/>
+          <a:ext cx="0" cy="0"/>
+          <a:chOff x="0" y="0"/>
+          <a:chExt cx="0" cy="0"/>
+        </a:xfrm>
+      </p:grpSpPr>
+      <p:sp>
+        <p:nvSpPr>
+          <p:cNvPr id="4" name="Rita card">
+            <a:extLst>
+              <a:ext uri="{FF2B5EF4-FFF2-40B4-BE49-F238E27FC236}">
+                <a16:creationId xmlns:a16="http://schemas.microsoft.com/office/drawing/2014/main" id="{DE3F91AE-EEF0-4B77-F796-372EBD91B7DF}"/>
+              </a:ext>
+            </a:extLst>
+          </p:cNvPr>
+          <p:cNvSpPr/>
+          <p:nvPr/>
+        </p:nvSpPr>
+        <p:spPr>
+          <a:xfrm>
+            <a:off x="368693" y="3433761"/>
+            <a:ext cx="8387563" cy="1319448"/>
+          </a:xfrm>
+          <a:prstGeom prst="roundRect">
+            <a:avLst>
+              <a:gd name="adj" fmla="val 5714"/>
+            </a:avLst>
+          </a:prstGeom>
+          <a:solidFill>
+            <a:schemeClr val="tx2"/>
+          </a:solidFill>
+          <a:ln/>
+        </p:spPr>
+        <p:txBody>
+          <a:bodyPr/>
+          <a:lstStyle/>
+          <a:p>
+            <a:endParaRPr lang="en-PT" dirty="0">
+              <a:solidFill>
+                <a:schemeClr val="bg1"/>
+              </a:solidFill>
+            </a:endParaRPr>
+          </a:p>
+        </p:txBody>
+      </p:sp>
+      <p:sp>
+        <p:nvSpPr>
+          <p:cNvPr id="3" name="Rita card">
+            <a:extLst>
+              <a:ext uri="{FF2B5EF4-FFF2-40B4-BE49-F238E27FC236}">
+                <a16:creationId xmlns:a16="http://schemas.microsoft.com/office/drawing/2014/main" id="{30711021-712A-717F-2C45-15DE97DD91DD}"/>
+              </a:ext>
+            </a:extLst>
+          </p:cNvPr>
+          <p:cNvSpPr/>
+          <p:nvPr/>
+        </p:nvSpPr>
+        <p:spPr>
+          <a:xfrm>
+            <a:off x="4731143" y="1938337"/>
+            <a:ext cx="4025113" cy="1238250"/>
+          </a:xfrm>
+          <a:prstGeom prst="roundRect">
+            <a:avLst>
+              <a:gd name="adj" fmla="val 5714"/>
+            </a:avLst>
+          </a:prstGeom>
+          <a:solidFill>
+            <a:schemeClr val="bg2"/>
+          </a:solidFill>
+          <a:ln/>
+        </p:spPr>
+        <p:txBody>
+          <a:bodyPr/>
+          <a:lstStyle/>
+          <a:p>
+            <a:endParaRPr lang="en-PT"/>
+          </a:p>
+        </p:txBody>
+      </p:sp>
+      <p:sp>
+        <p:nvSpPr>
+          <p:cNvPr id="2" name="Rita card">
+            <a:extLst>
+              <a:ext uri="{FF2B5EF4-FFF2-40B4-BE49-F238E27FC236}">
+                <a16:creationId xmlns:a16="http://schemas.microsoft.com/office/drawing/2014/main" id="{0FDC3C32-5582-6860-15BE-D9F57C237ACD}"/>
+              </a:ext>
+            </a:extLst>
+          </p:cNvPr>
+          <p:cNvSpPr/>
+          <p:nvPr/>
+        </p:nvSpPr>
+        <p:spPr>
+          <a:xfrm>
+            <a:off x="368693" y="1938337"/>
+            <a:ext cx="4025113" cy="1238250"/>
+          </a:xfrm>
+          <a:prstGeom prst="roundRect">
+            <a:avLst>
+              <a:gd name="adj" fmla="val 5714"/>
+            </a:avLst>
+          </a:prstGeom>
+          <a:solidFill>
+            <a:schemeClr val="bg2"/>
+          </a:solidFill>
+          <a:ln/>
+        </p:spPr>
+        <p:txBody>
+          <a:bodyPr/>
+          <a:lstStyle/>
+          <a:p>
+            <a:endParaRPr lang="en-PT"/>
+          </a:p>
+        </p:txBody>
+      </p:sp>
+      <p:sp>
+        <p:nvSpPr>
+          <p:cNvPr id="46" name="Title 45">
+            <a:extLst>
+              <a:ext uri="{FF2B5EF4-FFF2-40B4-BE49-F238E27FC236}">
+                <a16:creationId xmlns:a16="http://schemas.microsoft.com/office/drawing/2014/main" id="{D35B6AAC-B8F8-6D43-4F74-381A49A405D9}"/>
+              </a:ext>
+            </a:extLst>
+          </p:cNvPr>
+          <p:cNvSpPr>
+            <a:spLocks noGrp="1"/>
+          </p:cNvSpPr>
+          <p:nvPr>
+            <p:ph type="title" idx="100"/>
+          </p:nvPr>
+        </p:nvSpPr>
+        <p:spPr>
+          <a:xfrm>
+            <a:off x="457200" y="274320"/>
+            <a:ext cx="8229600" cy="640080"/>
+          </a:xfrm>
+        </p:spPr>
+        <p:txBody>
+          <a:bodyPr lIns="0" tIns="0" rIns="0" bIns="0" anchor="ctr">
+            <a:noAutofit/>
+          </a:bodyPr>
+          <a:lstStyle>
+            <a:defPPr algn="ctr">
+              <a:defRPr sz="3200" b="1">
+                <a:solidFill>
+                  <a:srgbClr val="0B1F3A"/>
+                </a:solidFill>
+                <a:latin typeface="Calibri"/>
+                <a:ea typeface="Calibri"/>
+                <a:cs typeface="Calibri"/>
+              </a:defRPr>
+            </a:defPPr>
+          </a:lstStyle>
+          <a:p>
+            <a:pPr algn="ctr">
+              <a:defRPr sz="3200" b="1">
+                <a:solidFill>
+                  <a:srgbClr val="0B1F3A"/>
+                </a:solidFill>
+                <a:latin typeface="Calibri"/>
+                <a:ea typeface="Calibri"/>
+                <a:cs typeface="Calibri"/>
+              </a:defRPr>
+            </a:pPr>
+            <a:r>
+              <a:rPr sz="3200" b="1">
+                <a:solidFill>
+                  <a:srgbClr val="0B1F3A"/>
+                </a:solidFill>
+                <a:latin typeface="Calibri"/>
+                <a:ea typeface="Calibri"/>
+                <a:cs typeface="Calibri"/>
+              </a:rPr>
+              <a:t>Product vision</a:t>
+            </a:r>
+            <a:endParaRPr/>
+          </a:p>
+        </p:txBody>
+      </p:sp>
+      <p:pic>
+        <p:nvPicPr>
+          <p:cNvPr id="47" name="Picture 46">
+            <a:extLst>
+              <a:ext uri="{FF2B5EF4-FFF2-40B4-BE49-F238E27FC236}">
+                <a16:creationId xmlns:a16="http://schemas.microsoft.com/office/drawing/2014/main" id="{2165DBDE-5B3C-471C-9703-4CC44BBC29BB}"/>
+              </a:ext>
+            </a:extLst>
+          </p:cNvPr>
+          <p:cNvPicPr>
+            <a:picLocks noChangeAspect="1"/>
+          </p:cNvPicPr>
+          <p:nvPr/>
+        </p:nvPicPr>
+        <p:blipFill>
+          <a:blip r:embed="rId3"/>
+          <a:stretch/>
+        </p:blipFill>
+        <p:spPr>
+          <a:xfrm>
+            <a:off x="657225" y="900113"/>
+            <a:ext cx="952500" cy="952500"/>
+          </a:xfrm>
+          <a:prstGeom prst="rect">
+            <a:avLst/>
+          </a:prstGeom>
+        </p:spPr>
+      </p:pic>
+      <p:sp>
+        <p:nvSpPr>
+          <p:cNvPr id="48" name="Vision statement">
+            <a:extLst>
+              <a:ext uri="{FF2B5EF4-FFF2-40B4-BE49-F238E27FC236}">
+                <a16:creationId xmlns:a16="http://schemas.microsoft.com/office/drawing/2014/main" id="{BD580D43-FE42-4BF9-83F1-89CD57D05A09}"/>
+              </a:ext>
+            </a:extLst>
+          </p:cNvPr>
+          <p:cNvSpPr>
+            <a:spLocks noGrp="1"/>
+          </p:cNvSpPr>
+          <p:nvPr/>
+        </p:nvSpPr>
+        <p:spPr>
+          <a:xfrm>
+            <a:off x="1914525" y="914400"/>
+            <a:ext cx="6572250" cy="876300"/>
+          </a:xfrm>
+          <a:prstGeom prst="rect">
+            <a:avLst/>
+          </a:prstGeom>
+          <a:noFill/>
+          <a:ln w="0">
+            <a:noFill/>
+          </a:ln>
+        </p:spPr>
+        <p:txBody>
+          <a:bodyPr wrap="square" lIns="0" tIns="0" rIns="0" bIns="0" anchor="t">
+            <a:noAutofit/>
+          </a:bodyPr>
+          <a:lstStyle>
+            <a:defPPr algn="l">
+              <a:defRPr sz="2500" b="1">
+                <a:solidFill>
+                  <a:srgbClr val="0B1F3A"/>
+                </a:solidFill>
+                <a:latin typeface="Calibri"/>
+                <a:ea typeface="Calibri"/>
+                <a:cs typeface="Calibri"/>
+              </a:defRPr>
+            </a:defPPr>
+          </a:lstStyle>
+          <a:p>
+            <a:pPr algn="l">
+              <a:defRPr sz="2500" b="1">
+                <a:solidFill>
+                  <a:srgbClr val="0B1F3A"/>
+                </a:solidFill>
+                <a:latin typeface="Calibri"/>
+                <a:ea typeface="Calibri"/>
+                <a:cs typeface="Calibri"/>
+              </a:defRPr>
+            </a:pPr>
+            <a:r>
+              <a:rPr sz="2500" b="1" dirty="0">
+                <a:solidFill>
+                  <a:srgbClr val="0B1F3A"/>
+                </a:solidFill>
+                <a:latin typeface="Calibri"/>
+                <a:ea typeface="Calibri"/>
+                <a:cs typeface="Calibri"/>
+              </a:rPr>
+              <a:t>Reliable event information</a:t>
+            </a:r>
+            <a:r>
+              <a:rPr lang="pt-PT" sz="2500" b="1" dirty="0">
+                <a:solidFill>
+                  <a:srgbClr val="0B1F3A"/>
+                </a:solidFill>
+                <a:latin typeface="Calibri"/>
+                <a:ea typeface="Calibri"/>
+                <a:cs typeface="Calibri"/>
+              </a:rPr>
+              <a:t> </a:t>
+            </a:r>
+            <a:r>
+              <a:rPr sz="2500" b="1" dirty="0">
+                <a:solidFill>
+                  <a:srgbClr val="0B1F3A"/>
+                </a:solidFill>
+                <a:latin typeface="Calibri"/>
+                <a:ea typeface="Calibri"/>
+                <a:cs typeface="Calibri"/>
+              </a:rPr>
+              <a:t>and coordinated help</a:t>
+            </a:r>
+          </a:p>
+        </p:txBody>
+      </p:sp>
+      <p:sp>
+        <p:nvSpPr>
+          <p:cNvPr id="49" name="Vision audience">
+            <a:extLst>
+              <a:ext uri="{FF2B5EF4-FFF2-40B4-BE49-F238E27FC236}">
+                <a16:creationId xmlns:a16="http://schemas.microsoft.com/office/drawing/2014/main" id="{9DF1A56B-71E1-4DA3-8CB2-715A03FFF714}"/>
+              </a:ext>
+            </a:extLst>
+          </p:cNvPr>
+          <p:cNvSpPr>
+            <a:spLocks noGrp="1"/>
+          </p:cNvSpPr>
+          <p:nvPr/>
+        </p:nvSpPr>
+        <p:spPr>
+          <a:xfrm>
+            <a:off x="1919288" y="1395413"/>
+            <a:ext cx="6667500" cy="285750"/>
+          </a:xfrm>
+          <a:prstGeom prst="rect">
+            <a:avLst/>
+          </a:prstGeom>
+          <a:noFill/>
+          <a:ln w="0">
+            <a:noFill/>
+          </a:ln>
+        </p:spPr>
+        <p:txBody>
+          <a:bodyPr wrap="square" lIns="0" tIns="0" rIns="0" bIns="0" anchor="t">
+            <a:noAutofit/>
+          </a:bodyPr>
+          <a:lstStyle>
+            <a:defPPr algn="l">
+              <a:defRPr sz="1500">
+                <a:solidFill>
+                  <a:srgbClr val="1F4E79"/>
+                </a:solidFill>
+                <a:latin typeface="Calibri"/>
+                <a:ea typeface="Calibri"/>
+                <a:cs typeface="Calibri"/>
+              </a:defRPr>
+            </a:defPPr>
+          </a:lstStyle>
+          <a:p>
+            <a:pPr algn="l">
+              <a:defRPr sz="1500">
+                <a:solidFill>
+                  <a:srgbClr val="1F4E79"/>
+                </a:solidFill>
+                <a:latin typeface="Calibri"/>
+                <a:ea typeface="Calibri"/>
+                <a:cs typeface="Calibri"/>
+              </a:defRPr>
+            </a:pPr>
+            <a:r>
+              <a:rPr sz="1500" dirty="0">
+                <a:solidFill>
+                  <a:srgbClr val="1F4E79"/>
+                </a:solidFill>
+                <a:latin typeface="Calibri"/>
+                <a:ea typeface="Calibri"/>
+                <a:cs typeface="Calibri"/>
+              </a:rPr>
+              <a:t>A shared platform for participants and event teams</a:t>
+            </a:r>
+          </a:p>
+        </p:txBody>
+      </p:sp>
+      <p:sp>
+        <p:nvSpPr>
+          <p:cNvPr id="50" name="Participants heading">
+            <a:extLst>
+              <a:ext uri="{FF2B5EF4-FFF2-40B4-BE49-F238E27FC236}">
+                <a16:creationId xmlns:a16="http://schemas.microsoft.com/office/drawing/2014/main" id="{72DAA3F8-A99E-4817-B74D-445363117F11}"/>
+              </a:ext>
+            </a:extLst>
+          </p:cNvPr>
+          <p:cNvSpPr>
+            <a:spLocks noGrp="1"/>
+          </p:cNvSpPr>
+          <p:nvPr/>
+        </p:nvSpPr>
+        <p:spPr>
+          <a:xfrm>
+            <a:off x="457200" y="2052637"/>
+            <a:ext cx="3857625" cy="285750"/>
+          </a:xfrm>
+          <a:prstGeom prst="rect">
+            <a:avLst/>
+          </a:prstGeom>
+          <a:noFill/>
+          <a:ln w="0">
+            <a:noFill/>
+          </a:ln>
+        </p:spPr>
+        <p:txBody>
+          <a:bodyPr wrap="square" lIns="0" tIns="0" rIns="0" bIns="0" anchor="t">
+            <a:noAutofit/>
+          </a:bodyPr>
+          <a:lstStyle>
+            <a:defPPr algn="l">
+              <a:defRPr sz="1700" b="1">
+                <a:solidFill>
+                  <a:srgbClr val="1F4E79"/>
+                </a:solidFill>
+                <a:latin typeface="Calibri"/>
+                <a:ea typeface="Calibri"/>
+                <a:cs typeface="Calibri"/>
+              </a:defRPr>
+            </a:defPPr>
+          </a:lstStyle>
+          <a:p>
+            <a:pPr algn="l">
+              <a:defRPr sz="1700" b="1">
+                <a:solidFill>
+                  <a:srgbClr val="1F4E79"/>
+                </a:solidFill>
+                <a:latin typeface="Calibri"/>
+                <a:ea typeface="Calibri"/>
+                <a:cs typeface="Calibri"/>
+              </a:defRPr>
+            </a:pPr>
+            <a:r>
+              <a:rPr sz="1700" b="1" dirty="0">
+                <a:solidFill>
+                  <a:srgbClr val="1F4E79"/>
+                </a:solidFill>
+                <a:latin typeface="Calibri"/>
+                <a:ea typeface="Calibri"/>
+                <a:cs typeface="Calibri"/>
+              </a:rPr>
+              <a:t>For participants</a:t>
+            </a:r>
+          </a:p>
+        </p:txBody>
+      </p:sp>
+      <p:sp>
+        <p:nvSpPr>
+          <p:cNvPr id="51" name="Participants journey">
+            <a:extLst>
+              <a:ext uri="{FF2B5EF4-FFF2-40B4-BE49-F238E27FC236}">
+                <a16:creationId xmlns:a16="http://schemas.microsoft.com/office/drawing/2014/main" id="{FDD69BD9-71D1-41AC-8425-813E9BD26FD3}"/>
+              </a:ext>
+            </a:extLst>
+          </p:cNvPr>
+          <p:cNvSpPr>
+            <a:spLocks noGrp="1"/>
+          </p:cNvSpPr>
+          <p:nvPr/>
+        </p:nvSpPr>
+        <p:spPr>
+          <a:xfrm>
+            <a:off x="457200" y="2386012"/>
+            <a:ext cx="3848100" cy="781050"/>
+          </a:xfrm>
+          <a:prstGeom prst="rect">
+            <a:avLst/>
+          </a:prstGeom>
+          <a:noFill/>
+          <a:ln w="0">
+            <a:noFill/>
+          </a:ln>
+        </p:spPr>
+        <p:txBody>
+          <a:bodyPr wrap="square" lIns="0" tIns="0" rIns="0" bIns="0" anchor="t">
+            <a:noAutofit/>
+          </a:bodyPr>
+          <a:lstStyle>
+            <a:defPPr algn="l">
+              <a:defRPr sz="1500">
+                <a:solidFill>
+                  <a:srgbClr val="1B2430"/>
+                </a:solidFill>
+                <a:latin typeface="Calibri"/>
+                <a:ea typeface="Calibri"/>
+                <a:cs typeface="Calibri"/>
+              </a:defRPr>
+            </a:defPPr>
+          </a:lstStyle>
+          <a:p>
+            <a:pPr algn="l">
+              <a:defRPr sz="1500">
+                <a:solidFill>
+                  <a:srgbClr val="1B2430"/>
+                </a:solidFill>
+                <a:latin typeface="Calibri"/>
+                <a:ea typeface="Calibri"/>
+                <a:cs typeface="Calibri"/>
+              </a:defRPr>
+            </a:pPr>
+            <a:r>
+              <a:rPr sz="1500" dirty="0">
+                <a:solidFill>
+                  <a:srgbClr val="1B2430"/>
+                </a:solidFill>
+                <a:latin typeface="Calibri"/>
+                <a:ea typeface="Calibri"/>
+                <a:cs typeface="Calibri"/>
+              </a:rPr>
+              <a:t>Open by link or QR. Find the map and transport options, then request help with context and location.</a:t>
+            </a:r>
+          </a:p>
+        </p:txBody>
+      </p:sp>
+      <p:sp>
+        <p:nvSpPr>
+          <p:cNvPr id="52" name="Event team heading">
+            <a:extLst>
+              <a:ext uri="{FF2B5EF4-FFF2-40B4-BE49-F238E27FC236}">
+                <a16:creationId xmlns:a16="http://schemas.microsoft.com/office/drawing/2014/main" id="{EA37A2C6-44B2-4F7C-B5CD-57F6307C62E2}"/>
+              </a:ext>
+            </a:extLst>
+          </p:cNvPr>
+          <p:cNvSpPr>
+            <a:spLocks noGrp="1"/>
+          </p:cNvSpPr>
+          <p:nvPr/>
+        </p:nvSpPr>
+        <p:spPr>
+          <a:xfrm>
+            <a:off x="4800600" y="2071687"/>
+            <a:ext cx="3886200" cy="285750"/>
+          </a:xfrm>
+          <a:prstGeom prst="rect">
+            <a:avLst/>
+          </a:prstGeom>
+          <a:noFill/>
+          <a:ln w="0">
+            <a:noFill/>
+          </a:ln>
+        </p:spPr>
+        <p:txBody>
+          <a:bodyPr wrap="square" lIns="0" tIns="0" rIns="0" bIns="0" anchor="t">
+            <a:noAutofit/>
+          </a:bodyPr>
+          <a:lstStyle>
+            <a:defPPr algn="l">
+              <a:defRPr sz="1700" b="1">
+                <a:solidFill>
+                  <a:srgbClr val="1F4E79"/>
+                </a:solidFill>
+                <a:latin typeface="Calibri"/>
+                <a:ea typeface="Calibri"/>
+                <a:cs typeface="Calibri"/>
+              </a:defRPr>
+            </a:defPPr>
+          </a:lstStyle>
+          <a:p>
+            <a:pPr algn="l">
+              <a:defRPr sz="1700" b="1">
+                <a:solidFill>
+                  <a:srgbClr val="1F4E79"/>
+                </a:solidFill>
+                <a:latin typeface="Calibri"/>
+                <a:ea typeface="Calibri"/>
+                <a:cs typeface="Calibri"/>
+              </a:defRPr>
+            </a:pPr>
+            <a:r>
+              <a:rPr sz="1700" b="1">
+                <a:solidFill>
+                  <a:srgbClr val="1F4E79"/>
+                </a:solidFill>
+                <a:latin typeface="Calibri"/>
+                <a:ea typeface="Calibri"/>
+                <a:cs typeface="Calibri"/>
+              </a:rPr>
+              <a:t>For the event team</a:t>
+            </a:r>
+          </a:p>
+        </p:txBody>
+      </p:sp>
+      <p:sp>
+        <p:nvSpPr>
+          <p:cNvPr id="53" name="Event team journey">
+            <a:extLst>
+              <a:ext uri="{FF2B5EF4-FFF2-40B4-BE49-F238E27FC236}">
+                <a16:creationId xmlns:a16="http://schemas.microsoft.com/office/drawing/2014/main" id="{C93A605C-E103-414A-A0FC-CFFB4FECDB34}"/>
+              </a:ext>
+            </a:extLst>
+          </p:cNvPr>
+          <p:cNvSpPr>
+            <a:spLocks noGrp="1"/>
+          </p:cNvSpPr>
+          <p:nvPr/>
+        </p:nvSpPr>
+        <p:spPr>
+          <a:xfrm>
+            <a:off x="4800600" y="2405062"/>
+            <a:ext cx="3886200" cy="781050"/>
+          </a:xfrm>
+          <a:prstGeom prst="rect">
+            <a:avLst/>
+          </a:prstGeom>
+          <a:noFill/>
+          <a:ln w="0">
+            <a:noFill/>
+          </a:ln>
+        </p:spPr>
+        <p:txBody>
+          <a:bodyPr wrap="square" lIns="0" tIns="0" rIns="0" bIns="0" anchor="t">
+            <a:noAutofit/>
+          </a:bodyPr>
+          <a:lstStyle>
+            <a:defPPr algn="l">
+              <a:defRPr sz="1500">
+                <a:solidFill>
+                  <a:srgbClr val="1B2430"/>
+                </a:solidFill>
+                <a:latin typeface="Calibri"/>
+                <a:ea typeface="Calibri"/>
+                <a:cs typeface="Calibri"/>
+              </a:defRPr>
+            </a:defPPr>
+          </a:lstStyle>
+          <a:p>
+            <a:pPr algn="l">
+              <a:defRPr sz="1500">
+                <a:solidFill>
+                  <a:srgbClr val="1B2430"/>
+                </a:solidFill>
+                <a:latin typeface="Calibri"/>
+                <a:ea typeface="Calibri"/>
+                <a:cs typeface="Calibri"/>
+              </a:defRPr>
+            </a:pPr>
+            <a:r>
+              <a:rPr sz="1500">
+                <a:solidFill>
+                  <a:srgbClr val="1B2430"/>
+                </a:solidFill>
+                <a:latin typeface="Calibri"/>
+                <a:ea typeface="Calibri"/>
+                <a:cs typeface="Calibri"/>
+              </a:rPr>
+              <a:t>Configure the event and update information. Prioritise each request and route it to the right team.</a:t>
+            </a:r>
+          </a:p>
+        </p:txBody>
+      </p:sp>
+      <p:sp>
+        <p:nvSpPr>
+          <p:cNvPr id="54" name="MVP heading">
+            <a:extLst>
+              <a:ext uri="{FF2B5EF4-FFF2-40B4-BE49-F238E27FC236}">
+                <a16:creationId xmlns:a16="http://schemas.microsoft.com/office/drawing/2014/main" id="{FD4759BC-83D1-4166-BC0D-9B2F91CAF75B}"/>
+              </a:ext>
+            </a:extLst>
+          </p:cNvPr>
+          <p:cNvSpPr>
+            <a:spLocks noGrp="1"/>
+          </p:cNvSpPr>
+          <p:nvPr/>
+        </p:nvSpPr>
+        <p:spPr>
+          <a:xfrm>
+            <a:off x="457200" y="3614736"/>
+            <a:ext cx="1352550" cy="285750"/>
+          </a:xfrm>
+          <a:prstGeom prst="rect">
+            <a:avLst/>
+          </a:prstGeom>
+          <a:noFill/>
+          <a:ln w="0">
+            <a:noFill/>
+          </a:ln>
+        </p:spPr>
+        <p:txBody>
+          <a:bodyPr wrap="square" lIns="0" tIns="0" rIns="0" bIns="0" anchor="t">
+            <a:noAutofit/>
+          </a:bodyPr>
+          <a:lstStyle>
+            <a:defPPr algn="l">
+              <a:defRPr sz="1500" b="1">
+                <a:solidFill>
+                  <a:srgbClr val="0B1F3A"/>
+                </a:solidFill>
+                <a:latin typeface="Calibri"/>
+                <a:ea typeface="Calibri"/>
+                <a:cs typeface="Calibri"/>
+              </a:defRPr>
+            </a:defPPr>
+          </a:lstStyle>
+          <a:p>
+            <a:pPr algn="l">
+              <a:defRPr sz="1500" b="1">
+                <a:solidFill>
+                  <a:srgbClr val="0B1F3A"/>
+                </a:solidFill>
+                <a:latin typeface="Calibri"/>
+                <a:ea typeface="Calibri"/>
+                <a:cs typeface="Calibri"/>
+              </a:defRPr>
+            </a:pPr>
+            <a:r>
+              <a:rPr sz="1500" b="1" dirty="0">
+                <a:solidFill>
+                  <a:schemeClr val="accent1"/>
+                </a:solidFill>
+                <a:latin typeface="Calibri"/>
+                <a:ea typeface="Calibri"/>
+                <a:cs typeface="Calibri"/>
+              </a:rPr>
+              <a:t>MVP</a:t>
+            </a:r>
+          </a:p>
+        </p:txBody>
+      </p:sp>
+      <p:sp>
+        <p:nvSpPr>
+          <p:cNvPr id="55" name="MVP scope">
+            <a:extLst>
+              <a:ext uri="{FF2B5EF4-FFF2-40B4-BE49-F238E27FC236}">
+                <a16:creationId xmlns:a16="http://schemas.microsoft.com/office/drawing/2014/main" id="{EE15BBC2-61C5-47DC-90AD-58954614B58C}"/>
+              </a:ext>
+            </a:extLst>
+          </p:cNvPr>
+          <p:cNvSpPr>
+            <a:spLocks noGrp="1"/>
+          </p:cNvSpPr>
+          <p:nvPr/>
+        </p:nvSpPr>
+        <p:spPr>
+          <a:xfrm>
+            <a:off x="1914525" y="3614736"/>
+            <a:ext cx="6772275" cy="457200"/>
+          </a:xfrm>
+          <a:prstGeom prst="rect">
+            <a:avLst/>
+          </a:prstGeom>
+          <a:noFill/>
+          <a:ln w="0">
+            <a:noFill/>
+          </a:ln>
+        </p:spPr>
+        <p:txBody>
+          <a:bodyPr wrap="square" lIns="0" tIns="0" rIns="0" bIns="0" anchor="t">
+            <a:noAutofit/>
+          </a:bodyPr>
+          <a:lstStyle>
+            <a:defPPr algn="l">
+              <a:defRPr sz="1300">
+                <a:solidFill>
+                  <a:srgbClr val="1B2430"/>
+                </a:solidFill>
+                <a:latin typeface="Calibri"/>
+                <a:ea typeface="Calibri"/>
+                <a:cs typeface="Calibri"/>
+              </a:defRPr>
+            </a:defPPr>
+          </a:lstStyle>
+          <a:p>
+            <a:pPr algn="l">
+              <a:defRPr sz="1300">
+                <a:solidFill>
+                  <a:srgbClr val="1B2430"/>
+                </a:solidFill>
+                <a:latin typeface="Calibri"/>
+                <a:ea typeface="Calibri"/>
+                <a:cs typeface="Calibri"/>
+              </a:defRPr>
+            </a:pPr>
+            <a:r>
+              <a:rPr sz="1300" dirty="0">
+                <a:solidFill>
+                  <a:schemeClr val="bg1"/>
+                </a:solidFill>
+                <a:latin typeface="Calibri"/>
+                <a:ea typeface="Calibri"/>
+                <a:cs typeface="Calibri"/>
+              </a:rPr>
+              <a:t>Event selection, venue map, essential information, transport and help requests, with an event </a:t>
+            </a:r>
+            <a:r>
+              <a:rPr sz="1300" dirty="0" err="1">
+                <a:solidFill>
+                  <a:schemeClr val="bg1"/>
+                </a:solidFill>
+                <a:latin typeface="Calibri"/>
+                <a:ea typeface="Calibri"/>
+                <a:cs typeface="Calibri"/>
+              </a:rPr>
+              <a:t>backoffice</a:t>
+            </a:r>
+            <a:r>
+              <a:rPr sz="1300" dirty="0">
+                <a:solidFill>
+                  <a:schemeClr val="bg1"/>
+                </a:solidFill>
+                <a:latin typeface="Calibri"/>
+                <a:ea typeface="Calibri"/>
+                <a:cs typeface="Calibri"/>
+              </a:rPr>
+              <a:t>.</a:t>
+            </a:r>
+          </a:p>
+        </p:txBody>
+      </p:sp>
+      <p:sp>
+        <p:nvSpPr>
+          <p:cNvPr id="56" name="Success heading">
+            <a:extLst>
+              <a:ext uri="{FF2B5EF4-FFF2-40B4-BE49-F238E27FC236}">
+                <a16:creationId xmlns:a16="http://schemas.microsoft.com/office/drawing/2014/main" id="{5A36368D-A38A-49D3-AB41-D9FC53609A8B}"/>
+              </a:ext>
+            </a:extLst>
+          </p:cNvPr>
+          <p:cNvSpPr>
+            <a:spLocks noGrp="1"/>
+          </p:cNvSpPr>
+          <p:nvPr/>
+        </p:nvSpPr>
+        <p:spPr>
+          <a:xfrm>
+            <a:off x="457200" y="4195761"/>
+            <a:ext cx="1352550" cy="304800"/>
+          </a:xfrm>
+          <a:prstGeom prst="rect">
+            <a:avLst/>
+          </a:prstGeom>
+          <a:noFill/>
+          <a:ln w="0">
+            <a:noFill/>
+          </a:ln>
+        </p:spPr>
+        <p:txBody>
+          <a:bodyPr wrap="square" lIns="0" tIns="0" rIns="0" bIns="0" anchor="t">
+            <a:noAutofit/>
+          </a:bodyPr>
+          <a:lstStyle>
+            <a:defPPr algn="l">
+              <a:defRPr sz="1500" b="1">
+                <a:solidFill>
+                  <a:srgbClr val="0B1F3A"/>
+                </a:solidFill>
+                <a:latin typeface="Calibri"/>
+                <a:ea typeface="Calibri"/>
+                <a:cs typeface="Calibri"/>
+              </a:defRPr>
+            </a:defPPr>
+          </a:lstStyle>
+          <a:p>
+            <a:pPr algn="l">
+              <a:defRPr sz="1500" b="1">
+                <a:solidFill>
+                  <a:srgbClr val="0B1F3A"/>
+                </a:solidFill>
+                <a:latin typeface="Calibri"/>
+                <a:ea typeface="Calibri"/>
+                <a:cs typeface="Calibri"/>
+              </a:defRPr>
+            </a:pPr>
+            <a:r>
+              <a:rPr sz="1500" b="1" dirty="0">
+                <a:solidFill>
+                  <a:schemeClr val="accent1"/>
+                </a:solidFill>
+                <a:latin typeface="Calibri"/>
+                <a:ea typeface="Calibri"/>
+                <a:cs typeface="Calibri"/>
+              </a:rPr>
+              <a:t>Success criteria</a:t>
+            </a:r>
+          </a:p>
+        </p:txBody>
+      </p:sp>
+      <p:sp>
+        <p:nvSpPr>
+          <p:cNvPr id="57" name="Success criteria">
+            <a:extLst>
+              <a:ext uri="{FF2B5EF4-FFF2-40B4-BE49-F238E27FC236}">
+                <a16:creationId xmlns:a16="http://schemas.microsoft.com/office/drawing/2014/main" id="{3BC16916-00CE-4194-9ADB-BCE37690540A}"/>
+              </a:ext>
+            </a:extLst>
+          </p:cNvPr>
+          <p:cNvSpPr>
+            <a:spLocks noGrp="1"/>
+          </p:cNvSpPr>
+          <p:nvPr/>
+        </p:nvSpPr>
+        <p:spPr>
+          <a:xfrm>
+            <a:off x="1914525" y="4195761"/>
+            <a:ext cx="6772275" cy="457200"/>
+          </a:xfrm>
+          <a:prstGeom prst="rect">
+            <a:avLst/>
+          </a:prstGeom>
+          <a:noFill/>
+          <a:ln w="0">
+            <a:noFill/>
+          </a:ln>
+        </p:spPr>
+        <p:txBody>
+          <a:bodyPr wrap="square" lIns="0" tIns="0" rIns="0" bIns="0" anchor="t">
+            <a:noAutofit/>
+          </a:bodyPr>
+          <a:lstStyle>
+            <a:defPPr algn="l">
+              <a:defRPr sz="1300">
+                <a:solidFill>
+                  <a:srgbClr val="1B2430"/>
+                </a:solidFill>
+                <a:latin typeface="Calibri"/>
+                <a:ea typeface="Calibri"/>
+                <a:cs typeface="Calibri"/>
+              </a:defRPr>
+            </a:defPPr>
+          </a:lstStyle>
+          <a:p>
+            <a:pPr algn="l">
+              <a:defRPr sz="1300">
+                <a:solidFill>
+                  <a:srgbClr val="1B2430"/>
+                </a:solidFill>
+                <a:latin typeface="Calibri"/>
+                <a:ea typeface="Calibri"/>
+                <a:cs typeface="Calibri"/>
+              </a:defRPr>
+            </a:pPr>
+            <a:r>
+              <a:rPr sz="1300">
+                <a:solidFill>
+                  <a:schemeClr val="bg1"/>
+                </a:solidFill>
+                <a:latin typeface="Calibri"/>
+                <a:ea typeface="Calibri"/>
+                <a:cs typeface="Calibri"/>
+              </a:rPr>
+              <a:t>Faster access to information and operational response, less confusion, adoption and positive feedback.</a:t>
+            </a:r>
           </a:p>
         </p:txBody>
       </p:sp>

</xml_diff>

<commit_message>
docs (#32): Add status overview slide
Green/yellow/red status of DoR/DoD, team roles and process, domain model
and architecture, as asked by the teacher. Speaker notes in Portuguese.

Co-Authored-By: Claude Opus 5.5 <noreply@anthropic.com>
</commit_message>
<xml_diff>
--- a/Docs/Presentation/Farol_First_Presentation.pptx
+++ b/Docs/Presentation/Farol_First_Presentation.pptx
@@ -14,6 +14,7 @@
     <p:sldId id="257" r:id="rId4"/>
     <p:sldId id="258" r:id="rId5"/>
     <p:sldId id="260" r:id="rId6"/>
+    <p:sldId id="262" r:id="rId13"/>
   </p:sldIdLst>
   <p:sldSz cx="9144000" cy="5143500" type="screen16x9"/>
   <p:notesSz cx="5143500" cy="9144000"/>
@@ -136,6 +137,11 @@
         <p14:section name="User workflows (António Guerra)" id="{5D2A7C18-9E41-4B6F-A3D0-8C7E1F24B9A6}">
           <p14:sldIdLst>
             <p14:sldId id="260"/>
+          </p14:sldIdLst>
+        </p14:section>
+        <p14:section name="Status overview" id="{2BDB7B91-3058-42AC-8457-3A3E92086DEB}">
+          <p14:sldIdLst>
+            <p14:sldId id="262"/>
           </p14:sldIdLst>
         </p14:section>
       </p14:sectionLst>
@@ -813,6 +819,52 @@
         <p14:creationId xmlns:p14="http://schemas.microsoft.com/office/powerpoint/2010/main" val="1024086991"/>
       </p:ext>
     </p:extLst>
+  </p:cSld>
+  <p:clrMapOvr>
+    <a:masterClrMapping/>
+  </p:clrMapOvr>
+</p:notes>
+</file>
+
+<file path=ppt/notesSlides/notesSlide7.xml><?xml version="1.0" encoding="utf-8"?>
+<p:notes xmlns:a="http://schemas.openxmlformats.org/drawingml/2006/main" xmlns:p="http://schemas.openxmlformats.org/presentationml/2006/main" xmlns:r="http://schemas.openxmlformats.org/officeDocument/2006/relationships">
+  <p:cSld>
+    <p:spTree>
+      <p:nvGrpSpPr>
+        <p:cNvPr id="1" name=""/>
+        <p:cNvGrpSpPr/>
+        <p:nvPr/>
+      </p:nvGrpSpPr>
+      <p:grpSpPr>
+        <a:xfrm>
+          <a:off x="0" y="0"/>
+          <a:ext cx="0" cy="0"/>
+          <a:chOff x="0" y="0"/>
+          <a:chExt cx="0" cy="0"/>
+        </a:xfrm>
+      </p:grpSpPr>
+      <p:sp>
+        <p:nvSpPr>
+          <p:cNvPr id="3" name="Notes Placeholder 2"/>
+          <p:cNvSpPr>
+            <a:spLocks noGrp="1"/>
+          </p:cNvSpPr>
+          <p:nvPr>
+            <p:ph type="body" idx="1"/>
+          </p:nvPr>
+        </p:nvSpPr>
+        <p:spPr/>
+        <p:txBody>
+          <a:bodyPr/>
+          <a:lstStyle/>
+          <a:p>
+            <a:r>
+              <a:t>(~45 s) Ponto de situação dos quatro temas pedidos pelo professor. DoR e DoD: verde. Foram acordados pela equipa a 8 de outubro; a regra é uma user story, uma issue, um PR. Já estão no GitHub: o DoR e o DoD da story nos issue forms e o DoD do PR no template de PR. Falta só criar as colunas Ready e Done no board. Papéis e processo: amarelo. Temos seis papéis definidos, GitHub Flow, sprints A, B e C com datas e duas reuniões por semana. Já temos uma verificação automática das convenções em cada PR. Falta pôr o board a funcionar e ligar a proteção do main com squash merge. Modelo de domínio: amarelo. Temos dois bounded contexts, o diagrama de classes, as regras de negócio e a parte de privacidade; o login obrigatório já está decidido. Faltam as questões DM-2 a DM-5 e as entidades Report, Badge e PlatformAdmin. Arquitetura: amarelo. Já começou a ser trabalhada: temos as vistas de contexto, contentores e deployment e o fluxo assíncrono de triagem com IA, mas ainda faltam fechar as decisões: serviços ou monólito modular, a stack tecnológica, os ADRs, o esboço da API e o walking skeleton. É a prioridade para o início do Sprint B.</a:t>
+            </a:r>
+          </a:p>
+        </p:txBody>
+      </p:sp>
+    </p:spTree>
   </p:cSld>
   <p:clrMapOvr>
     <a:masterClrMapping/>
@@ -1555,6 +1607,956 @@
 
 <file path=ppt/slides/slide2.xml><?xml version="1.0" encoding="utf-8"?>
 <p:sld xmlns:a="http://schemas.openxmlformats.org/drawingml/2006/main" xmlns:r="http://schemas.openxmlformats.org/officeDocument/2006/relationships" xmlns:p="http://schemas.openxmlformats.org/presentationml/2006/main">
+  <p:cSld name="Slide 2">
+    <p:spTree>
+      <p:nvGrpSpPr>
+        <p:cNvPr id="1" name=""/>
+        <p:cNvGrpSpPr/>
+        <p:nvPr/>
+      </p:nvGrpSpPr>
+      <p:grpSpPr>
+        <a:xfrm>
+          <a:off x="0" y="0"/>
+          <a:ext cx="0" cy="0"/>
+          <a:chOff x="0" y="0"/>
+          <a:chExt cx="0" cy="0"/>
+        </a:xfrm>
+      </p:grpSpPr>
+      <p:sp>
+        <p:nvSpPr>
+          <p:cNvPr id="4" name="Rita card">
+            <a:extLst>
+              <a:ext uri="{FF2B5EF4-FFF2-40B4-BE49-F238E27FC236}">
+                <a16:creationId xmlns:a16="http://schemas.microsoft.com/office/drawing/2014/main" id="{DE3F91AE-EEF0-4B77-F796-372EBD91B7DF}"/>
+              </a:ext>
+            </a:extLst>
+          </p:cNvPr>
+          <p:cNvSpPr/>
+          <p:nvPr/>
+        </p:nvSpPr>
+        <p:spPr>
+          <a:xfrm>
+            <a:off x="368693" y="3433761"/>
+            <a:ext cx="8387563" cy="1319448"/>
+          </a:xfrm>
+          <a:prstGeom prst="roundRect">
+            <a:avLst>
+              <a:gd name="adj" fmla="val 5714"/>
+            </a:avLst>
+          </a:prstGeom>
+          <a:solidFill>
+            <a:schemeClr val="tx2"/>
+          </a:solidFill>
+          <a:ln/>
+        </p:spPr>
+        <p:txBody>
+          <a:bodyPr/>
+          <a:lstStyle/>
+          <a:p>
+            <a:endParaRPr lang="en-PT" dirty="0">
+              <a:solidFill>
+                <a:schemeClr val="bg1"/>
+              </a:solidFill>
+            </a:endParaRPr>
+          </a:p>
+        </p:txBody>
+      </p:sp>
+      <p:sp>
+        <p:nvSpPr>
+          <p:cNvPr id="3" name="Rita card">
+            <a:extLst>
+              <a:ext uri="{FF2B5EF4-FFF2-40B4-BE49-F238E27FC236}">
+                <a16:creationId xmlns:a16="http://schemas.microsoft.com/office/drawing/2014/main" id="{30711021-712A-717F-2C45-15DE97DD91DD}"/>
+              </a:ext>
+            </a:extLst>
+          </p:cNvPr>
+          <p:cNvSpPr/>
+          <p:nvPr/>
+        </p:nvSpPr>
+        <p:spPr>
+          <a:xfrm>
+            <a:off x="4731143" y="1938337"/>
+            <a:ext cx="4025113" cy="1238250"/>
+          </a:xfrm>
+          <a:prstGeom prst="roundRect">
+            <a:avLst>
+              <a:gd name="adj" fmla="val 5714"/>
+            </a:avLst>
+          </a:prstGeom>
+          <a:solidFill>
+            <a:schemeClr val="bg2"/>
+          </a:solidFill>
+          <a:ln/>
+        </p:spPr>
+        <p:txBody>
+          <a:bodyPr/>
+          <a:lstStyle/>
+          <a:p>
+            <a:endParaRPr lang="en-PT"/>
+          </a:p>
+        </p:txBody>
+      </p:sp>
+      <p:sp>
+        <p:nvSpPr>
+          <p:cNvPr id="2" name="Rita card">
+            <a:extLst>
+              <a:ext uri="{FF2B5EF4-FFF2-40B4-BE49-F238E27FC236}">
+                <a16:creationId xmlns:a16="http://schemas.microsoft.com/office/drawing/2014/main" id="{0FDC3C32-5582-6860-15BE-D9F57C237ACD}"/>
+              </a:ext>
+            </a:extLst>
+          </p:cNvPr>
+          <p:cNvSpPr/>
+          <p:nvPr/>
+        </p:nvSpPr>
+        <p:spPr>
+          <a:xfrm>
+            <a:off x="368693" y="1938337"/>
+            <a:ext cx="4025113" cy="1238250"/>
+          </a:xfrm>
+          <a:prstGeom prst="roundRect">
+            <a:avLst>
+              <a:gd name="adj" fmla="val 5714"/>
+            </a:avLst>
+          </a:prstGeom>
+          <a:solidFill>
+            <a:schemeClr val="bg2"/>
+          </a:solidFill>
+          <a:ln/>
+        </p:spPr>
+        <p:txBody>
+          <a:bodyPr/>
+          <a:lstStyle/>
+          <a:p>
+            <a:endParaRPr lang="en-PT"/>
+          </a:p>
+        </p:txBody>
+      </p:sp>
+      <p:sp>
+        <p:nvSpPr>
+          <p:cNvPr id="46" name="Title 45">
+            <a:extLst>
+              <a:ext uri="{FF2B5EF4-FFF2-40B4-BE49-F238E27FC236}">
+                <a16:creationId xmlns:a16="http://schemas.microsoft.com/office/drawing/2014/main" id="{D35B6AAC-B8F8-6D43-4F74-381A49A405D9}"/>
+              </a:ext>
+            </a:extLst>
+          </p:cNvPr>
+          <p:cNvSpPr>
+            <a:spLocks noGrp="1"/>
+          </p:cNvSpPr>
+          <p:nvPr>
+            <p:ph type="title" idx="100"/>
+          </p:nvPr>
+        </p:nvSpPr>
+        <p:spPr>
+          <a:xfrm>
+            <a:off x="457200" y="274320"/>
+            <a:ext cx="8229600" cy="640080"/>
+          </a:xfrm>
+        </p:spPr>
+        <p:txBody>
+          <a:bodyPr lIns="0" tIns="0" rIns="0" bIns="0" anchor="ctr">
+            <a:noAutofit/>
+          </a:bodyPr>
+          <a:lstStyle>
+            <a:defPPr algn="ctr">
+              <a:defRPr sz="3200" b="1">
+                <a:solidFill>
+                  <a:srgbClr val="0B1F3A"/>
+                </a:solidFill>
+                <a:latin typeface="Calibri"/>
+                <a:ea typeface="Calibri"/>
+                <a:cs typeface="Calibri"/>
+              </a:defRPr>
+            </a:defPPr>
+          </a:lstStyle>
+          <a:p>
+            <a:pPr algn="ctr">
+              <a:defRPr sz="3200" b="1">
+                <a:solidFill>
+                  <a:srgbClr val="0B1F3A"/>
+                </a:solidFill>
+                <a:latin typeface="Calibri"/>
+                <a:ea typeface="Calibri"/>
+                <a:cs typeface="Calibri"/>
+              </a:defRPr>
+            </a:pPr>
+            <a:r>
+              <a:rPr sz="3200" b="1">
+                <a:solidFill>
+                  <a:srgbClr val="0B1F3A"/>
+                </a:solidFill>
+                <a:latin typeface="Calibri"/>
+                <a:ea typeface="Calibri"/>
+                <a:cs typeface="Calibri"/>
+              </a:rPr>
+              <a:t>Product vision</a:t>
+            </a:r>
+            <a:endParaRPr/>
+          </a:p>
+        </p:txBody>
+      </p:sp>
+      <p:pic>
+        <p:nvPicPr>
+          <p:cNvPr id="47" name="Picture 46">
+            <a:extLst>
+              <a:ext uri="{FF2B5EF4-FFF2-40B4-BE49-F238E27FC236}">
+                <a16:creationId xmlns:a16="http://schemas.microsoft.com/office/drawing/2014/main" id="{2165DBDE-5B3C-471C-9703-4CC44BBC29BB}"/>
+              </a:ext>
+            </a:extLst>
+          </p:cNvPr>
+          <p:cNvPicPr>
+            <a:picLocks noChangeAspect="1"/>
+          </p:cNvPicPr>
+          <p:nvPr/>
+        </p:nvPicPr>
+        <p:blipFill>
+          <a:blip r:embed="rId3"/>
+          <a:stretch/>
+        </p:blipFill>
+        <p:spPr>
+          <a:xfrm>
+            <a:off x="657225" y="900113"/>
+            <a:ext cx="952500" cy="952500"/>
+          </a:xfrm>
+          <a:prstGeom prst="rect">
+            <a:avLst/>
+          </a:prstGeom>
+        </p:spPr>
+      </p:pic>
+      <p:sp>
+        <p:nvSpPr>
+          <p:cNvPr id="48" name="Vision statement">
+            <a:extLst>
+              <a:ext uri="{FF2B5EF4-FFF2-40B4-BE49-F238E27FC236}">
+                <a16:creationId xmlns:a16="http://schemas.microsoft.com/office/drawing/2014/main" id="{BD580D43-FE42-4BF9-83F1-89CD57D05A09}"/>
+              </a:ext>
+            </a:extLst>
+          </p:cNvPr>
+          <p:cNvSpPr>
+            <a:spLocks noGrp="1"/>
+          </p:cNvSpPr>
+          <p:nvPr/>
+        </p:nvSpPr>
+        <p:spPr>
+          <a:xfrm>
+            <a:off x="1914525" y="914400"/>
+            <a:ext cx="6572250" cy="876300"/>
+          </a:xfrm>
+          <a:prstGeom prst="rect">
+            <a:avLst/>
+          </a:prstGeom>
+          <a:noFill/>
+          <a:ln w="0">
+            <a:noFill/>
+          </a:ln>
+        </p:spPr>
+        <p:txBody>
+          <a:bodyPr wrap="square" lIns="0" tIns="0" rIns="0" bIns="0" anchor="t">
+            <a:noAutofit/>
+          </a:bodyPr>
+          <a:lstStyle>
+            <a:defPPr algn="l">
+              <a:defRPr sz="2500" b="1">
+                <a:solidFill>
+                  <a:srgbClr val="0B1F3A"/>
+                </a:solidFill>
+                <a:latin typeface="Calibri"/>
+                <a:ea typeface="Calibri"/>
+                <a:cs typeface="Calibri"/>
+              </a:defRPr>
+            </a:defPPr>
+          </a:lstStyle>
+          <a:p>
+            <a:pPr algn="l">
+              <a:defRPr sz="2500" b="1">
+                <a:solidFill>
+                  <a:srgbClr val="0B1F3A"/>
+                </a:solidFill>
+                <a:latin typeface="Calibri"/>
+                <a:ea typeface="Calibri"/>
+                <a:cs typeface="Calibri"/>
+              </a:defRPr>
+            </a:pPr>
+            <a:r>
+              <a:rPr sz="2500" b="1" dirty="0">
+                <a:solidFill>
+                  <a:srgbClr val="0B1F3A"/>
+                </a:solidFill>
+                <a:latin typeface="Calibri"/>
+                <a:ea typeface="Calibri"/>
+                <a:cs typeface="Calibri"/>
+              </a:rPr>
+              <a:t>Reliable event information</a:t>
+            </a:r>
+            <a:r>
+              <a:rPr lang="pt-PT" sz="2500" b="1" dirty="0">
+                <a:solidFill>
+                  <a:srgbClr val="0B1F3A"/>
+                </a:solidFill>
+                <a:latin typeface="Calibri"/>
+                <a:ea typeface="Calibri"/>
+                <a:cs typeface="Calibri"/>
+              </a:rPr>
+              <a:t> </a:t>
+            </a:r>
+            <a:r>
+              <a:rPr sz="2500" b="1" dirty="0">
+                <a:solidFill>
+                  <a:srgbClr val="0B1F3A"/>
+                </a:solidFill>
+                <a:latin typeface="Calibri"/>
+                <a:ea typeface="Calibri"/>
+                <a:cs typeface="Calibri"/>
+              </a:rPr>
+              <a:t>and coordinated help</a:t>
+            </a:r>
+          </a:p>
+        </p:txBody>
+      </p:sp>
+      <p:sp>
+        <p:nvSpPr>
+          <p:cNvPr id="49" name="Vision audience">
+            <a:extLst>
+              <a:ext uri="{FF2B5EF4-FFF2-40B4-BE49-F238E27FC236}">
+                <a16:creationId xmlns:a16="http://schemas.microsoft.com/office/drawing/2014/main" id="{9DF1A56B-71E1-4DA3-8CB2-715A03FFF714}"/>
+              </a:ext>
+            </a:extLst>
+          </p:cNvPr>
+          <p:cNvSpPr>
+            <a:spLocks noGrp="1"/>
+          </p:cNvSpPr>
+          <p:nvPr/>
+        </p:nvSpPr>
+        <p:spPr>
+          <a:xfrm>
+            <a:off x="1919288" y="1395413"/>
+            <a:ext cx="6667500" cy="285750"/>
+          </a:xfrm>
+          <a:prstGeom prst="rect">
+            <a:avLst/>
+          </a:prstGeom>
+          <a:noFill/>
+          <a:ln w="0">
+            <a:noFill/>
+          </a:ln>
+        </p:spPr>
+        <p:txBody>
+          <a:bodyPr wrap="square" lIns="0" tIns="0" rIns="0" bIns="0" anchor="t">
+            <a:noAutofit/>
+          </a:bodyPr>
+          <a:lstStyle>
+            <a:defPPr algn="l">
+              <a:defRPr sz="1500">
+                <a:solidFill>
+                  <a:srgbClr val="1F4E79"/>
+                </a:solidFill>
+                <a:latin typeface="Calibri"/>
+                <a:ea typeface="Calibri"/>
+                <a:cs typeface="Calibri"/>
+              </a:defRPr>
+            </a:defPPr>
+          </a:lstStyle>
+          <a:p>
+            <a:pPr algn="l">
+              <a:defRPr sz="1500">
+                <a:solidFill>
+                  <a:srgbClr val="1F4E79"/>
+                </a:solidFill>
+                <a:latin typeface="Calibri"/>
+                <a:ea typeface="Calibri"/>
+                <a:cs typeface="Calibri"/>
+              </a:defRPr>
+            </a:pPr>
+            <a:r>
+              <a:rPr sz="1500" dirty="0">
+                <a:solidFill>
+                  <a:srgbClr val="1F4E79"/>
+                </a:solidFill>
+                <a:latin typeface="Calibri"/>
+                <a:ea typeface="Calibri"/>
+                <a:cs typeface="Calibri"/>
+              </a:rPr>
+              <a:t>A shared platform for participants and event teams</a:t>
+            </a:r>
+          </a:p>
+        </p:txBody>
+      </p:sp>
+      <p:sp>
+        <p:nvSpPr>
+          <p:cNvPr id="50" name="Participants heading">
+            <a:extLst>
+              <a:ext uri="{FF2B5EF4-FFF2-40B4-BE49-F238E27FC236}">
+                <a16:creationId xmlns:a16="http://schemas.microsoft.com/office/drawing/2014/main" id="{72DAA3F8-A99E-4817-B74D-445363117F11}"/>
+              </a:ext>
+            </a:extLst>
+          </p:cNvPr>
+          <p:cNvSpPr>
+            <a:spLocks noGrp="1"/>
+          </p:cNvSpPr>
+          <p:nvPr/>
+        </p:nvSpPr>
+        <p:spPr>
+          <a:xfrm>
+            <a:off x="457200" y="2052637"/>
+            <a:ext cx="3857625" cy="285750"/>
+          </a:xfrm>
+          <a:prstGeom prst="rect">
+            <a:avLst/>
+          </a:prstGeom>
+          <a:noFill/>
+          <a:ln w="0">
+            <a:noFill/>
+          </a:ln>
+        </p:spPr>
+        <p:txBody>
+          <a:bodyPr wrap="square" lIns="0" tIns="0" rIns="0" bIns="0" anchor="t">
+            <a:noAutofit/>
+          </a:bodyPr>
+          <a:lstStyle>
+            <a:defPPr algn="l">
+              <a:defRPr sz="1700" b="1">
+                <a:solidFill>
+                  <a:srgbClr val="1F4E79"/>
+                </a:solidFill>
+                <a:latin typeface="Calibri"/>
+                <a:ea typeface="Calibri"/>
+                <a:cs typeface="Calibri"/>
+              </a:defRPr>
+            </a:defPPr>
+          </a:lstStyle>
+          <a:p>
+            <a:pPr algn="l">
+              <a:defRPr sz="1700" b="1">
+                <a:solidFill>
+                  <a:srgbClr val="1F4E79"/>
+                </a:solidFill>
+                <a:latin typeface="Calibri"/>
+                <a:ea typeface="Calibri"/>
+                <a:cs typeface="Calibri"/>
+              </a:defRPr>
+            </a:pPr>
+            <a:r>
+              <a:rPr sz="1700" b="1" dirty="0">
+                <a:solidFill>
+                  <a:srgbClr val="1F4E79"/>
+                </a:solidFill>
+                <a:latin typeface="Calibri"/>
+                <a:ea typeface="Calibri"/>
+                <a:cs typeface="Calibri"/>
+              </a:rPr>
+              <a:t>For participants</a:t>
+            </a:r>
+          </a:p>
+        </p:txBody>
+      </p:sp>
+      <p:sp>
+        <p:nvSpPr>
+          <p:cNvPr id="51" name="Participants journey">
+            <a:extLst>
+              <a:ext uri="{FF2B5EF4-FFF2-40B4-BE49-F238E27FC236}">
+                <a16:creationId xmlns:a16="http://schemas.microsoft.com/office/drawing/2014/main" id="{FDD69BD9-71D1-41AC-8425-813E9BD26FD3}"/>
+              </a:ext>
+            </a:extLst>
+          </p:cNvPr>
+          <p:cNvSpPr>
+            <a:spLocks noGrp="1"/>
+          </p:cNvSpPr>
+          <p:nvPr/>
+        </p:nvSpPr>
+        <p:spPr>
+          <a:xfrm>
+            <a:off x="457200" y="2386012"/>
+            <a:ext cx="3848100" cy="781050"/>
+          </a:xfrm>
+          <a:prstGeom prst="rect">
+            <a:avLst/>
+          </a:prstGeom>
+          <a:noFill/>
+          <a:ln w="0">
+            <a:noFill/>
+          </a:ln>
+        </p:spPr>
+        <p:txBody>
+          <a:bodyPr wrap="square" lIns="0" tIns="0" rIns="0" bIns="0" anchor="t">
+            <a:noAutofit/>
+          </a:bodyPr>
+          <a:lstStyle>
+            <a:defPPr algn="l">
+              <a:defRPr sz="1500">
+                <a:solidFill>
+                  <a:srgbClr val="1B2430"/>
+                </a:solidFill>
+                <a:latin typeface="Calibri"/>
+                <a:ea typeface="Calibri"/>
+                <a:cs typeface="Calibri"/>
+              </a:defRPr>
+            </a:defPPr>
+          </a:lstStyle>
+          <a:p>
+            <a:pPr algn="l">
+              <a:defRPr sz="1500">
+                <a:solidFill>
+                  <a:srgbClr val="1B2430"/>
+                </a:solidFill>
+                <a:latin typeface="Calibri"/>
+                <a:ea typeface="Calibri"/>
+                <a:cs typeface="Calibri"/>
+              </a:defRPr>
+            </a:pPr>
+            <a:r>
+              <a:rPr sz="1500" dirty="0">
+                <a:solidFill>
+                  <a:srgbClr val="1B2430"/>
+                </a:solidFill>
+                <a:latin typeface="Calibri"/>
+                <a:ea typeface="Calibri"/>
+                <a:cs typeface="Calibri"/>
+              </a:rPr>
+              <a:t>Open by link or QR. Find the map and transport options, then request help with context and location.</a:t>
+            </a:r>
+          </a:p>
+        </p:txBody>
+      </p:sp>
+      <p:sp>
+        <p:nvSpPr>
+          <p:cNvPr id="52" name="Event team heading">
+            <a:extLst>
+              <a:ext uri="{FF2B5EF4-FFF2-40B4-BE49-F238E27FC236}">
+                <a16:creationId xmlns:a16="http://schemas.microsoft.com/office/drawing/2014/main" id="{EA37A2C6-44B2-4F7C-B5CD-57F6307C62E2}"/>
+              </a:ext>
+            </a:extLst>
+          </p:cNvPr>
+          <p:cNvSpPr>
+            <a:spLocks noGrp="1"/>
+          </p:cNvSpPr>
+          <p:nvPr/>
+        </p:nvSpPr>
+        <p:spPr>
+          <a:xfrm>
+            <a:off x="4800600" y="2071687"/>
+            <a:ext cx="3886200" cy="285750"/>
+          </a:xfrm>
+          <a:prstGeom prst="rect">
+            <a:avLst/>
+          </a:prstGeom>
+          <a:noFill/>
+          <a:ln w="0">
+            <a:noFill/>
+          </a:ln>
+        </p:spPr>
+        <p:txBody>
+          <a:bodyPr wrap="square" lIns="0" tIns="0" rIns="0" bIns="0" anchor="t">
+            <a:noAutofit/>
+          </a:bodyPr>
+          <a:lstStyle>
+            <a:defPPr algn="l">
+              <a:defRPr sz="1700" b="1">
+                <a:solidFill>
+                  <a:srgbClr val="1F4E79"/>
+                </a:solidFill>
+                <a:latin typeface="Calibri"/>
+                <a:ea typeface="Calibri"/>
+                <a:cs typeface="Calibri"/>
+              </a:defRPr>
+            </a:defPPr>
+          </a:lstStyle>
+          <a:p>
+            <a:pPr algn="l">
+              <a:defRPr sz="1700" b="1">
+                <a:solidFill>
+                  <a:srgbClr val="1F4E79"/>
+                </a:solidFill>
+                <a:latin typeface="Calibri"/>
+                <a:ea typeface="Calibri"/>
+                <a:cs typeface="Calibri"/>
+              </a:defRPr>
+            </a:pPr>
+            <a:r>
+              <a:rPr sz="1700" b="1">
+                <a:solidFill>
+                  <a:srgbClr val="1F4E79"/>
+                </a:solidFill>
+                <a:latin typeface="Calibri"/>
+                <a:ea typeface="Calibri"/>
+                <a:cs typeface="Calibri"/>
+              </a:rPr>
+              <a:t>For the event team</a:t>
+            </a:r>
+          </a:p>
+        </p:txBody>
+      </p:sp>
+      <p:sp>
+        <p:nvSpPr>
+          <p:cNvPr id="53" name="Event team journey">
+            <a:extLst>
+              <a:ext uri="{FF2B5EF4-FFF2-40B4-BE49-F238E27FC236}">
+                <a16:creationId xmlns:a16="http://schemas.microsoft.com/office/drawing/2014/main" id="{C93A605C-E103-414A-A0FC-CFFB4FECDB34}"/>
+              </a:ext>
+            </a:extLst>
+          </p:cNvPr>
+          <p:cNvSpPr>
+            <a:spLocks noGrp="1"/>
+          </p:cNvSpPr>
+          <p:nvPr/>
+        </p:nvSpPr>
+        <p:spPr>
+          <a:xfrm>
+            <a:off x="4800600" y="2405062"/>
+            <a:ext cx="3886200" cy="781050"/>
+          </a:xfrm>
+          <a:prstGeom prst="rect">
+            <a:avLst/>
+          </a:prstGeom>
+          <a:noFill/>
+          <a:ln w="0">
+            <a:noFill/>
+          </a:ln>
+        </p:spPr>
+        <p:txBody>
+          <a:bodyPr wrap="square" lIns="0" tIns="0" rIns="0" bIns="0" anchor="t">
+            <a:noAutofit/>
+          </a:bodyPr>
+          <a:lstStyle>
+            <a:defPPr algn="l">
+              <a:defRPr sz="1500">
+                <a:solidFill>
+                  <a:srgbClr val="1B2430"/>
+                </a:solidFill>
+                <a:latin typeface="Calibri"/>
+                <a:ea typeface="Calibri"/>
+                <a:cs typeface="Calibri"/>
+              </a:defRPr>
+            </a:defPPr>
+          </a:lstStyle>
+          <a:p>
+            <a:pPr algn="l">
+              <a:defRPr sz="1500">
+                <a:solidFill>
+                  <a:srgbClr val="1B2430"/>
+                </a:solidFill>
+                <a:latin typeface="Calibri"/>
+                <a:ea typeface="Calibri"/>
+                <a:cs typeface="Calibri"/>
+              </a:defRPr>
+            </a:pPr>
+            <a:r>
+              <a:rPr sz="1500">
+                <a:solidFill>
+                  <a:srgbClr val="1B2430"/>
+                </a:solidFill>
+                <a:latin typeface="Calibri"/>
+                <a:ea typeface="Calibri"/>
+                <a:cs typeface="Calibri"/>
+              </a:rPr>
+              <a:t>Configure the event and update information. Prioritise each request and route it to the right team.</a:t>
+            </a:r>
+          </a:p>
+        </p:txBody>
+      </p:sp>
+      <p:sp>
+        <p:nvSpPr>
+          <p:cNvPr id="54" name="MVP heading">
+            <a:extLst>
+              <a:ext uri="{FF2B5EF4-FFF2-40B4-BE49-F238E27FC236}">
+                <a16:creationId xmlns:a16="http://schemas.microsoft.com/office/drawing/2014/main" id="{FD4759BC-83D1-4166-BC0D-9B2F91CAF75B}"/>
+              </a:ext>
+            </a:extLst>
+          </p:cNvPr>
+          <p:cNvSpPr>
+            <a:spLocks noGrp="1"/>
+          </p:cNvSpPr>
+          <p:nvPr/>
+        </p:nvSpPr>
+        <p:spPr>
+          <a:xfrm>
+            <a:off x="457200" y="3614736"/>
+            <a:ext cx="1352550" cy="285750"/>
+          </a:xfrm>
+          <a:prstGeom prst="rect">
+            <a:avLst/>
+          </a:prstGeom>
+          <a:noFill/>
+          <a:ln w="0">
+            <a:noFill/>
+          </a:ln>
+        </p:spPr>
+        <p:txBody>
+          <a:bodyPr wrap="square" lIns="0" tIns="0" rIns="0" bIns="0" anchor="t">
+            <a:noAutofit/>
+          </a:bodyPr>
+          <a:lstStyle>
+            <a:defPPr algn="l">
+              <a:defRPr sz="1500" b="1">
+                <a:solidFill>
+                  <a:srgbClr val="0B1F3A"/>
+                </a:solidFill>
+                <a:latin typeface="Calibri"/>
+                <a:ea typeface="Calibri"/>
+                <a:cs typeface="Calibri"/>
+              </a:defRPr>
+            </a:defPPr>
+          </a:lstStyle>
+          <a:p>
+            <a:pPr algn="l">
+              <a:defRPr sz="1500" b="1">
+                <a:solidFill>
+                  <a:srgbClr val="0B1F3A"/>
+                </a:solidFill>
+                <a:latin typeface="Calibri"/>
+                <a:ea typeface="Calibri"/>
+                <a:cs typeface="Calibri"/>
+              </a:defRPr>
+            </a:pPr>
+            <a:r>
+              <a:rPr sz="1500" b="1" dirty="0">
+                <a:solidFill>
+                  <a:schemeClr val="accent1"/>
+                </a:solidFill>
+                <a:latin typeface="Calibri"/>
+                <a:ea typeface="Calibri"/>
+                <a:cs typeface="Calibri"/>
+              </a:rPr>
+              <a:t>MVP</a:t>
+            </a:r>
+          </a:p>
+        </p:txBody>
+      </p:sp>
+      <p:sp>
+        <p:nvSpPr>
+          <p:cNvPr id="55" name="MVP scope">
+            <a:extLst>
+              <a:ext uri="{FF2B5EF4-FFF2-40B4-BE49-F238E27FC236}">
+                <a16:creationId xmlns:a16="http://schemas.microsoft.com/office/drawing/2014/main" id="{EE15BBC2-61C5-47DC-90AD-58954614B58C}"/>
+              </a:ext>
+            </a:extLst>
+          </p:cNvPr>
+          <p:cNvSpPr>
+            <a:spLocks noGrp="1"/>
+          </p:cNvSpPr>
+          <p:nvPr/>
+        </p:nvSpPr>
+        <p:spPr>
+          <a:xfrm>
+            <a:off x="1914525" y="3614736"/>
+            <a:ext cx="6772275" cy="457200"/>
+          </a:xfrm>
+          <a:prstGeom prst="rect">
+            <a:avLst/>
+          </a:prstGeom>
+          <a:noFill/>
+          <a:ln w="0">
+            <a:noFill/>
+          </a:ln>
+        </p:spPr>
+        <p:txBody>
+          <a:bodyPr wrap="square" lIns="0" tIns="0" rIns="0" bIns="0" anchor="t">
+            <a:noAutofit/>
+          </a:bodyPr>
+          <a:lstStyle>
+            <a:defPPr algn="l">
+              <a:defRPr sz="1300">
+                <a:solidFill>
+                  <a:srgbClr val="1B2430"/>
+                </a:solidFill>
+                <a:latin typeface="Calibri"/>
+                <a:ea typeface="Calibri"/>
+                <a:cs typeface="Calibri"/>
+              </a:defRPr>
+            </a:defPPr>
+          </a:lstStyle>
+          <a:p>
+            <a:pPr algn="l">
+              <a:defRPr sz="1300">
+                <a:solidFill>
+                  <a:srgbClr val="1B2430"/>
+                </a:solidFill>
+                <a:latin typeface="Calibri"/>
+                <a:ea typeface="Calibri"/>
+                <a:cs typeface="Calibri"/>
+              </a:defRPr>
+            </a:pPr>
+            <a:r>
+              <a:rPr sz="1300" dirty="0">
+                <a:solidFill>
+                  <a:schemeClr val="bg1"/>
+                </a:solidFill>
+                <a:latin typeface="Calibri"/>
+                <a:ea typeface="Calibri"/>
+                <a:cs typeface="Calibri"/>
+              </a:rPr>
+              <a:t>Event selection, venue map, essential information, transport and help requests, with an event </a:t>
+            </a:r>
+            <a:r>
+              <a:rPr sz="1300" dirty="0" err="1">
+                <a:solidFill>
+                  <a:schemeClr val="bg1"/>
+                </a:solidFill>
+                <a:latin typeface="Calibri"/>
+                <a:ea typeface="Calibri"/>
+                <a:cs typeface="Calibri"/>
+              </a:rPr>
+              <a:t>backoffice</a:t>
+            </a:r>
+            <a:r>
+              <a:rPr sz="1300" dirty="0">
+                <a:solidFill>
+                  <a:schemeClr val="bg1"/>
+                </a:solidFill>
+                <a:latin typeface="Calibri"/>
+                <a:ea typeface="Calibri"/>
+                <a:cs typeface="Calibri"/>
+              </a:rPr>
+              <a:t>.</a:t>
+            </a:r>
+          </a:p>
+        </p:txBody>
+      </p:sp>
+      <p:sp>
+        <p:nvSpPr>
+          <p:cNvPr id="56" name="Success heading">
+            <a:extLst>
+              <a:ext uri="{FF2B5EF4-FFF2-40B4-BE49-F238E27FC236}">
+                <a16:creationId xmlns:a16="http://schemas.microsoft.com/office/drawing/2014/main" id="{5A36368D-A38A-49D3-AB41-D9FC53609A8B}"/>
+              </a:ext>
+            </a:extLst>
+          </p:cNvPr>
+          <p:cNvSpPr>
+            <a:spLocks noGrp="1"/>
+          </p:cNvSpPr>
+          <p:nvPr/>
+        </p:nvSpPr>
+        <p:spPr>
+          <a:xfrm>
+            <a:off x="457200" y="4195761"/>
+            <a:ext cx="1352550" cy="304800"/>
+          </a:xfrm>
+          <a:prstGeom prst="rect">
+            <a:avLst/>
+          </a:prstGeom>
+          <a:noFill/>
+          <a:ln w="0">
+            <a:noFill/>
+          </a:ln>
+        </p:spPr>
+        <p:txBody>
+          <a:bodyPr wrap="square" lIns="0" tIns="0" rIns="0" bIns="0" anchor="t">
+            <a:noAutofit/>
+          </a:bodyPr>
+          <a:lstStyle>
+            <a:defPPr algn="l">
+              <a:defRPr sz="1500" b="1">
+                <a:solidFill>
+                  <a:srgbClr val="0B1F3A"/>
+                </a:solidFill>
+                <a:latin typeface="Calibri"/>
+                <a:ea typeface="Calibri"/>
+                <a:cs typeface="Calibri"/>
+              </a:defRPr>
+            </a:defPPr>
+          </a:lstStyle>
+          <a:p>
+            <a:pPr algn="l">
+              <a:defRPr sz="1500" b="1">
+                <a:solidFill>
+                  <a:srgbClr val="0B1F3A"/>
+                </a:solidFill>
+                <a:latin typeface="Calibri"/>
+                <a:ea typeface="Calibri"/>
+                <a:cs typeface="Calibri"/>
+              </a:defRPr>
+            </a:pPr>
+            <a:r>
+              <a:rPr sz="1500" b="1" dirty="0">
+                <a:solidFill>
+                  <a:schemeClr val="accent1"/>
+                </a:solidFill>
+                <a:latin typeface="Calibri"/>
+                <a:ea typeface="Calibri"/>
+                <a:cs typeface="Calibri"/>
+              </a:rPr>
+              <a:t>Success criteria</a:t>
+            </a:r>
+          </a:p>
+        </p:txBody>
+      </p:sp>
+      <p:sp>
+        <p:nvSpPr>
+          <p:cNvPr id="57" name="Success criteria">
+            <a:extLst>
+              <a:ext uri="{FF2B5EF4-FFF2-40B4-BE49-F238E27FC236}">
+                <a16:creationId xmlns:a16="http://schemas.microsoft.com/office/drawing/2014/main" id="{3BC16916-00CE-4194-9ADB-BCE37690540A}"/>
+              </a:ext>
+            </a:extLst>
+          </p:cNvPr>
+          <p:cNvSpPr>
+            <a:spLocks noGrp="1"/>
+          </p:cNvSpPr>
+          <p:nvPr/>
+        </p:nvSpPr>
+        <p:spPr>
+          <a:xfrm>
+            <a:off x="1914525" y="4195761"/>
+            <a:ext cx="6772275" cy="457200"/>
+          </a:xfrm>
+          <a:prstGeom prst="rect">
+            <a:avLst/>
+          </a:prstGeom>
+          <a:noFill/>
+          <a:ln w="0">
+            <a:noFill/>
+          </a:ln>
+        </p:spPr>
+        <p:txBody>
+          <a:bodyPr wrap="square" lIns="0" tIns="0" rIns="0" bIns="0" anchor="t">
+            <a:noAutofit/>
+          </a:bodyPr>
+          <a:lstStyle>
+            <a:defPPr algn="l">
+              <a:defRPr sz="1300">
+                <a:solidFill>
+                  <a:srgbClr val="1B2430"/>
+                </a:solidFill>
+                <a:latin typeface="Calibri"/>
+                <a:ea typeface="Calibri"/>
+                <a:cs typeface="Calibri"/>
+              </a:defRPr>
+            </a:defPPr>
+          </a:lstStyle>
+          <a:p>
+            <a:pPr algn="l">
+              <a:defRPr sz="1300">
+                <a:solidFill>
+                  <a:srgbClr val="1B2430"/>
+                </a:solidFill>
+                <a:latin typeface="Calibri"/>
+                <a:ea typeface="Calibri"/>
+                <a:cs typeface="Calibri"/>
+              </a:defRPr>
+            </a:pPr>
+            <a:r>
+              <a:rPr sz="1300">
+                <a:solidFill>
+                  <a:schemeClr val="bg1"/>
+                </a:solidFill>
+                <a:latin typeface="Calibri"/>
+                <a:ea typeface="Calibri"/>
+                <a:cs typeface="Calibri"/>
+              </a:rPr>
+              <a:t>Faster access to information and operational response, less confusion, adoption and positive feedback.</a:t>
+            </a:r>
+          </a:p>
+        </p:txBody>
+      </p:sp>
+    </p:spTree>
+  </p:cSld>
+  <p:clrMapOvr>
+    <a:masterClrMapping/>
+  </p:clrMapOvr>
+</p:sld>
+</file>
+
+<file path=ppt/slides/slide3.xml><?xml version="1.0" encoding="utf-8"?>
+<p:sld xmlns:a="http://schemas.openxmlformats.org/drawingml/2006/main" xmlns:r="http://schemas.openxmlformats.org/officeDocument/2006/relationships" xmlns:p="http://schemas.openxmlformats.org/presentationml/2006/main">
   <p:cSld name="Slide 1">
     <p:spTree>
       <p:nvGrpSpPr>
@@ -3872,7 +4874,7 @@
 </p:sld>
 </file>
 
-<file path=ppt/slides/slide3.xml><?xml version="1.0" encoding="utf-8"?>
+<file path=ppt/slides/slide4.xml><?xml version="1.0" encoding="utf-8"?>
 <p:sld xmlns:a="http://schemas.openxmlformats.org/drawingml/2006/main" xmlns:r="http://schemas.openxmlformats.org/officeDocument/2006/relationships" xmlns:p="http://schemas.openxmlformats.org/presentationml/2006/main">
   <p:cSld name="Slide 2">
     <p:spTree>
@@ -5168,7 +6170,7 @@
 </p:sld>
 </file>
 
-<file path=ppt/slides/slide4.xml><?xml version="1.0" encoding="utf-8"?>
+<file path=ppt/slides/slide5.xml><?xml version="1.0" encoding="utf-8"?>
 <p:sld xmlns:a="http://schemas.openxmlformats.org/drawingml/2006/main" xmlns:r="http://schemas.openxmlformats.org/officeDocument/2006/relationships" xmlns:p="http://schemas.openxmlformats.org/presentationml/2006/main">
   <p:cSld name="Slide 3">
     <p:spTree>
@@ -6372,7 +7374,7 @@
 </p:sld>
 </file>
 
-<file path=ppt/slides/slide5.xml><?xml version="1.0" encoding="utf-8"?>
+<file path=ppt/slides/slide6.xml><?xml version="1.0" encoding="utf-8"?>
 <p:sld xmlns:a="http://schemas.openxmlformats.org/drawingml/2006/main" xmlns:r="http://schemas.openxmlformats.org/officeDocument/2006/relationships" xmlns:p="http://schemas.openxmlformats.org/presentationml/2006/main">
   <p:cSld name="User workflows">
     <p:spTree>
@@ -7911,146 +8913,24 @@
 </p:sld>
 </file>
 
-<file path=ppt/slides/slide6.xml><?xml version="1.0" encoding="utf-8"?>
-<p:sld xmlns:a="http://schemas.openxmlformats.org/drawingml/2006/main" xmlns:r="http://schemas.openxmlformats.org/officeDocument/2006/relationships" xmlns:p="http://schemas.openxmlformats.org/presentationml/2006/main">
-  <p:cSld name="Slide 2">
+<file path=ppt/slides/slide7.xml><?xml version="1.0" encoding="utf-8"?>
+<p:sld xmlns:a="http://schemas.openxmlformats.org/drawingml/2006/main" xmlns:p="http://schemas.openxmlformats.org/presentationml/2006/main" xmlns:r="http://schemas.openxmlformats.org/officeDocument/2006/relationships">
+  <p:cSld>
     <p:spTree>
       <p:nvGrpSpPr>
         <p:cNvPr id="1" name=""/>
         <p:cNvGrpSpPr/>
         <p:nvPr/>
       </p:nvGrpSpPr>
-      <p:grpSpPr>
-        <a:xfrm>
-          <a:off x="0" y="0"/>
-          <a:ext cx="0" cy="0"/>
-          <a:chOff x="0" y="0"/>
-          <a:chExt cx="0" cy="0"/>
-        </a:xfrm>
-      </p:grpSpPr>
-      <p:sp>
-        <p:nvSpPr>
-          <p:cNvPr id="4" name="Rita card">
-            <a:extLst>
-              <a:ext uri="{FF2B5EF4-FFF2-40B4-BE49-F238E27FC236}">
-                <a16:creationId xmlns:a16="http://schemas.microsoft.com/office/drawing/2014/main" id="{DE3F91AE-EEF0-4B77-F796-372EBD91B7DF}"/>
-              </a:ext>
-            </a:extLst>
-          </p:cNvPr>
-          <p:cNvSpPr/>
-          <p:nvPr/>
-        </p:nvSpPr>
-        <p:spPr>
-          <a:xfrm>
-            <a:off x="368693" y="3433761"/>
-            <a:ext cx="8387563" cy="1319448"/>
-          </a:xfrm>
-          <a:prstGeom prst="roundRect">
-            <a:avLst>
-              <a:gd name="adj" fmla="val 5714"/>
-            </a:avLst>
-          </a:prstGeom>
-          <a:solidFill>
-            <a:schemeClr val="tx2"/>
-          </a:solidFill>
-          <a:ln/>
-        </p:spPr>
-        <p:txBody>
-          <a:bodyPr/>
-          <a:lstStyle/>
-          <a:p>
-            <a:endParaRPr lang="en-PT" dirty="0">
-              <a:solidFill>
-                <a:schemeClr val="bg1"/>
-              </a:solidFill>
-            </a:endParaRPr>
-          </a:p>
-        </p:txBody>
-      </p:sp>
-      <p:sp>
-        <p:nvSpPr>
-          <p:cNvPr id="3" name="Rita card">
-            <a:extLst>
-              <a:ext uri="{FF2B5EF4-FFF2-40B4-BE49-F238E27FC236}">
-                <a16:creationId xmlns:a16="http://schemas.microsoft.com/office/drawing/2014/main" id="{30711021-712A-717F-2C45-15DE97DD91DD}"/>
-              </a:ext>
-            </a:extLst>
-          </p:cNvPr>
-          <p:cNvSpPr/>
-          <p:nvPr/>
-        </p:nvSpPr>
-        <p:spPr>
-          <a:xfrm>
-            <a:off x="4731143" y="1938337"/>
-            <a:ext cx="4025113" cy="1238250"/>
-          </a:xfrm>
-          <a:prstGeom prst="roundRect">
-            <a:avLst>
-              <a:gd name="adj" fmla="val 5714"/>
-            </a:avLst>
-          </a:prstGeom>
-          <a:solidFill>
-            <a:schemeClr val="bg2"/>
-          </a:solidFill>
-          <a:ln/>
-        </p:spPr>
-        <p:txBody>
-          <a:bodyPr/>
-          <a:lstStyle/>
-          <a:p>
-            <a:endParaRPr lang="en-PT"/>
-          </a:p>
-        </p:txBody>
-      </p:sp>
-      <p:sp>
-        <p:nvSpPr>
-          <p:cNvPr id="2" name="Rita card">
-            <a:extLst>
-              <a:ext uri="{FF2B5EF4-FFF2-40B4-BE49-F238E27FC236}">
-                <a16:creationId xmlns:a16="http://schemas.microsoft.com/office/drawing/2014/main" id="{0FDC3C32-5582-6860-15BE-D9F57C237ACD}"/>
-              </a:ext>
-            </a:extLst>
-          </p:cNvPr>
-          <p:cNvSpPr/>
-          <p:nvPr/>
-        </p:nvSpPr>
-        <p:spPr>
-          <a:xfrm>
-            <a:off x="368693" y="1938337"/>
-            <a:ext cx="4025113" cy="1238250"/>
-          </a:xfrm>
-          <a:prstGeom prst="roundRect">
-            <a:avLst>
-              <a:gd name="adj" fmla="val 5714"/>
-            </a:avLst>
-          </a:prstGeom>
-          <a:solidFill>
-            <a:schemeClr val="bg2"/>
-          </a:solidFill>
-          <a:ln/>
-        </p:spPr>
-        <p:txBody>
-          <a:bodyPr/>
-          <a:lstStyle/>
-          <a:p>
-            <a:endParaRPr lang="en-PT"/>
-          </a:p>
-        </p:txBody>
-      </p:sp>
-      <p:sp>
-        <p:nvSpPr>
-          <p:cNvPr id="46" name="Title 45">
-            <a:extLst>
-              <a:ext uri="{FF2B5EF4-FFF2-40B4-BE49-F238E27FC236}">
-                <a16:creationId xmlns:a16="http://schemas.microsoft.com/office/drawing/2014/main" id="{D35B6AAC-B8F8-6D43-4F74-381A49A405D9}"/>
-              </a:ext>
-            </a:extLst>
-          </p:cNvPr>
+      <p:grpSpPr/>
+      <p:sp>
+        <p:nvSpPr>
+          <p:cNvPr id="2" name="Text 0"/>
           <p:cNvSpPr>
             <a:spLocks noGrp="1"/>
           </p:cNvSpPr>
           <p:nvPr>
-            <p:ph type="title" idx="100"/>
+            <p:ph type="title" idx="100" hasCustomPrompt="1"/>
           </p:nvPr>
         </p:nvSpPr>
         <p:spPr>
@@ -8058,797 +8938,1069 @@
             <a:off x="457200" y="274320"/>
             <a:ext cx="8229600" cy="640080"/>
           </a:xfrm>
-        </p:spPr>
-        <p:txBody>
-          <a:bodyPr lIns="0" tIns="0" rIns="0" bIns="0" anchor="ctr">
-            <a:noAutofit/>
-          </a:bodyPr>
-          <a:lstStyle>
-            <a:defPPr algn="ctr">
-              <a:defRPr sz="3200" b="1">
-                <a:solidFill>
-                  <a:srgbClr val="0B1F3A"/>
-                </a:solidFill>
-                <a:latin typeface="Calibri"/>
-                <a:ea typeface="Calibri"/>
-                <a:cs typeface="Calibri"/>
-              </a:defRPr>
-            </a:defPPr>
-          </a:lstStyle>
-          <a:p>
-            <a:pPr algn="ctr">
-              <a:defRPr sz="3200" b="1">
-                <a:solidFill>
-                  <a:srgbClr val="0B1F3A"/>
-                </a:solidFill>
-                <a:latin typeface="Calibri"/>
-                <a:ea typeface="Calibri"/>
-                <a:cs typeface="Calibri"/>
-              </a:defRPr>
-            </a:pPr>
-            <a:r>
-              <a:rPr sz="3200" b="1">
-                <a:solidFill>
-                  <a:srgbClr val="0B1F3A"/>
-                </a:solidFill>
-                <a:latin typeface="Calibri"/>
-                <a:ea typeface="Calibri"/>
-                <a:cs typeface="Calibri"/>
-              </a:rPr>
-              <a:t>Product vision</a:t>
-            </a:r>
-            <a:endParaRPr/>
-          </a:p>
-        </p:txBody>
-      </p:sp>
-      <p:pic>
-        <p:nvPicPr>
-          <p:cNvPr id="47" name="Picture 46">
-            <a:extLst>
-              <a:ext uri="{FF2B5EF4-FFF2-40B4-BE49-F238E27FC236}">
-                <a16:creationId xmlns:a16="http://schemas.microsoft.com/office/drawing/2014/main" id="{2165DBDE-5B3C-471C-9703-4CC44BBC29BB}"/>
-              </a:ext>
-            </a:extLst>
-          </p:cNvPr>
-          <p:cNvPicPr>
-            <a:picLocks noChangeAspect="1"/>
-          </p:cNvPicPr>
-          <p:nvPr/>
-        </p:nvPicPr>
-        <p:blipFill>
-          <a:blip r:embed="rId3"/>
-          <a:stretch/>
-        </p:blipFill>
-        <p:spPr>
-          <a:xfrm>
-            <a:off x="657225" y="900113"/>
-            <a:ext cx="952500" cy="952500"/>
-          </a:xfrm>
-          <a:prstGeom prst="rect">
-            <a:avLst/>
-          </a:prstGeom>
-        </p:spPr>
-      </p:pic>
-      <p:sp>
-        <p:nvSpPr>
-          <p:cNvPr id="48" name="Vision statement">
-            <a:extLst>
-              <a:ext uri="{FF2B5EF4-FFF2-40B4-BE49-F238E27FC236}">
-                <a16:creationId xmlns:a16="http://schemas.microsoft.com/office/drawing/2014/main" id="{BD580D43-FE42-4BF9-83F1-89CD57D05A09}"/>
-              </a:ext>
-            </a:extLst>
-          </p:cNvPr>
-          <p:cNvSpPr>
-            <a:spLocks noGrp="1"/>
-          </p:cNvSpPr>
-          <p:nvPr/>
-        </p:nvSpPr>
-        <p:spPr>
-          <a:xfrm>
-            <a:off x="1914525" y="914400"/>
-            <a:ext cx="6572250" cy="876300"/>
-          </a:xfrm>
-          <a:prstGeom prst="rect">
-            <a:avLst/>
-          </a:prstGeom>
-          <a:noFill/>
-          <a:ln w="0">
+          <a:prstGeom prst="rect">
+            <a:avLst/>
+          </a:prstGeom>
+          <a:noFill/>
+          <a:ln/>
+        </p:spPr>
+        <p:txBody>
+          <a:bodyPr wrap="square" lIns="0" tIns="0" rIns="0" bIns="0" rtlCol="0" anchor="ctr"/>
+          <a:lstStyle/>
+          <a:p>
+            <a:pPr marL="0" indent="0">
+              <a:buNone/>
+            </a:pPr>
+            <a:r>
+              <a:rPr lang="en-US" sz="3200" b="1" dirty="0">
+                <a:solidFill>
+                  <a:schemeClr val="tx2"/>
+                </a:solidFill>
+              </a:rPr>
+              <a:t>Process and technical status</a:t>
+            </a:r>
+            <a:endParaRPr lang="en-US" sz="3200" dirty="0"/>
+          </a:p>
+        </p:txBody>
+      </p:sp>
+      <p:sp>
+        <p:nvSpPr>
+          <p:cNvPr id="3" name="DoR / DoD card"/>
+          <p:cNvSpPr/>
+          <p:nvPr/>
+        </p:nvSpPr>
+        <p:spPr>
+          <a:xfrm>
+            <a:off x="457200" y="1005840"/>
+            <a:ext cx="4023360" cy="1645920"/>
+          </a:xfrm>
+          <a:prstGeom prst="roundRect">
+            <a:avLst>
+              <a:gd name="adj" fmla="val 6000"/>
+            </a:avLst>
+          </a:prstGeom>
+          <a:solidFill>
+            <a:schemeClr val="bg2"/>
+          </a:solidFill>
+          <a:ln>
             <a:noFill/>
           </a:ln>
-        </p:spPr>
-        <p:txBody>
-          <a:bodyPr wrap="square" lIns="0" tIns="0" rIns="0" bIns="0" anchor="t">
-            <a:noAutofit/>
-          </a:bodyPr>
-          <a:lstStyle>
-            <a:defPPr algn="l">
-              <a:defRPr sz="2500" b="1">
-                <a:solidFill>
-                  <a:srgbClr val="0B1F3A"/>
-                </a:solidFill>
-                <a:latin typeface="Calibri"/>
-                <a:ea typeface="Calibri"/>
-                <a:cs typeface="Calibri"/>
-              </a:defRPr>
-            </a:defPPr>
-          </a:lstStyle>
-          <a:p>
-            <a:pPr algn="l">
-              <a:defRPr sz="2500" b="1">
-                <a:solidFill>
-                  <a:srgbClr val="0B1F3A"/>
-                </a:solidFill>
-                <a:latin typeface="Calibri"/>
-                <a:ea typeface="Calibri"/>
-                <a:cs typeface="Calibri"/>
-              </a:defRPr>
-            </a:pPr>
-            <a:r>
-              <a:rPr sz="2500" b="1" dirty="0">
-                <a:solidFill>
-                  <a:srgbClr val="0B1F3A"/>
-                </a:solidFill>
-                <a:latin typeface="Calibri"/>
-                <a:ea typeface="Calibri"/>
-                <a:cs typeface="Calibri"/>
-              </a:rPr>
-              <a:t>Reliable event information</a:t>
-            </a:r>
-            <a:r>
-              <a:rPr lang="pt-PT" sz="2500" b="1" dirty="0">
-                <a:solidFill>
-                  <a:srgbClr val="0B1F3A"/>
-                </a:solidFill>
-                <a:latin typeface="Calibri"/>
-                <a:ea typeface="Calibri"/>
-                <a:cs typeface="Calibri"/>
-              </a:rPr>
-              <a:t> </a:t>
-            </a:r>
-            <a:r>
-              <a:rPr sz="2500" b="1" dirty="0">
-                <a:solidFill>
-                  <a:srgbClr val="0B1F3A"/>
-                </a:solidFill>
-                <a:latin typeface="Calibri"/>
-                <a:ea typeface="Calibri"/>
-                <a:cs typeface="Calibri"/>
-              </a:rPr>
-              <a:t>and coordinated help</a:t>
-            </a:r>
-          </a:p>
-        </p:txBody>
-      </p:sp>
-      <p:sp>
-        <p:nvSpPr>
-          <p:cNvPr id="49" name="Vision audience">
-            <a:extLst>
-              <a:ext uri="{FF2B5EF4-FFF2-40B4-BE49-F238E27FC236}">
-                <a16:creationId xmlns:a16="http://schemas.microsoft.com/office/drawing/2014/main" id="{9DF1A56B-71E1-4DA3-8CB2-715A03FFF714}"/>
-              </a:ext>
-            </a:extLst>
-          </p:cNvPr>
-          <p:cNvSpPr>
-            <a:spLocks noGrp="1"/>
-          </p:cNvSpPr>
-          <p:nvPr/>
-        </p:nvSpPr>
-        <p:spPr>
-          <a:xfrm>
-            <a:off x="1919288" y="1395413"/>
-            <a:ext cx="6667500" cy="285750"/>
-          </a:xfrm>
-          <a:prstGeom prst="rect">
-            <a:avLst/>
-          </a:prstGeom>
-          <a:noFill/>
-          <a:ln w="0">
+          <a:effectLst/>
+        </p:spPr>
+        <p:style>
+          <a:lnRef idx="1">
+            <a:schemeClr val="accent1"/>
+          </a:lnRef>
+          <a:fillRef idx="3">
+            <a:schemeClr val="accent1"/>
+          </a:fillRef>
+          <a:effectRef idx="2">
+            <a:schemeClr val="accent1"/>
+          </a:effectRef>
+          <a:fontRef idx="minor">
+            <a:schemeClr val="lt1"/>
+          </a:fontRef>
+        </p:style>
+        <p:txBody>
+          <a:bodyPr rtlCol="0" anchor="ctr"/>
+          <a:lstStyle/>
+          <a:p>
+            <a:pPr algn="ctr"/>
+          </a:p>
+        </p:txBody>
+      </p:sp>
+      <p:sp>
+        <p:nvSpPr>
+          <p:cNvPr id="4" name="DoR / DoD status"/>
+          <p:cNvSpPr/>
+          <p:nvPr/>
+        </p:nvSpPr>
+        <p:spPr>
+          <a:xfrm>
+            <a:off x="640080" y="1188720"/>
+            <a:ext cx="365760" cy="365760"/>
+          </a:xfrm>
+          <a:prstGeom prst="ellipse">
+            <a:avLst/>
+          </a:prstGeom>
+          <a:solidFill>
+            <a:srgbClr val="2E9E5B"/>
+          </a:solidFill>
+          <a:ln>
             <a:noFill/>
           </a:ln>
-        </p:spPr>
-        <p:txBody>
-          <a:bodyPr wrap="square" lIns="0" tIns="0" rIns="0" bIns="0" anchor="t">
-            <a:noAutofit/>
+          <a:effectLst/>
+        </p:spPr>
+        <p:style>
+          <a:lnRef idx="1">
+            <a:schemeClr val="accent1"/>
+          </a:lnRef>
+          <a:fillRef idx="3">
+            <a:schemeClr val="accent1"/>
+          </a:fillRef>
+          <a:effectRef idx="2">
+            <a:schemeClr val="accent1"/>
+          </a:effectRef>
+          <a:fontRef idx="minor">
+            <a:schemeClr val="lt1"/>
+          </a:fontRef>
+        </p:style>
+        <p:txBody>
+          <a:bodyPr rtlCol="0" anchor="ctr"/>
+          <a:lstStyle/>
+          <a:p>
+            <a:pPr algn="ctr"/>
+          </a:p>
+        </p:txBody>
+      </p:sp>
+      <p:sp>
+        <p:nvSpPr>
+          <p:cNvPr id="5" name="DoR / DoD name"/>
+          <p:cNvSpPr txBox="1"/>
+          <p:nvPr/>
+        </p:nvSpPr>
+        <p:spPr>
+          <a:xfrm>
+            <a:off x="1143000" y="1188720"/>
+            <a:ext cx="2377440" cy="365760"/>
+          </a:xfrm>
+          <a:prstGeom prst="rect">
+            <a:avLst/>
+          </a:prstGeom>
+          <a:noFill/>
+        </p:spPr>
+        <p:txBody>
+          <a:bodyPr wrap="square" lIns="0" rIns="0" tIns="0" bIns="0" anchor="ctr">
+            <a:spAutoFit/>
           </a:bodyPr>
-          <a:lstStyle>
-            <a:defPPr algn="l">
-              <a:defRPr sz="1500">
+          <a:lstStyle/>
+          <a:p>
+            <a:pPr algn="l"/>
+            <a:r>
+              <a:rPr sz="1700" b="1">
+                <a:solidFill>
+                  <a:srgbClr val="0B1F3A"/>
+                </a:solidFill>
+              </a:rPr>
+              <a:t>DoR / DoD</a:t>
+            </a:r>
+          </a:p>
+        </p:txBody>
+      </p:sp>
+      <p:sp>
+        <p:nvSpPr>
+          <p:cNvPr id="6" name="DoR / DoD label"/>
+          <p:cNvSpPr txBox="1"/>
+          <p:nvPr/>
+        </p:nvSpPr>
+        <p:spPr>
+          <a:xfrm>
+            <a:off x="3429000" y="1188720"/>
+            <a:ext cx="868680" cy="365760"/>
+          </a:xfrm>
+          <a:prstGeom prst="rect">
+            <a:avLst/>
+          </a:prstGeom>
+          <a:noFill/>
+        </p:spPr>
+        <p:txBody>
+          <a:bodyPr wrap="square" lIns="0" rIns="0" tIns="0" bIns="0" anchor="ctr">
+            <a:spAutoFit/>
+          </a:bodyPr>
+          <a:lstStyle/>
+          <a:p>
+            <a:pPr algn="r"/>
+            <a:r>
+              <a:rPr sz="1300" b="1">
+                <a:solidFill>
+                  <a:srgbClr val="2E9E5B"/>
+                </a:solidFill>
+              </a:rPr>
+              <a:t>On track</a:t>
+            </a:r>
+          </a:p>
+        </p:txBody>
+      </p:sp>
+      <p:sp>
+        <p:nvSpPr>
+          <p:cNvPr id="7" name="DoR / DoD done"/>
+          <p:cNvSpPr txBox="1"/>
+          <p:nvPr/>
+        </p:nvSpPr>
+        <p:spPr>
+          <a:xfrm>
+            <a:off x="640080" y="1691640"/>
+            <a:ext cx="3657600" cy="411480"/>
+          </a:xfrm>
+          <a:prstGeom prst="rect">
+            <a:avLst/>
+          </a:prstGeom>
+          <a:noFill/>
+        </p:spPr>
+        <p:txBody>
+          <a:bodyPr wrap="square" lIns="0" rIns="0" tIns="0" bIns="0" anchor="t">
+            <a:spAutoFit/>
+          </a:bodyPr>
+          <a:lstStyle/>
+          <a:p>
+            <a:pPr algn="l"/>
+            <a:r>
+              <a:rPr sz="1300" b="1">
                 <a:solidFill>
                   <a:srgbClr val="1F4E79"/>
                 </a:solidFill>
-                <a:latin typeface="Calibri"/>
-                <a:ea typeface="Calibri"/>
-                <a:cs typeface="Calibri"/>
-              </a:defRPr>
-            </a:defPPr>
-          </a:lstStyle>
-          <a:p>
-            <a:pPr algn="l">
-              <a:defRPr sz="1500">
+              </a:rPr>
+              <a:t>Done  </a:t>
+            </a:r>
+            <a:r>
+              <a:rPr sz="1300" b="0">
+                <a:solidFill>
+                  <a:srgbClr val="1B2430"/>
+                </a:solidFill>
+              </a:rPr>
+              <a:t>Agreed 8 Oct; in issue forms and PR template</a:t>
+            </a:r>
+          </a:p>
+        </p:txBody>
+      </p:sp>
+      <p:sp>
+        <p:nvSpPr>
+          <p:cNvPr id="8" name="DoR / DoD next"/>
+          <p:cNvSpPr txBox="1"/>
+          <p:nvPr/>
+        </p:nvSpPr>
+        <p:spPr>
+          <a:xfrm>
+            <a:off x="640080" y="2121408"/>
+            <a:ext cx="3657600" cy="411480"/>
+          </a:xfrm>
+          <a:prstGeom prst="rect">
+            <a:avLst/>
+          </a:prstGeom>
+          <a:noFill/>
+        </p:spPr>
+        <p:txBody>
+          <a:bodyPr wrap="square" lIns="0" rIns="0" tIns="0" bIns="0" anchor="t">
+            <a:spAutoFit/>
+          </a:bodyPr>
+          <a:lstStyle/>
+          <a:p>
+            <a:pPr algn="l"/>
+            <a:r>
+              <a:rPr sz="1300" b="1">
                 <a:solidFill>
                   <a:srgbClr val="1F4E79"/>
                 </a:solidFill>
-                <a:latin typeface="Calibri"/>
-                <a:ea typeface="Calibri"/>
-                <a:cs typeface="Calibri"/>
-              </a:defRPr>
-            </a:pPr>
-            <a:r>
-              <a:rPr sz="1500" dirty="0">
-                <a:solidFill>
-                  <a:srgbClr val="1F4E79"/>
-                </a:solidFill>
-                <a:latin typeface="Calibri"/>
-                <a:ea typeface="Calibri"/>
-                <a:cs typeface="Calibri"/>
-              </a:rPr>
-              <a:t>A shared platform for participants and event teams</a:t>
-            </a:r>
-          </a:p>
-        </p:txBody>
-      </p:sp>
-      <p:sp>
-        <p:nvSpPr>
-          <p:cNvPr id="50" name="Participants heading">
-            <a:extLst>
-              <a:ext uri="{FF2B5EF4-FFF2-40B4-BE49-F238E27FC236}">
-                <a16:creationId xmlns:a16="http://schemas.microsoft.com/office/drawing/2014/main" id="{72DAA3F8-A99E-4817-B74D-445363117F11}"/>
-              </a:ext>
-            </a:extLst>
-          </p:cNvPr>
-          <p:cNvSpPr>
-            <a:spLocks noGrp="1"/>
-          </p:cNvSpPr>
-          <p:nvPr/>
-        </p:nvSpPr>
-        <p:spPr>
-          <a:xfrm>
-            <a:off x="457200" y="2052637"/>
-            <a:ext cx="3857625" cy="285750"/>
-          </a:xfrm>
-          <a:prstGeom prst="rect">
-            <a:avLst/>
-          </a:prstGeom>
-          <a:noFill/>
-          <a:ln w="0">
+              </a:rPr>
+              <a:t>Next  </a:t>
+            </a:r>
+            <a:r>
+              <a:rPr sz="1300" b="0">
+                <a:solidFill>
+                  <a:srgbClr val="1B2430"/>
+                </a:solidFill>
+              </a:rPr>
+              <a:t>Ready and Done columns on the board</a:t>
+            </a:r>
+          </a:p>
+        </p:txBody>
+      </p:sp>
+      <p:sp>
+        <p:nvSpPr>
+          <p:cNvPr id="9" name="Team roles and process card"/>
+          <p:cNvSpPr/>
+          <p:nvPr/>
+        </p:nvSpPr>
+        <p:spPr>
+          <a:xfrm>
+            <a:off x="4663440" y="1005840"/>
+            <a:ext cx="4023360" cy="1645920"/>
+          </a:xfrm>
+          <a:prstGeom prst="roundRect">
+            <a:avLst>
+              <a:gd name="adj" fmla="val 6000"/>
+            </a:avLst>
+          </a:prstGeom>
+          <a:solidFill>
+            <a:schemeClr val="bg2"/>
+          </a:solidFill>
+          <a:ln>
             <a:noFill/>
           </a:ln>
-        </p:spPr>
-        <p:txBody>
-          <a:bodyPr wrap="square" lIns="0" tIns="0" rIns="0" bIns="0" anchor="t">
-            <a:noAutofit/>
-          </a:bodyPr>
-          <a:lstStyle>
-            <a:defPPr algn="l">
-              <a:defRPr sz="1700" b="1">
-                <a:solidFill>
-                  <a:srgbClr val="1F4E79"/>
-                </a:solidFill>
-                <a:latin typeface="Calibri"/>
-                <a:ea typeface="Calibri"/>
-                <a:cs typeface="Calibri"/>
-              </a:defRPr>
-            </a:defPPr>
-          </a:lstStyle>
-          <a:p>
-            <a:pPr algn="l">
-              <a:defRPr sz="1700" b="1">
-                <a:solidFill>
-                  <a:srgbClr val="1F4E79"/>
-                </a:solidFill>
-                <a:latin typeface="Calibri"/>
-                <a:ea typeface="Calibri"/>
-                <a:cs typeface="Calibri"/>
-              </a:defRPr>
-            </a:pPr>
-            <a:r>
-              <a:rPr sz="1700" b="1" dirty="0">
-                <a:solidFill>
-                  <a:srgbClr val="1F4E79"/>
-                </a:solidFill>
-                <a:latin typeface="Calibri"/>
-                <a:ea typeface="Calibri"/>
-                <a:cs typeface="Calibri"/>
-              </a:rPr>
-              <a:t>For participants</a:t>
-            </a:r>
-          </a:p>
-        </p:txBody>
-      </p:sp>
-      <p:sp>
-        <p:nvSpPr>
-          <p:cNvPr id="51" name="Participants journey">
-            <a:extLst>
-              <a:ext uri="{FF2B5EF4-FFF2-40B4-BE49-F238E27FC236}">
-                <a16:creationId xmlns:a16="http://schemas.microsoft.com/office/drawing/2014/main" id="{FDD69BD9-71D1-41AC-8425-813E9BD26FD3}"/>
-              </a:ext>
-            </a:extLst>
-          </p:cNvPr>
-          <p:cNvSpPr>
-            <a:spLocks noGrp="1"/>
-          </p:cNvSpPr>
-          <p:nvPr/>
-        </p:nvSpPr>
-        <p:spPr>
-          <a:xfrm>
-            <a:off x="457200" y="2386012"/>
-            <a:ext cx="3848100" cy="781050"/>
-          </a:xfrm>
-          <a:prstGeom prst="rect">
-            <a:avLst/>
-          </a:prstGeom>
-          <a:noFill/>
-          <a:ln w="0">
+          <a:effectLst/>
+        </p:spPr>
+        <p:style>
+          <a:lnRef idx="1">
+            <a:schemeClr val="accent1"/>
+          </a:lnRef>
+          <a:fillRef idx="3">
+            <a:schemeClr val="accent1"/>
+          </a:fillRef>
+          <a:effectRef idx="2">
+            <a:schemeClr val="accent1"/>
+          </a:effectRef>
+          <a:fontRef idx="minor">
+            <a:schemeClr val="lt1"/>
+          </a:fontRef>
+        </p:style>
+        <p:txBody>
+          <a:bodyPr rtlCol="0" anchor="ctr"/>
+          <a:lstStyle/>
+          <a:p>
+            <a:pPr algn="ctr"/>
+          </a:p>
+        </p:txBody>
+      </p:sp>
+      <p:sp>
+        <p:nvSpPr>
+          <p:cNvPr id="10" name="Team roles and process status"/>
+          <p:cNvSpPr/>
+          <p:nvPr/>
+        </p:nvSpPr>
+        <p:spPr>
+          <a:xfrm>
+            <a:off x="4846320" y="1188720"/>
+            <a:ext cx="365760" cy="365760"/>
+          </a:xfrm>
+          <a:prstGeom prst="ellipse">
+            <a:avLst/>
+          </a:prstGeom>
+          <a:solidFill>
+            <a:srgbClr val="E8A300"/>
+          </a:solidFill>
+          <a:ln>
             <a:noFill/>
           </a:ln>
-        </p:spPr>
-        <p:txBody>
-          <a:bodyPr wrap="square" lIns="0" tIns="0" rIns="0" bIns="0" anchor="t">
-            <a:noAutofit/>
+          <a:effectLst/>
+        </p:spPr>
+        <p:style>
+          <a:lnRef idx="1">
+            <a:schemeClr val="accent1"/>
+          </a:lnRef>
+          <a:fillRef idx="3">
+            <a:schemeClr val="accent1"/>
+          </a:fillRef>
+          <a:effectRef idx="2">
+            <a:schemeClr val="accent1"/>
+          </a:effectRef>
+          <a:fontRef idx="minor">
+            <a:schemeClr val="lt1"/>
+          </a:fontRef>
+        </p:style>
+        <p:txBody>
+          <a:bodyPr rtlCol="0" anchor="ctr"/>
+          <a:lstStyle/>
+          <a:p>
+            <a:pPr algn="ctr"/>
+          </a:p>
+        </p:txBody>
+      </p:sp>
+      <p:sp>
+        <p:nvSpPr>
+          <p:cNvPr id="11" name="Team roles and process name"/>
+          <p:cNvSpPr txBox="1"/>
+          <p:nvPr/>
+        </p:nvSpPr>
+        <p:spPr>
+          <a:xfrm>
+            <a:off x="5349240" y="1188720"/>
+            <a:ext cx="2377440" cy="365760"/>
+          </a:xfrm>
+          <a:prstGeom prst="rect">
+            <a:avLst/>
+          </a:prstGeom>
+          <a:noFill/>
+        </p:spPr>
+        <p:txBody>
+          <a:bodyPr wrap="square" lIns="0" rIns="0" tIns="0" bIns="0" anchor="ctr">
+            <a:spAutoFit/>
           </a:bodyPr>
-          <a:lstStyle>
-            <a:defPPr algn="l">
-              <a:defRPr sz="1500">
+          <a:lstStyle/>
+          <a:p>
+            <a:pPr algn="l"/>
+            <a:r>
+              <a:rPr sz="1700" b="1">
+                <a:solidFill>
+                  <a:srgbClr val="0B1F3A"/>
+                </a:solidFill>
+              </a:rPr>
+              <a:t>Team roles and process</a:t>
+            </a:r>
+          </a:p>
+        </p:txBody>
+      </p:sp>
+      <p:sp>
+        <p:nvSpPr>
+          <p:cNvPr id="12" name="Team roles and process label"/>
+          <p:cNvSpPr txBox="1"/>
+          <p:nvPr/>
+        </p:nvSpPr>
+        <p:spPr>
+          <a:xfrm>
+            <a:off x="7635240" y="1188720"/>
+            <a:ext cx="868680" cy="365760"/>
+          </a:xfrm>
+          <a:prstGeom prst="rect">
+            <a:avLst/>
+          </a:prstGeom>
+          <a:noFill/>
+        </p:spPr>
+        <p:txBody>
+          <a:bodyPr wrap="square" lIns="0" rIns="0" tIns="0" bIns="0" anchor="ctr">
+            <a:spAutoFit/>
+          </a:bodyPr>
+          <a:lstStyle/>
+          <a:p>
+            <a:pPr algn="r"/>
+            <a:r>
+              <a:rPr sz="1300" b="1">
+                <a:solidFill>
+                  <a:srgbClr val="E8A300"/>
+                </a:solidFill>
+              </a:rPr>
+              <a:t>In progress</a:t>
+            </a:r>
+          </a:p>
+        </p:txBody>
+      </p:sp>
+      <p:sp>
+        <p:nvSpPr>
+          <p:cNvPr id="13" name="Team roles and process done"/>
+          <p:cNvSpPr txBox="1"/>
+          <p:nvPr/>
+        </p:nvSpPr>
+        <p:spPr>
+          <a:xfrm>
+            <a:off x="4846320" y="1691640"/>
+            <a:ext cx="3657600" cy="411480"/>
+          </a:xfrm>
+          <a:prstGeom prst="rect">
+            <a:avLst/>
+          </a:prstGeom>
+          <a:noFill/>
+        </p:spPr>
+        <p:txBody>
+          <a:bodyPr wrap="square" lIns="0" rIns="0" tIns="0" bIns="0" anchor="t">
+            <a:spAutoFit/>
+          </a:bodyPr>
+          <a:lstStyle/>
+          <a:p>
+            <a:pPr algn="l"/>
+            <a:r>
+              <a:rPr sz="1300" b="1">
+                <a:solidFill>
+                  <a:srgbClr val="1F4E79"/>
+                </a:solidFill>
+              </a:rPr>
+              <a:t>Done  </a:t>
+            </a:r>
+            <a:r>
+              <a:rPr sz="1300" b="0">
                 <a:solidFill>
                   <a:srgbClr val="1B2430"/>
                 </a:solidFill>
-                <a:latin typeface="Calibri"/>
-                <a:ea typeface="Calibri"/>
-                <a:cs typeface="Calibri"/>
-              </a:defRPr>
-            </a:defPPr>
-          </a:lstStyle>
-          <a:p>
-            <a:pPr algn="l">
-              <a:defRPr sz="1500">
+              </a:rPr>
+              <a:t>6 roles, GitHub Flow, sprints A to C, 2 meetings</a:t>
+            </a:r>
+          </a:p>
+        </p:txBody>
+      </p:sp>
+      <p:sp>
+        <p:nvSpPr>
+          <p:cNvPr id="14" name="Team roles and process next"/>
+          <p:cNvSpPr txBox="1"/>
+          <p:nvPr/>
+        </p:nvSpPr>
+        <p:spPr>
+          <a:xfrm>
+            <a:off x="4846320" y="2121408"/>
+            <a:ext cx="3657600" cy="411480"/>
+          </a:xfrm>
+          <a:prstGeom prst="rect">
+            <a:avLst/>
+          </a:prstGeom>
+          <a:noFill/>
+        </p:spPr>
+        <p:txBody>
+          <a:bodyPr wrap="square" lIns="0" rIns="0" tIns="0" bIns="0" anchor="t">
+            <a:spAutoFit/>
+          </a:bodyPr>
+          <a:lstStyle/>
+          <a:p>
+            <a:pPr algn="l"/>
+            <a:r>
+              <a:rPr sz="1300" b="1">
+                <a:solidFill>
+                  <a:srgbClr val="1F4E79"/>
+                </a:solidFill>
+              </a:rPr>
+              <a:t>Next  </a:t>
+            </a:r>
+            <a:r>
+              <a:rPr sz="1300" b="0">
                 <a:solidFill>
                   <a:srgbClr val="1B2430"/>
                 </a:solidFill>
-                <a:latin typeface="Calibri"/>
-                <a:ea typeface="Calibri"/>
-                <a:cs typeface="Calibri"/>
-              </a:defRPr>
-            </a:pPr>
-            <a:r>
-              <a:rPr sz="1500" dirty="0">
-                <a:solidFill>
-                  <a:srgbClr val="1B2430"/>
-                </a:solidFill>
-                <a:latin typeface="Calibri"/>
-                <a:ea typeface="Calibri"/>
-                <a:cs typeface="Calibri"/>
-              </a:rPr>
-              <a:t>Open by link or QR. Find the map and transport options, then request help with context and location.</a:t>
-            </a:r>
-          </a:p>
-        </p:txBody>
-      </p:sp>
-      <p:sp>
-        <p:nvSpPr>
-          <p:cNvPr id="52" name="Event team heading">
-            <a:extLst>
-              <a:ext uri="{FF2B5EF4-FFF2-40B4-BE49-F238E27FC236}">
-                <a16:creationId xmlns:a16="http://schemas.microsoft.com/office/drawing/2014/main" id="{EA37A2C6-44B2-4F7C-B5CD-57F6307C62E2}"/>
-              </a:ext>
-            </a:extLst>
-          </p:cNvPr>
-          <p:cNvSpPr>
-            <a:spLocks noGrp="1"/>
-          </p:cNvSpPr>
-          <p:nvPr/>
-        </p:nvSpPr>
-        <p:spPr>
-          <a:xfrm>
-            <a:off x="4800600" y="2071687"/>
-            <a:ext cx="3886200" cy="285750"/>
-          </a:xfrm>
-          <a:prstGeom prst="rect">
-            <a:avLst/>
-          </a:prstGeom>
-          <a:noFill/>
-          <a:ln w="0">
+              </a:rPr>
+              <a:t>Board live; branch protection; squash only</a:t>
+            </a:r>
+          </a:p>
+        </p:txBody>
+      </p:sp>
+      <p:sp>
+        <p:nvSpPr>
+          <p:cNvPr id="15" name="Domain model card"/>
+          <p:cNvSpPr/>
+          <p:nvPr/>
+        </p:nvSpPr>
+        <p:spPr>
+          <a:xfrm>
+            <a:off x="457200" y="2834640"/>
+            <a:ext cx="4023360" cy="1645920"/>
+          </a:xfrm>
+          <a:prstGeom prst="roundRect">
+            <a:avLst>
+              <a:gd name="adj" fmla="val 6000"/>
+            </a:avLst>
+          </a:prstGeom>
+          <a:solidFill>
+            <a:schemeClr val="bg2"/>
+          </a:solidFill>
+          <a:ln>
             <a:noFill/>
           </a:ln>
-        </p:spPr>
-        <p:txBody>
-          <a:bodyPr wrap="square" lIns="0" tIns="0" rIns="0" bIns="0" anchor="t">
-            <a:noAutofit/>
-          </a:bodyPr>
-          <a:lstStyle>
-            <a:defPPr algn="l">
-              <a:defRPr sz="1700" b="1">
-                <a:solidFill>
-                  <a:srgbClr val="1F4E79"/>
-                </a:solidFill>
-                <a:latin typeface="Calibri"/>
-                <a:ea typeface="Calibri"/>
-                <a:cs typeface="Calibri"/>
-              </a:defRPr>
-            </a:defPPr>
-          </a:lstStyle>
-          <a:p>
-            <a:pPr algn="l">
-              <a:defRPr sz="1700" b="1">
-                <a:solidFill>
-                  <a:srgbClr val="1F4E79"/>
-                </a:solidFill>
-                <a:latin typeface="Calibri"/>
-                <a:ea typeface="Calibri"/>
-                <a:cs typeface="Calibri"/>
-              </a:defRPr>
-            </a:pPr>
-            <a:r>
-              <a:rPr sz="1700" b="1">
-                <a:solidFill>
-                  <a:srgbClr val="1F4E79"/>
-                </a:solidFill>
-                <a:latin typeface="Calibri"/>
-                <a:ea typeface="Calibri"/>
-                <a:cs typeface="Calibri"/>
-              </a:rPr>
-              <a:t>For the event team</a:t>
-            </a:r>
-          </a:p>
-        </p:txBody>
-      </p:sp>
-      <p:sp>
-        <p:nvSpPr>
-          <p:cNvPr id="53" name="Event team journey">
-            <a:extLst>
-              <a:ext uri="{FF2B5EF4-FFF2-40B4-BE49-F238E27FC236}">
-                <a16:creationId xmlns:a16="http://schemas.microsoft.com/office/drawing/2014/main" id="{C93A605C-E103-414A-A0FC-CFFB4FECDB34}"/>
-              </a:ext>
-            </a:extLst>
-          </p:cNvPr>
-          <p:cNvSpPr>
-            <a:spLocks noGrp="1"/>
-          </p:cNvSpPr>
-          <p:nvPr/>
-        </p:nvSpPr>
-        <p:spPr>
-          <a:xfrm>
-            <a:off x="4800600" y="2405062"/>
-            <a:ext cx="3886200" cy="781050"/>
-          </a:xfrm>
-          <a:prstGeom prst="rect">
-            <a:avLst/>
-          </a:prstGeom>
-          <a:noFill/>
-          <a:ln w="0">
+          <a:effectLst/>
+        </p:spPr>
+        <p:style>
+          <a:lnRef idx="1">
+            <a:schemeClr val="accent1"/>
+          </a:lnRef>
+          <a:fillRef idx="3">
+            <a:schemeClr val="accent1"/>
+          </a:fillRef>
+          <a:effectRef idx="2">
+            <a:schemeClr val="accent1"/>
+          </a:effectRef>
+          <a:fontRef idx="minor">
+            <a:schemeClr val="lt1"/>
+          </a:fontRef>
+        </p:style>
+        <p:txBody>
+          <a:bodyPr rtlCol="0" anchor="ctr"/>
+          <a:lstStyle/>
+          <a:p>
+            <a:pPr algn="ctr"/>
+          </a:p>
+        </p:txBody>
+      </p:sp>
+      <p:sp>
+        <p:nvSpPr>
+          <p:cNvPr id="16" name="Domain model status"/>
+          <p:cNvSpPr/>
+          <p:nvPr/>
+        </p:nvSpPr>
+        <p:spPr>
+          <a:xfrm>
+            <a:off x="640080" y="3017520"/>
+            <a:ext cx="365760" cy="365760"/>
+          </a:xfrm>
+          <a:prstGeom prst="ellipse">
+            <a:avLst/>
+          </a:prstGeom>
+          <a:solidFill>
+            <a:srgbClr val="E8A300"/>
+          </a:solidFill>
+          <a:ln>
             <a:noFill/>
           </a:ln>
-        </p:spPr>
-        <p:txBody>
-          <a:bodyPr wrap="square" lIns="0" tIns="0" rIns="0" bIns="0" anchor="t">
-            <a:noAutofit/>
+          <a:effectLst/>
+        </p:spPr>
+        <p:style>
+          <a:lnRef idx="1">
+            <a:schemeClr val="accent1"/>
+          </a:lnRef>
+          <a:fillRef idx="3">
+            <a:schemeClr val="accent1"/>
+          </a:fillRef>
+          <a:effectRef idx="2">
+            <a:schemeClr val="accent1"/>
+          </a:effectRef>
+          <a:fontRef idx="minor">
+            <a:schemeClr val="lt1"/>
+          </a:fontRef>
+        </p:style>
+        <p:txBody>
+          <a:bodyPr rtlCol="0" anchor="ctr"/>
+          <a:lstStyle/>
+          <a:p>
+            <a:pPr algn="ctr"/>
+          </a:p>
+        </p:txBody>
+      </p:sp>
+      <p:sp>
+        <p:nvSpPr>
+          <p:cNvPr id="17" name="Domain model name"/>
+          <p:cNvSpPr txBox="1"/>
+          <p:nvPr/>
+        </p:nvSpPr>
+        <p:spPr>
+          <a:xfrm>
+            <a:off x="1143000" y="3017520"/>
+            <a:ext cx="2377440" cy="365760"/>
+          </a:xfrm>
+          <a:prstGeom prst="rect">
+            <a:avLst/>
+          </a:prstGeom>
+          <a:noFill/>
+        </p:spPr>
+        <p:txBody>
+          <a:bodyPr wrap="square" lIns="0" rIns="0" tIns="0" bIns="0" anchor="ctr">
+            <a:spAutoFit/>
           </a:bodyPr>
-          <a:lstStyle>
-            <a:defPPr algn="l">
-              <a:defRPr sz="1500">
+          <a:lstStyle/>
+          <a:p>
+            <a:pPr algn="l"/>
+            <a:r>
+              <a:rPr sz="1700" b="1">
+                <a:solidFill>
+                  <a:srgbClr val="0B1F3A"/>
+                </a:solidFill>
+              </a:rPr>
+              <a:t>Domain model</a:t>
+            </a:r>
+          </a:p>
+        </p:txBody>
+      </p:sp>
+      <p:sp>
+        <p:nvSpPr>
+          <p:cNvPr id="18" name="Domain model label"/>
+          <p:cNvSpPr txBox="1"/>
+          <p:nvPr/>
+        </p:nvSpPr>
+        <p:spPr>
+          <a:xfrm>
+            <a:off x="3429000" y="3017520"/>
+            <a:ext cx="868680" cy="365760"/>
+          </a:xfrm>
+          <a:prstGeom prst="rect">
+            <a:avLst/>
+          </a:prstGeom>
+          <a:noFill/>
+        </p:spPr>
+        <p:txBody>
+          <a:bodyPr wrap="square" lIns="0" rIns="0" tIns="0" bIns="0" anchor="ctr">
+            <a:spAutoFit/>
+          </a:bodyPr>
+          <a:lstStyle/>
+          <a:p>
+            <a:pPr algn="r"/>
+            <a:r>
+              <a:rPr sz="1300" b="1">
+                <a:solidFill>
+                  <a:srgbClr val="E8A300"/>
+                </a:solidFill>
+              </a:rPr>
+              <a:t>In progress</a:t>
+            </a:r>
+          </a:p>
+        </p:txBody>
+      </p:sp>
+      <p:sp>
+        <p:nvSpPr>
+          <p:cNvPr id="19" name="Domain model done"/>
+          <p:cNvSpPr txBox="1"/>
+          <p:nvPr/>
+        </p:nvSpPr>
+        <p:spPr>
+          <a:xfrm>
+            <a:off x="640080" y="3520440"/>
+            <a:ext cx="3657600" cy="411480"/>
+          </a:xfrm>
+          <a:prstGeom prst="rect">
+            <a:avLst/>
+          </a:prstGeom>
+          <a:noFill/>
+        </p:spPr>
+        <p:txBody>
+          <a:bodyPr wrap="square" lIns="0" rIns="0" tIns="0" bIns="0" anchor="t">
+            <a:spAutoFit/>
+          </a:bodyPr>
+          <a:lstStyle/>
+          <a:p>
+            <a:pPr algn="l"/>
+            <a:r>
+              <a:rPr sz="1300" b="1">
+                <a:solidFill>
+                  <a:srgbClr val="1F4E79"/>
+                </a:solidFill>
+              </a:rPr>
+              <a:t>Done  </a:t>
+            </a:r>
+            <a:r>
+              <a:rPr sz="1300" b="0">
                 <a:solidFill>
                   <a:srgbClr val="1B2430"/>
                 </a:solidFill>
-                <a:latin typeface="Calibri"/>
-                <a:ea typeface="Calibri"/>
-                <a:cs typeface="Calibri"/>
-              </a:defRPr>
-            </a:defPPr>
-          </a:lstStyle>
-          <a:p>
-            <a:pPr algn="l">
-              <a:defRPr sz="1500">
+              </a:rPr>
+              <a:t>2 contexts, class diagram, rules, privacy</a:t>
+            </a:r>
+          </a:p>
+        </p:txBody>
+      </p:sp>
+      <p:sp>
+        <p:nvSpPr>
+          <p:cNvPr id="20" name="Domain model next"/>
+          <p:cNvSpPr txBox="1"/>
+          <p:nvPr/>
+        </p:nvSpPr>
+        <p:spPr>
+          <a:xfrm>
+            <a:off x="640080" y="3950208"/>
+            <a:ext cx="3657600" cy="411480"/>
+          </a:xfrm>
+          <a:prstGeom prst="rect">
+            <a:avLst/>
+          </a:prstGeom>
+          <a:noFill/>
+        </p:spPr>
+        <p:txBody>
+          <a:bodyPr wrap="square" lIns="0" rIns="0" tIns="0" bIns="0" anchor="t">
+            <a:spAutoFit/>
+          </a:bodyPr>
+          <a:lstStyle/>
+          <a:p>
+            <a:pPr algn="l"/>
+            <a:r>
+              <a:rPr sz="1300" b="1">
+                <a:solidFill>
+                  <a:srgbClr val="1F4E79"/>
+                </a:solidFill>
+              </a:rPr>
+              <a:t>Next  </a:t>
+            </a:r>
+            <a:r>
+              <a:rPr sz="1300" b="0">
                 <a:solidFill>
                   <a:srgbClr val="1B2430"/>
                 </a:solidFill>
-                <a:latin typeface="Calibri"/>
-                <a:ea typeface="Calibri"/>
-                <a:cs typeface="Calibri"/>
-              </a:defRPr>
-            </a:pPr>
-            <a:r>
-              <a:rPr sz="1500">
-                <a:solidFill>
-                  <a:srgbClr val="1B2430"/>
-                </a:solidFill>
-                <a:latin typeface="Calibri"/>
-                <a:ea typeface="Calibri"/>
-                <a:cs typeface="Calibri"/>
-              </a:rPr>
-              <a:t>Configure the event and update information. Prioritise each request and route it to the right team.</a:t>
-            </a:r>
-          </a:p>
-        </p:txBody>
-      </p:sp>
-      <p:sp>
-        <p:nvSpPr>
-          <p:cNvPr id="54" name="MVP heading">
-            <a:extLst>
-              <a:ext uri="{FF2B5EF4-FFF2-40B4-BE49-F238E27FC236}">
-                <a16:creationId xmlns:a16="http://schemas.microsoft.com/office/drawing/2014/main" id="{FD4759BC-83D1-4166-BC0D-9B2F91CAF75B}"/>
-              </a:ext>
-            </a:extLst>
-          </p:cNvPr>
-          <p:cNvSpPr>
-            <a:spLocks noGrp="1"/>
-          </p:cNvSpPr>
-          <p:nvPr/>
-        </p:nvSpPr>
-        <p:spPr>
-          <a:xfrm>
-            <a:off x="457200" y="3614736"/>
-            <a:ext cx="1352550" cy="285750"/>
-          </a:xfrm>
-          <a:prstGeom prst="rect">
-            <a:avLst/>
-          </a:prstGeom>
-          <a:noFill/>
-          <a:ln w="0">
+              </a:rPr>
+              <a:t>DM-2 to DM-5; Report, Badge, PlatformAdmin</a:t>
+            </a:r>
+          </a:p>
+        </p:txBody>
+      </p:sp>
+      <p:sp>
+        <p:nvSpPr>
+          <p:cNvPr id="21" name="High-level architecture card"/>
+          <p:cNvSpPr/>
+          <p:nvPr/>
+        </p:nvSpPr>
+        <p:spPr>
+          <a:xfrm>
+            <a:off x="4663440" y="2834640"/>
+            <a:ext cx="4023360" cy="1645920"/>
+          </a:xfrm>
+          <a:prstGeom prst="roundRect">
+            <a:avLst>
+              <a:gd name="adj" fmla="val 6000"/>
+            </a:avLst>
+          </a:prstGeom>
+          <a:solidFill>
+            <a:schemeClr val="bg2"/>
+          </a:solidFill>
+          <a:ln>
             <a:noFill/>
           </a:ln>
-        </p:spPr>
-        <p:txBody>
-          <a:bodyPr wrap="square" lIns="0" tIns="0" rIns="0" bIns="0" anchor="t">
-            <a:noAutofit/>
-          </a:bodyPr>
-          <a:lstStyle>
-            <a:defPPr algn="l">
-              <a:defRPr sz="1500" b="1">
-                <a:solidFill>
-                  <a:srgbClr val="0B1F3A"/>
-                </a:solidFill>
-                <a:latin typeface="Calibri"/>
-                <a:ea typeface="Calibri"/>
-                <a:cs typeface="Calibri"/>
-              </a:defRPr>
-            </a:defPPr>
-          </a:lstStyle>
-          <a:p>
-            <a:pPr algn="l">
-              <a:defRPr sz="1500" b="1">
-                <a:solidFill>
-                  <a:srgbClr val="0B1F3A"/>
-                </a:solidFill>
-                <a:latin typeface="Calibri"/>
-                <a:ea typeface="Calibri"/>
-                <a:cs typeface="Calibri"/>
-              </a:defRPr>
-            </a:pPr>
-            <a:r>
-              <a:rPr sz="1500" b="1" dirty="0">
-                <a:solidFill>
-                  <a:schemeClr val="accent1"/>
-                </a:solidFill>
-                <a:latin typeface="Calibri"/>
-                <a:ea typeface="Calibri"/>
-                <a:cs typeface="Calibri"/>
-              </a:rPr>
-              <a:t>MVP</a:t>
-            </a:r>
-          </a:p>
-        </p:txBody>
-      </p:sp>
-      <p:sp>
-        <p:nvSpPr>
-          <p:cNvPr id="55" name="MVP scope">
-            <a:extLst>
-              <a:ext uri="{FF2B5EF4-FFF2-40B4-BE49-F238E27FC236}">
-                <a16:creationId xmlns:a16="http://schemas.microsoft.com/office/drawing/2014/main" id="{EE15BBC2-61C5-47DC-90AD-58954614B58C}"/>
-              </a:ext>
-            </a:extLst>
-          </p:cNvPr>
-          <p:cNvSpPr>
-            <a:spLocks noGrp="1"/>
-          </p:cNvSpPr>
-          <p:nvPr/>
-        </p:nvSpPr>
-        <p:spPr>
-          <a:xfrm>
-            <a:off x="1914525" y="3614736"/>
-            <a:ext cx="6772275" cy="457200"/>
-          </a:xfrm>
-          <a:prstGeom prst="rect">
-            <a:avLst/>
-          </a:prstGeom>
-          <a:noFill/>
-          <a:ln w="0">
+          <a:effectLst/>
+        </p:spPr>
+        <p:style>
+          <a:lnRef idx="1">
+            <a:schemeClr val="accent1"/>
+          </a:lnRef>
+          <a:fillRef idx="3">
+            <a:schemeClr val="accent1"/>
+          </a:fillRef>
+          <a:effectRef idx="2">
+            <a:schemeClr val="accent1"/>
+          </a:effectRef>
+          <a:fontRef idx="minor">
+            <a:schemeClr val="lt1"/>
+          </a:fontRef>
+        </p:style>
+        <p:txBody>
+          <a:bodyPr rtlCol="0" anchor="ctr"/>
+          <a:lstStyle/>
+          <a:p>
+            <a:pPr algn="ctr"/>
+          </a:p>
+        </p:txBody>
+      </p:sp>
+      <p:sp>
+        <p:nvSpPr>
+          <p:cNvPr id="22" name="High-level architecture status"/>
+          <p:cNvSpPr/>
+          <p:nvPr/>
+        </p:nvSpPr>
+        <p:spPr>
+          <a:xfrm>
+            <a:off x="4846320" y="3017520"/>
+            <a:ext cx="365760" cy="365760"/>
+          </a:xfrm>
+          <a:prstGeom prst="ellipse">
+            <a:avLst/>
+          </a:prstGeom>
+          <a:solidFill>
+            <a:srgbClr val="E8A300"/>
+          </a:solidFill>
+          <a:ln>
             <a:noFill/>
           </a:ln>
-        </p:spPr>
-        <p:txBody>
-          <a:bodyPr wrap="square" lIns="0" tIns="0" rIns="0" bIns="0" anchor="t">
-            <a:noAutofit/>
+          <a:effectLst/>
+        </p:spPr>
+        <p:style>
+          <a:lnRef idx="1">
+            <a:schemeClr val="accent1"/>
+          </a:lnRef>
+          <a:fillRef idx="3">
+            <a:schemeClr val="accent1"/>
+          </a:fillRef>
+          <a:effectRef idx="2">
+            <a:schemeClr val="accent1"/>
+          </a:effectRef>
+          <a:fontRef idx="minor">
+            <a:schemeClr val="lt1"/>
+          </a:fontRef>
+        </p:style>
+        <p:txBody>
+          <a:bodyPr rtlCol="0" anchor="ctr"/>
+          <a:lstStyle/>
+          <a:p>
+            <a:pPr algn="ctr"/>
+          </a:p>
+        </p:txBody>
+      </p:sp>
+      <p:sp>
+        <p:nvSpPr>
+          <p:cNvPr id="23" name="High-level architecture name"/>
+          <p:cNvSpPr txBox="1"/>
+          <p:nvPr/>
+        </p:nvSpPr>
+        <p:spPr>
+          <a:xfrm>
+            <a:off x="5349240" y="3017520"/>
+            <a:ext cx="2377440" cy="365760"/>
+          </a:xfrm>
+          <a:prstGeom prst="rect">
+            <a:avLst/>
+          </a:prstGeom>
+          <a:noFill/>
+        </p:spPr>
+        <p:txBody>
+          <a:bodyPr wrap="square" lIns="0" rIns="0" tIns="0" bIns="0" anchor="ctr">
+            <a:spAutoFit/>
           </a:bodyPr>
-          <a:lstStyle>
-            <a:defPPr algn="l">
-              <a:defRPr sz="1300">
+          <a:lstStyle/>
+          <a:p>
+            <a:pPr algn="l"/>
+            <a:r>
+              <a:rPr sz="1700" b="1">
+                <a:solidFill>
+                  <a:srgbClr val="0B1F3A"/>
+                </a:solidFill>
+              </a:rPr>
+              <a:t>High-level architecture</a:t>
+            </a:r>
+          </a:p>
+        </p:txBody>
+      </p:sp>
+      <p:sp>
+        <p:nvSpPr>
+          <p:cNvPr id="24" name="High-level architecture label"/>
+          <p:cNvSpPr txBox="1"/>
+          <p:nvPr/>
+        </p:nvSpPr>
+        <p:spPr>
+          <a:xfrm>
+            <a:off x="7635240" y="3017520"/>
+            <a:ext cx="868680" cy="365760"/>
+          </a:xfrm>
+          <a:prstGeom prst="rect">
+            <a:avLst/>
+          </a:prstGeom>
+          <a:noFill/>
+        </p:spPr>
+        <p:txBody>
+          <a:bodyPr wrap="square" lIns="0" rIns="0" tIns="0" bIns="0" anchor="ctr">
+            <a:spAutoFit/>
+          </a:bodyPr>
+          <a:lstStyle/>
+          <a:p>
+            <a:pPr algn="r"/>
+            <a:r>
+              <a:rPr sz="1300" b="1">
+                <a:solidFill>
+                  <a:srgbClr val="E8A300"/>
+                </a:solidFill>
+              </a:rPr>
+              <a:t>In progress</a:t>
+            </a:r>
+          </a:p>
+        </p:txBody>
+      </p:sp>
+      <p:sp>
+        <p:nvSpPr>
+          <p:cNvPr id="25" name="High-level architecture done"/>
+          <p:cNvSpPr txBox="1"/>
+          <p:nvPr/>
+        </p:nvSpPr>
+        <p:spPr>
+          <a:xfrm>
+            <a:off x="4846320" y="3520440"/>
+            <a:ext cx="3657600" cy="411480"/>
+          </a:xfrm>
+          <a:prstGeom prst="rect">
+            <a:avLst/>
+          </a:prstGeom>
+          <a:noFill/>
+        </p:spPr>
+        <p:txBody>
+          <a:bodyPr wrap="square" lIns="0" rIns="0" tIns="0" bIns="0" anchor="t">
+            <a:spAutoFit/>
+          </a:bodyPr>
+          <a:lstStyle/>
+          <a:p>
+            <a:pPr algn="l"/>
+            <a:r>
+              <a:rPr sz="1300" b="1">
+                <a:solidFill>
+                  <a:srgbClr val="1F4E79"/>
+                </a:solidFill>
+              </a:rPr>
+              <a:t>Done  </a:t>
+            </a:r>
+            <a:r>
+              <a:rPr sz="1300" b="0">
                 <a:solidFill>
                   <a:srgbClr val="1B2430"/>
                 </a:solidFill>
-                <a:latin typeface="Calibri"/>
-                <a:ea typeface="Calibri"/>
-                <a:cs typeface="Calibri"/>
-              </a:defRPr>
-            </a:defPPr>
-          </a:lstStyle>
-          <a:p>
-            <a:pPr algn="l">
-              <a:defRPr sz="1300">
+              </a:rPr>
+              <a:t>Context, container, deployment; AI triage flow</a:t>
+            </a:r>
+          </a:p>
+        </p:txBody>
+      </p:sp>
+      <p:sp>
+        <p:nvSpPr>
+          <p:cNvPr id="26" name="High-level architecture next"/>
+          <p:cNvSpPr txBox="1"/>
+          <p:nvPr/>
+        </p:nvSpPr>
+        <p:spPr>
+          <a:xfrm>
+            <a:off x="4846320" y="3950208"/>
+            <a:ext cx="3657600" cy="411480"/>
+          </a:xfrm>
+          <a:prstGeom prst="rect">
+            <a:avLst/>
+          </a:prstGeom>
+          <a:noFill/>
+        </p:spPr>
+        <p:txBody>
+          <a:bodyPr wrap="square" lIns="0" rIns="0" tIns="0" bIns="0" anchor="t">
+            <a:spAutoFit/>
+          </a:bodyPr>
+          <a:lstStyle/>
+          <a:p>
+            <a:pPr algn="l"/>
+            <a:r>
+              <a:rPr sz="1300" b="1">
+                <a:solidFill>
+                  <a:srgbClr val="1F4E79"/>
+                </a:solidFill>
+              </a:rPr>
+              <a:t>Next  </a:t>
+            </a:r>
+            <a:r>
+              <a:rPr sz="1300" b="0">
                 <a:solidFill>
                   <a:srgbClr val="1B2430"/>
                 </a:solidFill>
-                <a:latin typeface="Calibri"/>
-                <a:ea typeface="Calibri"/>
-                <a:cs typeface="Calibri"/>
-              </a:defRPr>
-            </a:pPr>
-            <a:r>
-              <a:rPr sz="1300" dirty="0">
-                <a:solidFill>
-                  <a:schemeClr val="bg1"/>
-                </a:solidFill>
-                <a:latin typeface="Calibri"/>
-                <a:ea typeface="Calibri"/>
-                <a:cs typeface="Calibri"/>
-              </a:rPr>
-              <a:t>Event selection, venue map, essential information, transport and help requests, with an event </a:t>
-            </a:r>
-            <a:r>
-              <a:rPr sz="1300" dirty="0" err="1">
-                <a:solidFill>
-                  <a:schemeClr val="bg1"/>
-                </a:solidFill>
-                <a:latin typeface="Calibri"/>
-                <a:ea typeface="Calibri"/>
-                <a:cs typeface="Calibri"/>
-              </a:rPr>
-              <a:t>backoffice</a:t>
-            </a:r>
-            <a:r>
-              <a:rPr sz="1300" dirty="0">
-                <a:solidFill>
-                  <a:schemeClr val="bg1"/>
-                </a:solidFill>
-                <a:latin typeface="Calibri"/>
-                <a:ea typeface="Calibri"/>
-                <a:cs typeface="Calibri"/>
-              </a:rPr>
-              <a:t>.</a:t>
-            </a:r>
-          </a:p>
-        </p:txBody>
-      </p:sp>
-      <p:sp>
-        <p:nvSpPr>
-          <p:cNvPr id="56" name="Success heading">
-            <a:extLst>
-              <a:ext uri="{FF2B5EF4-FFF2-40B4-BE49-F238E27FC236}">
-                <a16:creationId xmlns:a16="http://schemas.microsoft.com/office/drawing/2014/main" id="{5A36368D-A38A-49D3-AB41-D9FC53609A8B}"/>
-              </a:ext>
-            </a:extLst>
-          </p:cNvPr>
-          <p:cNvSpPr>
-            <a:spLocks noGrp="1"/>
-          </p:cNvSpPr>
-          <p:nvPr/>
-        </p:nvSpPr>
-        <p:spPr>
-          <a:xfrm>
-            <a:off x="457200" y="4195761"/>
-            <a:ext cx="1352550" cy="304800"/>
-          </a:xfrm>
-          <a:prstGeom prst="rect">
-            <a:avLst/>
-          </a:prstGeom>
-          <a:noFill/>
-          <a:ln w="0">
-            <a:noFill/>
-          </a:ln>
-        </p:spPr>
-        <p:txBody>
-          <a:bodyPr wrap="square" lIns="0" tIns="0" rIns="0" bIns="0" anchor="t">
-            <a:noAutofit/>
+              </a:rPr>
+              <a:t>Services vs monolith, stack, ADRs, skeleton</a:t>
+            </a:r>
+          </a:p>
+        </p:txBody>
+      </p:sp>
+      <p:sp>
+        <p:nvSpPr>
+          <p:cNvPr id="27" name="Legend"/>
+          <p:cNvSpPr txBox="1"/>
+          <p:nvPr/>
+        </p:nvSpPr>
+        <p:spPr>
+          <a:xfrm>
+            <a:off x="457200" y="4681728"/>
+            <a:ext cx="8229600" cy="274320"/>
+          </a:xfrm>
+          <a:prstGeom prst="rect">
+            <a:avLst/>
+          </a:prstGeom>
+          <a:noFill/>
+        </p:spPr>
+        <p:txBody>
+          <a:bodyPr wrap="square" lIns="0" rIns="0" tIns="0" bIns="0" anchor="t">
+            <a:spAutoFit/>
           </a:bodyPr>
-          <a:lstStyle>
-            <a:defPPr algn="l">
-              <a:defRPr sz="1500" b="1">
-                <a:solidFill>
-                  <a:srgbClr val="0B1F3A"/>
-                </a:solidFill>
-                <a:latin typeface="Calibri"/>
-                <a:ea typeface="Calibri"/>
-                <a:cs typeface="Calibri"/>
-              </a:defRPr>
-            </a:defPPr>
-          </a:lstStyle>
-          <a:p>
-            <a:pPr algn="l">
-              <a:defRPr sz="1500" b="1">
-                <a:solidFill>
-                  <a:srgbClr val="0B1F3A"/>
-                </a:solidFill>
-                <a:latin typeface="Calibri"/>
-                <a:ea typeface="Calibri"/>
-                <a:cs typeface="Calibri"/>
-              </a:defRPr>
-            </a:pPr>
-            <a:r>
-              <a:rPr sz="1500" b="1" dirty="0">
-                <a:solidFill>
-                  <a:schemeClr val="accent1"/>
-                </a:solidFill>
-                <a:latin typeface="Calibri"/>
-                <a:ea typeface="Calibri"/>
-                <a:cs typeface="Calibri"/>
-              </a:rPr>
-              <a:t>Success criteria</a:t>
-            </a:r>
-          </a:p>
-        </p:txBody>
-      </p:sp>
-      <p:sp>
-        <p:nvSpPr>
-          <p:cNvPr id="57" name="Success criteria">
-            <a:extLst>
-              <a:ext uri="{FF2B5EF4-FFF2-40B4-BE49-F238E27FC236}">
-                <a16:creationId xmlns:a16="http://schemas.microsoft.com/office/drawing/2014/main" id="{3BC16916-00CE-4194-9ADB-BCE37690540A}"/>
-              </a:ext>
-            </a:extLst>
-          </p:cNvPr>
-          <p:cNvSpPr>
-            <a:spLocks noGrp="1"/>
-          </p:cNvSpPr>
-          <p:nvPr/>
-        </p:nvSpPr>
-        <p:spPr>
-          <a:xfrm>
-            <a:off x="1914525" y="4195761"/>
-            <a:ext cx="6772275" cy="457200"/>
-          </a:xfrm>
-          <a:prstGeom prst="rect">
-            <a:avLst/>
-          </a:prstGeom>
-          <a:noFill/>
-          <a:ln w="0">
-            <a:noFill/>
-          </a:ln>
-        </p:spPr>
-        <p:txBody>
-          <a:bodyPr wrap="square" lIns="0" tIns="0" rIns="0" bIns="0" anchor="t">
-            <a:noAutofit/>
-          </a:bodyPr>
-          <a:lstStyle>
-            <a:defPPr algn="l">
-              <a:defRPr sz="1300">
-                <a:solidFill>
-                  <a:srgbClr val="1B2430"/>
-                </a:solidFill>
-                <a:latin typeface="Calibri"/>
-                <a:ea typeface="Calibri"/>
-                <a:cs typeface="Calibri"/>
-              </a:defRPr>
-            </a:defPPr>
-          </a:lstStyle>
-          <a:p>
-            <a:pPr algn="l">
-              <a:defRPr sz="1300">
-                <a:solidFill>
-                  <a:srgbClr val="1B2430"/>
-                </a:solidFill>
-                <a:latin typeface="Calibri"/>
-                <a:ea typeface="Calibri"/>
-                <a:cs typeface="Calibri"/>
-              </a:defRPr>
-            </a:pPr>
-            <a:r>
-              <a:rPr sz="1300">
-                <a:solidFill>
-                  <a:schemeClr val="bg1"/>
-                </a:solidFill>
-                <a:latin typeface="Calibri"/>
-                <a:ea typeface="Calibri"/>
-                <a:cs typeface="Calibri"/>
-              </a:rPr>
-              <a:t>Faster access to information and operational response, less confusion, adoption and positive feedback.</a:t>
+          <a:lstStyle/>
+          <a:p>
+            <a:pPr algn="l"/>
+            <a:r>
+              <a:rPr sz="1300" b="0">
+                <a:solidFill>
+                  <a:srgbClr val="2E9E5B"/>
+                </a:solidFill>
+              </a:rPr>
+              <a:t>● </a:t>
+            </a:r>
+            <a:r>
+              <a:rPr sz="1300" b="0">
+                <a:solidFill>
+                  <a:srgbClr val="5A6B85"/>
+                </a:solidFill>
+              </a:rPr>
+              <a:t>agreed and documented     </a:t>
+            </a:r>
+            <a:r>
+              <a:rPr sz="1300" b="0">
+                <a:solidFill>
+                  <a:srgbClr val="E8A300"/>
+                </a:solidFill>
+              </a:rPr>
+              <a:t>● </a:t>
+            </a:r>
+            <a:r>
+              <a:rPr sz="1300" b="0">
+                <a:solidFill>
+                  <a:srgbClr val="5A6B85"/>
+                </a:solidFill>
+              </a:rPr>
+              <a:t>drafted, decisions open     </a:t>
+            </a:r>
+            <a:r>
+              <a:rPr sz="1300" b="0">
+                <a:solidFill>
+                  <a:srgbClr val="D64545"/>
+                </a:solidFill>
+              </a:rPr>
+              <a:t>● </a:t>
+            </a:r>
+            <a:r>
+              <a:rPr sz="1300" b="0">
+                <a:solidFill>
+                  <a:srgbClr val="5A6B85"/>
+                </a:solidFill>
+              </a:rPr>
+              <a:t>key decisions missing     </a:t>
             </a:r>
           </a:p>
         </p:txBody>

</xml_diff>

<commit_message>
docs (#32): Apply deck review changes
Sofia's success on the personas slide is now the configured event; the
main-features slide no longer mentions 112; the status slide says
Services vs Modular and has no next step for DoR/DoD.

Co-Authored-By: Claude Opus 5.5 <noreply@anthropic.com>
</commit_message>
<xml_diff>
--- a/Docs/Presentation/Farol_First_Presentation.pptx
+++ b/Docs/Presentation/Farol_First_Presentation.pptx
@@ -139,7 +139,7 @@
             <p14:sldId id="260"/>
           </p14:sldIdLst>
         </p14:section>
-        <p14:section name="Status overview" id="{2BDB7B91-3058-42AC-8457-3A3E92086DEB}">
+        <p14:section name="Status overview" id="{A573BAAB-071E-46C6-A4BF-0AFB26A42381}">
           <p14:sldIdLst>
             <p14:sldId id="262"/>
           </p14:sldIdLst>
@@ -498,7 +498,7 @@
           <a:p>
             <a:r>
               <a:rPr lang="en-US" dirty="0"/>
-              <a:t>(~55 s) O Farol tem dois lados, ligados pela planta do recinto. O participante, depois de fazer login, vê a planta com entradas, casas de banho, primeiros socorros e paragens. O mais importante é o Pedir ajuda: primeiro aparece o Ligar 112; se não for uma emergência, escolhe uma categoria e marca na planta onde está. Vê também como voltar para casa, com as linhas da STCP e os shuttles do evento, recebe avisos em tempo real e pode reportar problemas na planta. Do lado da equipa, a organização cria o evento e gere os papéis e as equipas de resposta: médica, segurança, PCR e logística. Durante a noite, os operadores veem os pedidos chegar em tempo real, na lista e na planta, priorizam, encaminham para a equipa certa e confirmam os reports. Cada organização só vê os dados do seu evento.</a:t>
+              <a:t>(~55 s) O Farol tem dois lados, ligados pela planta do recinto. O participante, depois de fazer login, vê a planta com entradas, casas de banho, primeiros socorros e paragens. O mais importante é o Pedir ajuda: escolhe uma categoria e marca na planta onde está. Vê também como voltar para casa, com as linhas da STCP e os shuttles do evento, recebe avisos em tempo real e pode reportar problemas na planta. Do lado da equipa, a organização cria o evento e gere os papéis e as equipas de resposta: médica, segurança, PCR e logística. Durante a noite, os operadores veem os pedidos chegar em tempo real, na lista e na planta, priorizam, encaminham para a equipa certa e confirmam os reports. Cada organização só vê os dados do seu evento.</a:t>
             </a:r>
           </a:p>
         </p:txBody>
@@ -859,7 +859,7 @@
           <a:lstStyle/>
           <a:p>
             <a:r>
-              <a:t>(~45 s) Ponto de situação dos quatro temas pedidos pelo professor. DoR e DoD: verde. Foram acordados pela equipa a 8 de outubro; a regra é uma user story, uma issue, um PR. Já estão no GitHub: o DoR e o DoD da story nos issue forms e o DoD do PR no template de PR. Falta só criar as colunas Ready e Done no board. Papéis e processo: amarelo. Temos seis papéis definidos, GitHub Flow, sprints A, B e C com datas e duas reuniões por semana. Já temos uma verificação automática das convenções em cada PR. Falta pôr o board a funcionar e ligar a proteção do main com squash merge. Modelo de domínio: amarelo. Temos dois bounded contexts, o diagrama de classes, as regras de negócio e a parte de privacidade; o login obrigatório já está decidido. Faltam as questões DM-2 a DM-5 e as entidades Report, Badge e PlatformAdmin. Arquitetura: amarelo. Já começou a ser trabalhada: temos as vistas de contexto, contentores e deployment e o fluxo assíncrono de triagem com IA, mas ainda faltam fechar as decisões: serviços ou monólito modular, a stack tecnológica, os ADRs, o esboço da API e o walking skeleton. É a prioridade para o início do Sprint B.</a:t>
+              <a:t>(~45 s) Ponto de situação dos quatro temas pedidos pelo professor. DoR e DoD: verde. Foram acordados pela equipa a 8 de outubro; a regra é uma user story, uma issue, um PR. Já estão no GitHub: o DoR e o DoD da story nos issue forms e o DoD do PR no template de PR. Papéis e processo: amarelo. Temos seis papéis definidos, GitHub Flow, sprints A, B e C com datas e duas reuniões por semana. Já temos uma verificação automática das convenções em cada PR. Falta pôr o board a funcionar e ligar a proteção do main com squash merge. Modelo de domínio: amarelo. Temos dois bounded contexts, o diagrama de classes, as regras de negócio e a parte de privacidade; o login obrigatório já está decidido. Faltam as questões DM-2 a DM-5 e as entidades Report, Badge e PlatformAdmin. Arquitetura: amarelo. Já começou a ser trabalhada: temos as vistas de contexto, contentores e deployment e o fluxo assíncrono de triagem com IA, mas ainda faltam fechar as decisões: serviços ou monólito modular, a stack tecnológica, os ADRs, o esboço da API e o walking skeleton. É a prioridade para o início do Sprint B.</a:t>
             </a:r>
           </a:p>
         </p:txBody>
@@ -3926,7 +3926,7 @@
                   <a:schemeClr val="tx1"/>
                 </a:solidFill>
               </a:rPr>
-              <a:t>next night ready with configuration only</a:t>
+              <a:t>event configured and published</a:t>
             </a:r>
             <a:endParaRPr lang="en-US" sz="1200" dirty="0"/>
           </a:p>
@@ -5160,7 +5160,7 @@
       </p:pic>
       <p:sp>
         <p:nvSpPr>
-          <p:cNvPr id="11" name="Feature: Ask for help, 112 shown first"/>
+          <p:cNvPr id="11" name="Feature: Ask for help"/>
           <p:cNvSpPr txBox="1"/>
           <p:nvPr/>
         </p:nvSpPr>
@@ -5188,7 +5188,7 @@
                   <a:schemeClr val="tx1"/>
                 </a:solidFill>
               </a:rPr>
-              <a:t>Ask for help, 112 shown first</a:t>
+              <a:t>Ask for help</a:t>
             </a:r>
             <a:endParaRPr lang="en-US" sz="1400" dirty="0"/>
           </a:p>
@@ -9165,49 +9165,7 @@
       </p:sp>
       <p:sp>
         <p:nvSpPr>
-          <p:cNvPr id="8" name="DoR / DoD next"/>
-          <p:cNvSpPr txBox="1"/>
-          <p:nvPr/>
-        </p:nvSpPr>
-        <p:spPr>
-          <a:xfrm>
-            <a:off x="640080" y="2121408"/>
-            <a:ext cx="3657600" cy="411480"/>
-          </a:xfrm>
-          <a:prstGeom prst="rect">
-            <a:avLst/>
-          </a:prstGeom>
-          <a:noFill/>
-        </p:spPr>
-        <p:txBody>
-          <a:bodyPr wrap="square" lIns="0" rIns="0" tIns="0" bIns="0" anchor="t">
-            <a:spAutoFit/>
-          </a:bodyPr>
-          <a:lstStyle/>
-          <a:p>
-            <a:pPr algn="l"/>
-            <a:r>
-              <a:rPr sz="1300" b="1">
-                <a:solidFill>
-                  <a:srgbClr val="1F4E79"/>
-                </a:solidFill>
-              </a:rPr>
-              <a:t>Next  </a:t>
-            </a:r>
-            <a:r>
-              <a:rPr sz="1300" b="0">
-                <a:solidFill>
-                  <a:srgbClr val="1B2430"/>
-                </a:solidFill>
-              </a:rPr>
-              <a:t>Ready and Done columns on the board</a:t>
-            </a:r>
-          </a:p>
-        </p:txBody>
-      </p:sp>
-      <p:sp>
-        <p:nvSpPr>
-          <p:cNvPr id="9" name="Team roles and process card"/>
+          <p:cNvPr id="8" name="Team roles and process card"/>
           <p:cNvSpPr/>
           <p:nvPr/>
         </p:nvSpPr>
@@ -9253,7 +9211,7 @@
       </p:sp>
       <p:sp>
         <p:nvSpPr>
-          <p:cNvPr id="10" name="Team roles and process status"/>
+          <p:cNvPr id="9" name="Team roles and process status"/>
           <p:cNvSpPr/>
           <p:nvPr/>
         </p:nvSpPr>
@@ -9297,7 +9255,7 @@
       </p:sp>
       <p:sp>
         <p:nvSpPr>
-          <p:cNvPr id="11" name="Team roles and process name"/>
+          <p:cNvPr id="10" name="Team roles and process name"/>
           <p:cNvSpPr txBox="1"/>
           <p:nvPr/>
         </p:nvSpPr>
@@ -9331,7 +9289,7 @@
       </p:sp>
       <p:sp>
         <p:nvSpPr>
-          <p:cNvPr id="12" name="Team roles and process label"/>
+          <p:cNvPr id="11" name="Team roles and process label"/>
           <p:cNvSpPr txBox="1"/>
           <p:nvPr/>
         </p:nvSpPr>
@@ -9365,7 +9323,7 @@
       </p:sp>
       <p:sp>
         <p:nvSpPr>
-          <p:cNvPr id="13" name="Team roles and process done"/>
+          <p:cNvPr id="12" name="Team roles and process done"/>
           <p:cNvSpPr txBox="1"/>
           <p:nvPr/>
         </p:nvSpPr>
@@ -9407,7 +9365,7 @@
       </p:sp>
       <p:sp>
         <p:nvSpPr>
-          <p:cNvPr id="14" name="Team roles and process next"/>
+          <p:cNvPr id="13" name="Team roles and process next"/>
           <p:cNvSpPr txBox="1"/>
           <p:nvPr/>
         </p:nvSpPr>
@@ -9449,7 +9407,7 @@
       </p:sp>
       <p:sp>
         <p:nvSpPr>
-          <p:cNvPr id="15" name="Domain model card"/>
+          <p:cNvPr id="14" name="Domain model card"/>
           <p:cNvSpPr/>
           <p:nvPr/>
         </p:nvSpPr>
@@ -9495,7 +9453,7 @@
       </p:sp>
       <p:sp>
         <p:nvSpPr>
-          <p:cNvPr id="16" name="Domain model status"/>
+          <p:cNvPr id="15" name="Domain model status"/>
           <p:cNvSpPr/>
           <p:nvPr/>
         </p:nvSpPr>
@@ -9539,7 +9497,7 @@
       </p:sp>
       <p:sp>
         <p:nvSpPr>
-          <p:cNvPr id="17" name="Domain model name"/>
+          <p:cNvPr id="16" name="Domain model name"/>
           <p:cNvSpPr txBox="1"/>
           <p:nvPr/>
         </p:nvSpPr>
@@ -9573,7 +9531,7 @@
       </p:sp>
       <p:sp>
         <p:nvSpPr>
-          <p:cNvPr id="18" name="Domain model label"/>
+          <p:cNvPr id="17" name="Domain model label"/>
           <p:cNvSpPr txBox="1"/>
           <p:nvPr/>
         </p:nvSpPr>
@@ -9607,7 +9565,7 @@
       </p:sp>
       <p:sp>
         <p:nvSpPr>
-          <p:cNvPr id="19" name="Domain model done"/>
+          <p:cNvPr id="18" name="Domain model done"/>
           <p:cNvSpPr txBox="1"/>
           <p:nvPr/>
         </p:nvSpPr>
@@ -9649,7 +9607,7 @@
       </p:sp>
       <p:sp>
         <p:nvSpPr>
-          <p:cNvPr id="20" name="Domain model next"/>
+          <p:cNvPr id="19" name="Domain model next"/>
           <p:cNvSpPr txBox="1"/>
           <p:nvPr/>
         </p:nvSpPr>
@@ -9691,7 +9649,7 @@
       </p:sp>
       <p:sp>
         <p:nvSpPr>
-          <p:cNvPr id="21" name="High-level architecture card"/>
+          <p:cNvPr id="20" name="High-level architecture card"/>
           <p:cNvSpPr/>
           <p:nvPr/>
         </p:nvSpPr>
@@ -9737,7 +9695,7 @@
       </p:sp>
       <p:sp>
         <p:nvSpPr>
-          <p:cNvPr id="22" name="High-level architecture status"/>
+          <p:cNvPr id="21" name="High-level architecture status"/>
           <p:cNvSpPr/>
           <p:nvPr/>
         </p:nvSpPr>
@@ -9781,7 +9739,7 @@
       </p:sp>
       <p:sp>
         <p:nvSpPr>
-          <p:cNvPr id="23" name="High-level architecture name"/>
+          <p:cNvPr id="22" name="High-level architecture name"/>
           <p:cNvSpPr txBox="1"/>
           <p:nvPr/>
         </p:nvSpPr>
@@ -9815,7 +9773,7 @@
       </p:sp>
       <p:sp>
         <p:nvSpPr>
-          <p:cNvPr id="24" name="High-level architecture label"/>
+          <p:cNvPr id="23" name="High-level architecture label"/>
           <p:cNvSpPr txBox="1"/>
           <p:nvPr/>
         </p:nvSpPr>
@@ -9849,7 +9807,7 @@
       </p:sp>
       <p:sp>
         <p:nvSpPr>
-          <p:cNvPr id="25" name="High-level architecture done"/>
+          <p:cNvPr id="24" name="High-level architecture done"/>
           <p:cNvSpPr txBox="1"/>
           <p:nvPr/>
         </p:nvSpPr>
@@ -9891,7 +9849,7 @@
       </p:sp>
       <p:sp>
         <p:nvSpPr>
-          <p:cNvPr id="26" name="High-level architecture next"/>
+          <p:cNvPr id="25" name="High-level architecture next"/>
           <p:cNvSpPr txBox="1"/>
           <p:nvPr/>
         </p:nvSpPr>
@@ -9926,14 +9884,14 @@
                   <a:srgbClr val="1B2430"/>
                 </a:solidFill>
               </a:rPr>
-              <a:t>Services vs monolith, stack, ADRs, skeleton</a:t>
-            </a:r>
-          </a:p>
-        </p:txBody>
-      </p:sp>
-      <p:sp>
-        <p:nvSpPr>
-          <p:cNvPr id="27" name="Legend"/>
+              <a:t>Services vs Modular, stack, ADRs, skeleton</a:t>
+            </a:r>
+          </a:p>
+        </p:txBody>
+      </p:sp>
+      <p:sp>
+        <p:nvSpPr>
+          <p:cNvPr id="26" name="Legend"/>
           <p:cNvSpPr txBox="1"/>
           <p:nvPr/>
         </p:nvSpPr>

</xml_diff>